<commit_message>
Correct J-29: British was not the wrong audience either
The entry said a British fixture was wrong because the reader is in
Dublin. That is the same error one step along. CameraMatics has offices
in London and Darlington, Royal Mail is a named customer, and the June
raise is aimed at mainland Europe and the United States.

The defect was never which country. It was that nobody asked, and the
question has no single-country answer: this product carries km/h and
mph at once. Swapping one default for another left the hole open.

Co-Authored-By: Claude Opus 5 <noreply@anthropic.com>
Claude-Session: https://claude.ai/code/session_018sKrcprqkNQmfDKnYFUhGV
</commit_message>
<xml_diff>
--- a/Claude outputs/cameramatics-danny-daley.pptx
+++ b/Claude outputs/cameramatics-danny-daley.pptx
@@ -14885,24 +14885,24 @@
         </p:nvSpPr>
         <p:spPr>
           <a:xfrm>
-            <a:off x="658368" y="1627632"/>
-            <a:ext cx="10844784" cy="310896"/>
-          </a:xfrm>
-          <a:prstGeom prst="rect">
-            <a:avLst/>
-          </a:prstGeom>
-          <a:noFill/>
-          <a:ln/>
-        </p:spPr>
-        <p:txBody>
-          <a:bodyPr wrap="square" lIns="0" tIns="0" rIns="0" bIns="0" rtlCol="0" anchor="t"/>
-          <a:lstStyle/>
-          <a:p>
-            <a:pPr indent="0" marL="0">
-              <a:buNone/>
-            </a:pPr>
-            <a:r>
-              <a:rPr lang="en-US" sz="1250" dirty="0">
+            <a:off x="658368" y="1591056"/>
+            <a:ext cx="10844784" cy="274320"/>
+          </a:xfrm>
+          <a:prstGeom prst="rect">
+            <a:avLst/>
+          </a:prstGeom>
+          <a:noFill/>
+          <a:ln/>
+        </p:spPr>
+        <p:txBody>
+          <a:bodyPr wrap="square" lIns="0" tIns="0" rIns="0" bIns="0" rtlCol="0" anchor="t"/>
+          <a:lstStyle/>
+          <a:p>
+            <a:pPr indent="0" marL="0">
+              <a:buNone/>
+            </a:pPr>
+            <a:r>
+              <a:rPr lang="en-US" sz="1200" dirty="0">
                 <a:solidFill>
                   <a:srgbClr val="5E666F"/>
                 </a:solidFill>
@@ -14910,13 +14910,41 @@
                 <a:ea typeface="Calibri" pitchFamily="34" charset="-122"/>
                 <a:cs typeface="Calibri" pitchFamily="34" charset="-120"/>
               </a:rPr>
-              <a:t>Read left to right: what the manager does. Underneath: the story that makes it work. Rows are releases. </a:t>
-            </a:r>
-            <a:pPr indent="0" marL="0">
-              <a:buNone/>
-            </a:pPr>
-            <a:r>
-              <a:rPr lang="en-US" sz="1250" u="sng" dirty="0">
+              <a:t>Read left to right: what the manager does. Underneath: the story or decision that makes it work. Rows are releases, and </a:t>
+            </a:r>
+            <a:pPr indent="0" marL="0">
+              <a:buNone/>
+            </a:pPr>
+            <a:r>
+              <a:rPr lang="en-US" sz="1200" b="1" dirty="0">
+                <a:solidFill>
+                  <a:srgbClr val="5E666F"/>
+                </a:solidFill>
+                <a:latin typeface="Calibri" pitchFamily="34" charset="0"/>
+                <a:ea typeface="Calibri" pitchFamily="34" charset="-122"/>
+                <a:cs typeface="Calibri" pitchFamily="34" charset="-120"/>
+              </a:rPr>
+              <a:t>every card is a link</a:t>
+            </a:r>
+            <a:pPr indent="0" marL="0">
+              <a:buNone/>
+            </a:pPr>
+            <a:r>
+              <a:rPr lang="en-US" sz="1200" dirty="0">
+                <a:solidFill>
+                  <a:srgbClr val="5E666F"/>
+                </a:solidFill>
+                <a:latin typeface="Calibri" pitchFamily="34" charset="0"/>
+                <a:ea typeface="Calibri" pitchFamily="34" charset="-122"/>
+                <a:cs typeface="Calibri" pitchFamily="34" charset="-120"/>
+              </a:rPr>
+              <a:t>.   </a:t>
+            </a:r>
+            <a:pPr indent="0" marL="0">
+              <a:buNone/>
+            </a:pPr>
+            <a:r>
+              <a:rPr lang="en-US" sz="1200" u="sng" dirty="0">
                 <a:solidFill>
                   <a:srgbClr val="C8621E"/>
                 </a:solidFill>
@@ -14933,667 +14961,4070 @@
               </a:rPr>
               <a:t>Open the live story map</a:t>
             </a:r>
-            <a:endParaRPr lang="en-US" sz="1250" dirty="0"/>
-          </a:p>
-        </p:txBody>
-      </p:sp>
-      <p:pic>
-        <p:nvPicPr>
-          <p:cNvPr id="5" name="Image 0" descr="/home/claude/shots/storymap.png">    </p:cNvPr>
-          <p:cNvPicPr>
-            <a:picLocks noChangeAspect="1"/>
-          </p:cNvPicPr>
-          <p:nvPr/>
-        </p:nvPicPr>
-        <p:blipFill>
-          <a:blip r:embed="rId2"/>
-          <a:stretch>
-            <a:fillRect/>
-          </a:stretch>
-        </p:blipFill>
-        <p:spPr>
-          <a:xfrm>
-            <a:off x="658368" y="2011680"/>
-            <a:ext cx="10844784" cy="3986784"/>
-          </a:xfrm>
-          <a:prstGeom prst="rect">
-            <a:avLst/>
-          </a:prstGeom>
-        </p:spPr>
-      </p:pic>
-      <p:pic>
-        <p:nvPicPr>
-          <p:cNvPr id="6" name="Image 1" descr="/home/claude/shots/clear.png">
-            <a:hlinkClick r:id="rId4" tooltip="ADR-0012 · platform Four triggers, every signal"/>
-          </p:cNvPr>
-          <p:cNvPicPr>
-            <a:picLocks noChangeAspect="1"/>
-          </p:cNvPicPr>
-          <p:nvPr/>
-        </p:nvPicPr>
-        <p:blipFill>
-          <a:blip r:embed="rId3"/>
-          <a:stretch>
-            <a:fillRect/>
-          </a:stretch>
-        </p:blipFill>
-        <p:spPr>
-          <a:xfrm>
-            <a:off x="1119226" y="2529230"/>
-            <a:ext cx="1831543" cy="467258"/>
-          </a:xfrm>
-          <a:prstGeom prst="rect">
-            <a:avLst/>
-          </a:prstGeom>
-        </p:spPr>
-      </p:pic>
-      <p:pic>
-        <p:nvPicPr>
-          <p:cNvPr id="7" name="Image 2" descr="/home/claude/shots/clear.png">
-            <a:hlinkClick r:id="rId6" tooltip="ADR-0002 · platform Severity-gated video upload"/>
-          </p:cNvPr>
-          <p:cNvPicPr>
-            <a:picLocks noChangeAspect="1"/>
-          </p:cNvPicPr>
-          <p:nvPr/>
-        </p:nvPicPr>
-        <p:blipFill>
-          <a:blip r:embed="rId5"/>
-          <a:stretch>
-            <a:fillRect/>
-          </a:stretch>
-        </p:blipFill>
-        <p:spPr>
-          <a:xfrm>
-            <a:off x="1119226" y="3031236"/>
-            <a:ext cx="1831543" cy="374904"/>
-          </a:xfrm>
-          <a:prstGeom prst="rect">
-            <a:avLst/>
-          </a:prstGeom>
-        </p:spPr>
-      </p:pic>
-      <p:pic>
-        <p:nvPicPr>
-          <p:cNvPr id="8" name="Image 3" descr="/home/claude/shots/clear.png">
-            <a:hlinkClick r:id="rId8" tooltip="ADR-0007 · platform Four bands, each with an action"/>
-          </p:cNvPr>
-          <p:cNvPicPr>
-            <a:picLocks noChangeAspect="1"/>
-          </p:cNvPicPr>
-          <p:nvPr/>
-        </p:nvPicPr>
-        <p:blipFill>
-          <a:blip r:embed="rId7"/>
-          <a:stretch>
-            <a:fillRect/>
-          </a:stretch>
-        </p:blipFill>
-        <p:spPr>
-          <a:xfrm>
-            <a:off x="1119226" y="3440887"/>
-            <a:ext cx="1831543" cy="374904"/>
-          </a:xfrm>
-          <a:prstGeom prst="rect">
-            <a:avLst/>
-          </a:prstGeom>
-        </p:spPr>
-      </p:pic>
-      <p:pic>
-        <p:nvPicPr>
-          <p:cNvPr id="9" name="Image 4" descr="/home/claude/shots/clear.png">
-            <a:hlinkClick r:id="rId10" tooltip="ADR-0010 · platform Risk, neutral or credit"/>
-          </p:cNvPr>
-          <p:cNvPicPr>
-            <a:picLocks noChangeAspect="1"/>
-          </p:cNvPicPr>
-          <p:nvPr/>
-        </p:nvPicPr>
-        <p:blipFill>
-          <a:blip r:embed="rId9"/>
-          <a:stretch>
-            <a:fillRect/>
-          </a:stretch>
-        </p:blipFill>
-        <p:spPr>
-          <a:xfrm>
-            <a:off x="1119226" y="3850538"/>
-            <a:ext cx="1831543" cy="374904"/>
-          </a:xfrm>
-          <a:prstGeom prst="rect">
-            <a:avLst/>
-          </a:prstGeom>
-        </p:spPr>
-      </p:pic>
-      <p:pic>
-        <p:nvPicPr>
-          <p:cNvPr id="10" name="Image 5" descr="/home/claude/shots/clear.png">
-            <a:hlinkClick r:id="rId12" tooltip="US-001 A weekly set that can be finished"/>
-          </p:cNvPr>
-          <p:cNvPicPr>
-            <a:picLocks noChangeAspect="1"/>
-          </p:cNvPicPr>
-          <p:nvPr/>
-        </p:nvPicPr>
-        <p:blipFill>
-          <a:blip r:embed="rId11"/>
-          <a:stretch>
-            <a:fillRect/>
-          </a:stretch>
-        </p:blipFill>
-        <p:spPr>
-          <a:xfrm>
-            <a:off x="3025750" y="2529230"/>
-            <a:ext cx="1686154" cy="374904"/>
-          </a:xfrm>
-          <a:prstGeom prst="rect">
-            <a:avLst/>
-          </a:prstGeom>
-        </p:spPr>
-      </p:pic>
-      <p:pic>
-        <p:nvPicPr>
-          <p:cNvPr id="11" name="Image 6" descr="/home/claude/shots/clear.png">
-            <a:hlinkClick r:id="rId14" tooltip="US-002 Critical events bypass the rhythm"/>
-          </p:cNvPr>
-          <p:cNvPicPr>
-            <a:picLocks noChangeAspect="1"/>
-          </p:cNvPicPr>
-          <p:nvPr/>
-        </p:nvPicPr>
-        <p:blipFill>
-          <a:blip r:embed="rId13"/>
-          <a:stretch>
-            <a:fillRect/>
-          </a:stretch>
-        </p:blipFill>
-        <p:spPr>
-          <a:xfrm>
-            <a:off x="3025750" y="2938882"/>
-            <a:ext cx="1686154" cy="374904"/>
-          </a:xfrm>
-          <a:prstGeom prst="rect">
-            <a:avLst/>
-          </a:prstGeom>
-        </p:spPr>
-      </p:pic>
-      <p:pic>
-        <p:nvPicPr>
-          <p:cNvPr id="12" name="Image 7" descr="/home/claude/shots/clear.png">
-            <a:hlinkClick r:id="rId16" tooltip="US-003 The set closes, visibly"/>
-          </p:cNvPr>
-          <p:cNvPicPr>
-            <a:picLocks noChangeAspect="1"/>
-          </p:cNvPicPr>
-          <p:nvPr/>
-        </p:nvPicPr>
-        <p:blipFill>
-          <a:blip r:embed="rId15"/>
-          <a:stretch>
-            <a:fillRect/>
-          </a:stretch>
-        </p:blipFill>
-        <p:spPr>
-          <a:xfrm>
-            <a:off x="3025750" y="3348533"/>
-            <a:ext cx="1686154" cy="374904"/>
-          </a:xfrm>
-          <a:prstGeom prst="rect">
-            <a:avLst/>
-          </a:prstGeom>
-        </p:spPr>
-      </p:pic>
-      <p:pic>
-        <p:nvPicPr>
-          <p:cNvPr id="13" name="Image 8" descr="/home/claude/shots/clear.png">
-            <a:hlinkClick r:id="rId18" tooltip="US-004 Dismiss a group with a reason"/>
-          </p:cNvPr>
-          <p:cNvPicPr>
-            <a:picLocks noChangeAspect="1"/>
-          </p:cNvPicPr>
-          <p:nvPr/>
-        </p:nvPicPr>
-        <p:blipFill>
-          <a:blip r:embed="rId17"/>
-          <a:stretch>
-            <a:fillRect/>
-          </a:stretch>
-        </p:blipFill>
-        <p:spPr>
-          <a:xfrm>
-            <a:off x="4785970" y="2529230"/>
-            <a:ext cx="1941271" cy="374904"/>
-          </a:xfrm>
-          <a:prstGeom prst="rect">
-            <a:avLst/>
-          </a:prstGeom>
-        </p:spPr>
-      </p:pic>
-      <p:pic>
-        <p:nvPicPr>
-          <p:cNvPr id="14" name="Image 9" descr="/home/claude/shots/clear.png">
-            <a:hlinkClick r:id="rId20" tooltip="US-009 Dismiss one, with a reason"/>
-          </p:cNvPr>
-          <p:cNvPicPr>
-            <a:picLocks noChangeAspect="1"/>
-          </p:cNvPicPr>
-          <p:nvPr/>
-        </p:nvPicPr>
-        <p:blipFill>
-          <a:blip r:embed="rId19"/>
-          <a:stretch>
-            <a:fillRect/>
-          </a:stretch>
-        </p:blipFill>
-        <p:spPr>
-          <a:xfrm>
-            <a:off x="4785970" y="2938882"/>
-            <a:ext cx="1941271" cy="374904"/>
-          </a:xfrm>
-          <a:prstGeom prst="rect">
-            <a:avLst/>
-          </a:prstGeom>
-        </p:spPr>
-      </p:pic>
-      <p:pic>
-        <p:nvPicPr>
-          <p:cNvPr id="15" name="Image 10" descr="/home/claude/shots/clear.png">
-            <a:hlinkClick r:id="rId22" tooltip="US-005 Watch the clip, either side"/>
-          </p:cNvPr>
-          <p:cNvPicPr>
-            <a:picLocks noChangeAspect="1"/>
-          </p:cNvPicPr>
-          <p:nvPr/>
-        </p:nvPicPr>
-        <p:blipFill>
-          <a:blip r:embed="rId21"/>
-          <a:stretch>
-            <a:fillRect/>
-          </a:stretch>
-        </p:blipFill>
-        <p:spPr>
-          <a:xfrm>
-            <a:off x="6802222" y="2529230"/>
-            <a:ext cx="977494" cy="374904"/>
-          </a:xfrm>
-          <a:prstGeom prst="rect">
-            <a:avLst/>
-          </a:prstGeom>
-        </p:spPr>
-      </p:pic>
-      <p:pic>
-        <p:nvPicPr>
-          <p:cNvPr id="16" name="Image 11" descr="/home/claude/shots/clear.png">
-            <a:hlinkClick r:id="rId24" tooltip="US-006 See why it was graded and classified"/>
-          </p:cNvPr>
-          <p:cNvPicPr>
-            <a:picLocks noChangeAspect="1"/>
-          </p:cNvPicPr>
-          <p:nvPr/>
-        </p:nvPicPr>
-        <p:blipFill>
-          <a:blip r:embed="rId23"/>
-          <a:stretch>
-            <a:fillRect/>
-          </a:stretch>
-        </p:blipFill>
-        <p:spPr>
-          <a:xfrm>
-            <a:off x="6802222" y="2938882"/>
-            <a:ext cx="977494" cy="467258"/>
-          </a:xfrm>
-          <a:prstGeom prst="rect">
-            <a:avLst/>
-          </a:prstGeom>
-        </p:spPr>
-      </p:pic>
-      <p:pic>
-        <p:nvPicPr>
-          <p:cNvPr id="17" name="Image 12" descr="/home/claude/shots/clear.png">
-            <a:hlinkClick r:id="rId26" tooltip="US-007 Footage states are honest"/>
-          </p:cNvPr>
-          <p:cNvPicPr>
-            <a:picLocks noChangeAspect="1"/>
-          </p:cNvPicPr>
-          <p:nvPr/>
-        </p:nvPicPr>
-        <p:blipFill>
-          <a:blip r:embed="rId25"/>
-          <a:stretch>
-            <a:fillRect/>
-          </a:stretch>
-        </p:blipFill>
-        <p:spPr>
-          <a:xfrm>
-            <a:off x="6802222" y="3440887"/>
-            <a:ext cx="977494" cy="374904"/>
-          </a:xfrm>
-          <a:prstGeom prst="rect">
-            <a:avLst/>
-          </a:prstGeom>
-        </p:spPr>
-      </p:pic>
-      <p:pic>
-        <p:nvPicPr>
-          <p:cNvPr id="18" name="Image 13" descr="/home/claude/shots/clear.png">
-            <a:hlinkClick r:id="rId28" tooltip="US-008 Resolve who was driving"/>
-          </p:cNvPr>
-          <p:cNvPicPr>
-            <a:picLocks noChangeAspect="1"/>
-          </p:cNvPicPr>
-          <p:nvPr/>
-        </p:nvPicPr>
-        <p:blipFill>
-          <a:blip r:embed="rId27"/>
-          <a:stretch>
-            <a:fillRect/>
-          </a:stretch>
-        </p:blipFill>
-        <p:spPr>
-          <a:xfrm>
-            <a:off x="6802222" y="3850538"/>
-            <a:ext cx="977494" cy="374904"/>
-          </a:xfrm>
-          <a:prstGeom prst="rect">
-            <a:avLst/>
-          </a:prstGeom>
-        </p:spPr>
-      </p:pic>
-      <p:pic>
-        <p:nvPicPr>
-          <p:cNvPr id="19" name="Image 14" descr="/home/claude/shots/clear.png">
-            <a:hlinkClick r:id="rId30" tooltip="US-010 Log a coaching conversation"/>
-          </p:cNvPr>
-          <p:cNvPicPr>
-            <a:picLocks noChangeAspect="1"/>
-          </p:cNvPicPr>
-          <p:nvPr/>
-        </p:nvPicPr>
-        <p:blipFill>
-          <a:blip r:embed="rId29"/>
-          <a:stretch>
-            <a:fillRect/>
-          </a:stretch>
-        </p:blipFill>
-        <p:spPr>
-          <a:xfrm>
-            <a:off x="7854696" y="2529230"/>
-            <a:ext cx="1886407" cy="374904"/>
-          </a:xfrm>
-          <a:prstGeom prst="rect">
-            <a:avLst/>
-          </a:prstGeom>
-        </p:spPr>
-      </p:pic>
-      <p:pic>
-        <p:nvPicPr>
-          <p:cNvPr id="20" name="Image 15" descr="/home/claude/shots/clear.png">
-            <a:hlinkClick r:id="rId32" tooltip="US-011 Capture what the driver said"/>
-          </p:cNvPr>
-          <p:cNvPicPr>
-            <a:picLocks noChangeAspect="1"/>
-          </p:cNvPicPr>
-          <p:nvPr/>
-        </p:nvPicPr>
-        <p:blipFill>
-          <a:blip r:embed="rId31"/>
-          <a:stretch>
-            <a:fillRect/>
-          </a:stretch>
-        </p:blipFill>
-        <p:spPr>
-          <a:xfrm>
-            <a:off x="7854696" y="2938882"/>
-            <a:ext cx="1886407" cy="374904"/>
-          </a:xfrm>
-          <a:prstGeom prst="rect">
-            <a:avLst/>
-          </a:prstGeom>
-        </p:spPr>
-      </p:pic>
-      <p:pic>
-        <p:nvPicPr>
-          <p:cNvPr id="21" name="Image 16" descr="/home/claude/shots/clear.png">
-            <a:hlinkClick r:id="rId34" tooltip="US-012 Confirm recognition"/>
-          </p:cNvPr>
-          <p:cNvPicPr>
-            <a:picLocks noChangeAspect="1"/>
-          </p:cNvPicPr>
-          <p:nvPr/>
-        </p:nvPicPr>
-        <p:blipFill>
-          <a:blip r:embed="rId33"/>
-          <a:stretch>
-            <a:fillRect/>
-          </a:stretch>
-        </p:blipFill>
-        <p:spPr>
-          <a:xfrm>
-            <a:off x="7854696" y="3348533"/>
-            <a:ext cx="1886407" cy="374904"/>
-          </a:xfrm>
-          <a:prstGeom prst="rect">
-            <a:avLst/>
-          </a:prstGeom>
-        </p:spPr>
-      </p:pic>
-      <p:pic>
-        <p:nvPicPr>
-          <p:cNvPr id="22" name="Image 17" descr="/home/claude/shots/clear.png">
-            <a:hlinkClick r:id="rId36" tooltip="US-013 Send a medium group to the driver"/>
-          </p:cNvPr>
-          <p:cNvPicPr>
-            <a:picLocks noChangeAspect="1"/>
-          </p:cNvPicPr>
-          <p:nvPr/>
-        </p:nvPicPr>
-        <p:blipFill>
-          <a:blip r:embed="rId35"/>
-          <a:stretch>
-            <a:fillRect/>
-          </a:stretch>
-        </p:blipFill>
-        <p:spPr>
-          <a:xfrm>
-            <a:off x="7854696" y="3758184"/>
-            <a:ext cx="1886407" cy="374904"/>
-          </a:xfrm>
-          <a:prstGeom prst="rect">
-            <a:avLst/>
-          </a:prstGeom>
-        </p:spPr>
-      </p:pic>
-      <p:pic>
-        <p:nvPicPr>
-          <p:cNvPr id="23" name="Image 18" descr="/home/claude/shots/clear.png">
-            <a:hlinkClick r:id="rId38" tooltip="US-014 A driver record showing both sides"/>
-          </p:cNvPr>
-          <p:cNvPicPr>
-            <a:picLocks noChangeAspect="1"/>
-          </p:cNvPicPr>
-          <p:nvPr/>
-        </p:nvPicPr>
-        <p:blipFill>
-          <a:blip r:embed="rId37"/>
-          <a:stretch>
-            <a:fillRect/>
-          </a:stretch>
-        </p:blipFill>
-        <p:spPr>
-          <a:xfrm>
-            <a:off x="9816084" y="2529230"/>
-            <a:ext cx="1651406" cy="374904"/>
-          </a:xfrm>
-          <a:prstGeom prst="rect">
-            <a:avLst/>
-          </a:prstGeom>
-        </p:spPr>
-      </p:pic>
-      <p:pic>
-        <p:nvPicPr>
-          <p:cNvPr id="24" name="Image 19" descr="/home/claude/shots/clear.png">
-            <a:hlinkClick r:id="rId40" tooltip="US-015 · J-24 A fleet view that does not overstate"/>
-          </p:cNvPr>
-          <p:cNvPicPr>
-            <a:picLocks noChangeAspect="1"/>
-          </p:cNvPicPr>
-          <p:nvPr/>
-        </p:nvPicPr>
-        <p:blipFill>
-          <a:blip r:embed="rId39"/>
-          <a:stretch>
-            <a:fillRect/>
-          </a:stretch>
-        </p:blipFill>
-        <p:spPr>
-          <a:xfrm>
-            <a:off x="9816084" y="4353458"/>
-            <a:ext cx="1651406" cy="467258"/>
-          </a:xfrm>
-          <a:prstGeom prst="rect">
-            <a:avLst/>
-          </a:prstGeom>
-        </p:spPr>
-      </p:pic>
-      <p:pic>
-        <p:nvPicPr>
-          <p:cNvPr id="25" name="Image 20" descr="/home/claude/shots/clear.png">
-            <a:hlinkClick r:id="rId42" tooltip="ADR-0012 Headway and fatigue"/>
-          </p:cNvPr>
-          <p:cNvPicPr>
-            <a:picLocks noChangeAspect="1"/>
-          </p:cNvPicPr>
-          <p:nvPr/>
-        </p:nvPicPr>
-        <p:blipFill>
-          <a:blip r:embed="rId41"/>
-          <a:stretch>
-            <a:fillRect/>
-          </a:stretch>
-        </p:blipFill>
-        <p:spPr>
-          <a:xfrm>
-            <a:off x="1119226" y="4947818"/>
-            <a:ext cx="1831543" cy="467258"/>
-          </a:xfrm>
-          <a:prstGeom prst="rect">
-            <a:avLst/>
-          </a:prstGeom>
-        </p:spPr>
-      </p:pic>
-      <p:pic>
-        <p:nvPicPr>
-          <p:cNvPr id="26" name="Image 21" descr="/home/claude/shots/clear.png">
-            <a:hlinkClick r:id="rId44" tooltip="ADR-0009 · R-11 Re-engagement on sustained non-use"/>
-          </p:cNvPr>
-          <p:cNvPicPr>
-            <a:picLocks noChangeAspect="1"/>
-          </p:cNvPicPr>
-          <p:nvPr/>
-        </p:nvPicPr>
-        <p:blipFill>
-          <a:blip r:embed="rId43"/>
-          <a:stretch>
-            <a:fillRect/>
-          </a:stretch>
-        </p:blipFill>
-        <p:spPr>
-          <a:xfrm>
-            <a:off x="3025750" y="4947818"/>
-            <a:ext cx="1686154" cy="467258"/>
-          </a:xfrm>
-          <a:prstGeom prst="rect">
-            <a:avLst/>
-          </a:prstGeom>
-        </p:spPr>
-      </p:pic>
-      <p:pic>
-        <p:nvPicPr>
-          <p:cNvPr id="27" name="Image 22" descr="/home/claude/shots/clear.png">
-            <a:hlinkClick r:id="rId46" tooltip="ADR-0013 Downgrade audit tooling"/>
-          </p:cNvPr>
-          <p:cNvPicPr>
-            <a:picLocks noChangeAspect="1"/>
-          </p:cNvPicPr>
-          <p:nvPr/>
-        </p:nvPicPr>
-        <p:blipFill>
-          <a:blip r:embed="rId45"/>
-          <a:stretch>
-            <a:fillRect/>
-          </a:stretch>
-        </p:blipFill>
-        <p:spPr>
-          <a:xfrm>
-            <a:off x="4785970" y="4947818"/>
-            <a:ext cx="1941271" cy="467258"/>
-          </a:xfrm>
-          <a:prstGeom prst="rect">
-            <a:avLst/>
-          </a:prstGeom>
-        </p:spPr>
-      </p:pic>
-      <p:pic>
-        <p:nvPicPr>
-          <p:cNvPr id="28" name="Image 23" descr="/home/claude/shots/clear.png">
-            <a:hlinkClick r:id="rId48" tooltip="ADR-0004 Any driver-facing surface"/>
-          </p:cNvPr>
-          <p:cNvPicPr>
-            <a:picLocks noChangeAspect="1"/>
-          </p:cNvPicPr>
-          <p:nvPr/>
-        </p:nvPicPr>
-        <p:blipFill>
-          <a:blip r:embed="rId47"/>
-          <a:stretch>
-            <a:fillRect/>
-          </a:stretch>
-        </p:blipFill>
-        <p:spPr>
-          <a:xfrm>
-            <a:off x="7854696" y="4947818"/>
-            <a:ext cx="1886407" cy="467258"/>
-          </a:xfrm>
-          <a:prstGeom prst="rect">
-            <a:avLst/>
-          </a:prstGeom>
-        </p:spPr>
-      </p:pic>
-      <p:pic>
-        <p:nvPicPr>
-          <p:cNvPr id="29" name="Image 24" descr="/home/claude/shots/clear.png">
-            <a:hlinkClick r:id="rId50" tooltip="ADR-0006 · A-16 Depot-manager handover"/>
-          </p:cNvPr>
-          <p:cNvPicPr>
-            <a:picLocks noChangeAspect="1"/>
-          </p:cNvPicPr>
-          <p:nvPr/>
-        </p:nvPicPr>
-        <p:blipFill>
-          <a:blip r:embed="rId49"/>
-          <a:stretch>
-            <a:fillRect/>
-          </a:stretch>
-        </p:blipFill>
-        <p:spPr>
-          <a:xfrm>
-            <a:off x="7854696" y="5449824"/>
-            <a:ext cx="1886407" cy="467258"/>
-          </a:xfrm>
-          <a:prstGeom prst="rect">
-            <a:avLst/>
-          </a:prstGeom>
-        </p:spPr>
-      </p:pic>
-      <p:sp>
-        <p:nvSpPr>
-          <p:cNvPr id="30" name="Text 3"/>
-          <p:cNvSpPr txBox="1"/>
-          <p:nvPr/>
-        </p:nvSpPr>
-        <p:spPr>
-          <a:xfrm>
-            <a:off x="658368" y="6217920"/>
+            <a:endParaRPr lang="en-US" sz="1200" dirty="0"/>
+          </a:p>
+        </p:txBody>
+      </p:sp>
+      <p:sp>
+        <p:nvSpPr>
+          <p:cNvPr id="5" name="Shape 3"/>
+          <p:cNvSpPr/>
+          <p:nvPr/>
+        </p:nvSpPr>
+        <p:spPr>
+          <a:xfrm>
+            <a:off x="1463040" y="1810512"/>
+            <a:ext cx="1609344" cy="420624"/>
+          </a:xfrm>
+          <a:prstGeom prst="rect">
+            <a:avLst/>
+          </a:prstGeom>
+          <a:solidFill>
+            <a:srgbClr val="2B3038"/>
+          </a:solidFill>
+          <a:ln w="9525">
+            <a:solidFill>
+              <a:srgbClr val="2B3038"/>
+            </a:solidFill>
+            <a:prstDash val="solid"/>
+          </a:ln>
+        </p:spPr>
+      </p:sp>
+      <p:sp>
+        <p:nvSpPr>
+          <p:cNvPr id="6" name="Text 4"/>
+          <p:cNvSpPr txBox="1"/>
+          <p:nvPr/>
+        </p:nvSpPr>
+        <p:spPr>
+          <a:xfrm>
+            <a:off x="1554480" y="1883664"/>
+            <a:ext cx="1426464" cy="310896"/>
+          </a:xfrm>
+          <a:prstGeom prst="rect">
+            <a:avLst/>
+          </a:prstGeom>
+          <a:noFill/>
+          <a:ln/>
+        </p:spPr>
+        <p:txBody>
+          <a:bodyPr wrap="square" lIns="0" tIns="0" rIns="0" bIns="0" rtlCol="0" anchor="t"/>
+          <a:lstStyle/>
+          <a:p>
+            <a:pPr indent="0" marL="0">
+              <a:lnSpc>
+                <a:spcPts val="1050"/>
+              </a:lnSpc>
+              <a:buNone/>
+            </a:pPr>
+            <a:r>
+              <a:rPr lang="en-US" sz="860" b="1" dirty="0">
+                <a:solidFill>
+                  <a:srgbClr val="FFFFFF"/>
+                </a:solidFill>
+                <a:latin typeface="Cambria" pitchFamily="34" charset="0"/>
+                <a:ea typeface="Cambria" pitchFamily="34" charset="-122"/>
+                <a:cs typeface="Cambria" pitchFamily="34" charset="-120"/>
+              </a:rPr>
+              <a:t>Events arrive and get graded</a:t>
+            </a:r>
+            <a:endParaRPr lang="en-US" sz="860" dirty="0"/>
+          </a:p>
+        </p:txBody>
+      </p:sp>
+      <p:sp>
+        <p:nvSpPr>
+          <p:cNvPr id="7" name="Shape 5"/>
+          <p:cNvSpPr/>
+          <p:nvPr/>
+        </p:nvSpPr>
+        <p:spPr>
+          <a:xfrm>
+            <a:off x="3136392" y="1810512"/>
+            <a:ext cx="1609344" cy="420624"/>
+          </a:xfrm>
+          <a:prstGeom prst="rect">
+            <a:avLst/>
+          </a:prstGeom>
+          <a:solidFill>
+            <a:srgbClr val="2B3038"/>
+          </a:solidFill>
+          <a:ln w="9525">
+            <a:solidFill>
+              <a:srgbClr val="2B3038"/>
+            </a:solidFill>
+            <a:prstDash val="solid"/>
+          </a:ln>
+        </p:spPr>
+      </p:sp>
+      <p:sp>
+        <p:nvSpPr>
+          <p:cNvPr id="8" name="Text 6"/>
+          <p:cNvSpPr txBox="1"/>
+          <p:nvPr/>
+        </p:nvSpPr>
+        <p:spPr>
+          <a:xfrm>
+            <a:off x="3227832" y="1883664"/>
+            <a:ext cx="1426464" cy="310896"/>
+          </a:xfrm>
+          <a:prstGeom prst="rect">
+            <a:avLst/>
+          </a:prstGeom>
+          <a:noFill/>
+          <a:ln/>
+        </p:spPr>
+        <p:txBody>
+          <a:bodyPr wrap="square" lIns="0" tIns="0" rIns="0" bIns="0" rtlCol="0" anchor="t"/>
+          <a:lstStyle/>
+          <a:p>
+            <a:pPr indent="0" marL="0">
+              <a:lnSpc>
+                <a:spcPts val="1050"/>
+              </a:lnSpc>
+              <a:buNone/>
+            </a:pPr>
+            <a:r>
+              <a:rPr lang="en-US" sz="860" b="1" dirty="0">
+                <a:solidFill>
+                  <a:srgbClr val="FFFFFF"/>
+                </a:solidFill>
+                <a:latin typeface="Cambria" pitchFamily="34" charset="0"/>
+                <a:ea typeface="Cambria" pitchFamily="34" charset="-122"/>
+                <a:cs typeface="Cambria" pitchFamily="34" charset="-120"/>
+              </a:rPr>
+              <a:t>Start the week</a:t>
+            </a:r>
+            <a:endParaRPr lang="en-US" sz="860" dirty="0"/>
+          </a:p>
+        </p:txBody>
+      </p:sp>
+      <p:sp>
+        <p:nvSpPr>
+          <p:cNvPr id="9" name="Shape 7"/>
+          <p:cNvSpPr/>
+          <p:nvPr/>
+        </p:nvSpPr>
+        <p:spPr>
+          <a:xfrm>
+            <a:off x="4809744" y="1810512"/>
+            <a:ext cx="1609344" cy="420624"/>
+          </a:xfrm>
+          <a:prstGeom prst="rect">
+            <a:avLst/>
+          </a:prstGeom>
+          <a:solidFill>
+            <a:srgbClr val="2B3038"/>
+          </a:solidFill>
+          <a:ln w="9525">
+            <a:solidFill>
+              <a:srgbClr val="2B3038"/>
+            </a:solidFill>
+            <a:prstDash val="solid"/>
+          </a:ln>
+        </p:spPr>
+      </p:sp>
+      <p:sp>
+        <p:nvSpPr>
+          <p:cNvPr id="10" name="Text 8"/>
+          <p:cNvSpPr txBox="1"/>
+          <p:nvPr/>
+        </p:nvSpPr>
+        <p:spPr>
+          <a:xfrm>
+            <a:off x="4901184" y="1883664"/>
+            <a:ext cx="1426464" cy="310896"/>
+          </a:xfrm>
+          <a:prstGeom prst="rect">
+            <a:avLst/>
+          </a:prstGeom>
+          <a:noFill/>
+          <a:ln/>
+        </p:spPr>
+        <p:txBody>
+          <a:bodyPr wrap="square" lIns="0" tIns="0" rIns="0" bIns="0" rtlCol="0" anchor="t"/>
+          <a:lstStyle/>
+          <a:p>
+            <a:pPr indent="0" marL="0">
+              <a:lnSpc>
+                <a:spcPts val="1050"/>
+              </a:lnSpc>
+              <a:buNone/>
+            </a:pPr>
+            <a:r>
+              <a:rPr lang="en-US" sz="860" b="1" dirty="0">
+                <a:solidFill>
+                  <a:srgbClr val="FFFFFF"/>
+                </a:solidFill>
+                <a:latin typeface="Cambria" pitchFamily="34" charset="0"/>
+                <a:ea typeface="Cambria" pitchFamily="34" charset="-122"/>
+                <a:cs typeface="Cambria" pitchFamily="34" charset="-120"/>
+              </a:rPr>
+              <a:t>Clear the set</a:t>
+            </a:r>
+            <a:endParaRPr lang="en-US" sz="860" dirty="0"/>
+          </a:p>
+        </p:txBody>
+      </p:sp>
+      <p:sp>
+        <p:nvSpPr>
+          <p:cNvPr id="11" name="Shape 9"/>
+          <p:cNvSpPr/>
+          <p:nvPr/>
+        </p:nvSpPr>
+        <p:spPr>
+          <a:xfrm>
+            <a:off x="6483096" y="1810512"/>
+            <a:ext cx="1609344" cy="420624"/>
+          </a:xfrm>
+          <a:prstGeom prst="rect">
+            <a:avLst/>
+          </a:prstGeom>
+          <a:solidFill>
+            <a:srgbClr val="2B3038"/>
+          </a:solidFill>
+          <a:ln w="9525">
+            <a:solidFill>
+              <a:srgbClr val="2B3038"/>
+            </a:solidFill>
+            <a:prstDash val="solid"/>
+          </a:ln>
+        </p:spPr>
+      </p:sp>
+      <p:sp>
+        <p:nvSpPr>
+          <p:cNvPr id="12" name="Text 10"/>
+          <p:cNvSpPr txBox="1"/>
+          <p:nvPr/>
+        </p:nvSpPr>
+        <p:spPr>
+          <a:xfrm>
+            <a:off x="6574536" y="1883664"/>
+            <a:ext cx="1426464" cy="310896"/>
+          </a:xfrm>
+          <a:prstGeom prst="rect">
+            <a:avLst/>
+          </a:prstGeom>
+          <a:noFill/>
+          <a:ln/>
+        </p:spPr>
+        <p:txBody>
+          <a:bodyPr wrap="square" lIns="0" tIns="0" rIns="0" bIns="0" rtlCol="0" anchor="t"/>
+          <a:lstStyle/>
+          <a:p>
+            <a:pPr indent="0" marL="0">
+              <a:lnSpc>
+                <a:spcPts val="1050"/>
+              </a:lnSpc>
+              <a:buNone/>
+            </a:pPr>
+            <a:r>
+              <a:rPr lang="en-US" sz="860" b="1" dirty="0">
+                <a:solidFill>
+                  <a:srgbClr val="FFFFFF"/>
+                </a:solidFill>
+                <a:latin typeface="Cambria" pitchFamily="34" charset="0"/>
+                <a:ea typeface="Cambria" pitchFamily="34" charset="-122"/>
+                <a:cs typeface="Cambria" pitchFamily="34" charset="-120"/>
+              </a:rPr>
+              <a:t>Understand the event</a:t>
+            </a:r>
+            <a:endParaRPr lang="en-US" sz="860" dirty="0"/>
+          </a:p>
+        </p:txBody>
+      </p:sp>
+      <p:sp>
+        <p:nvSpPr>
+          <p:cNvPr id="13" name="Shape 11"/>
+          <p:cNvSpPr/>
+          <p:nvPr/>
+        </p:nvSpPr>
+        <p:spPr>
+          <a:xfrm>
+            <a:off x="8156448" y="1810512"/>
+            <a:ext cx="1609344" cy="420624"/>
+          </a:xfrm>
+          <a:prstGeom prst="rect">
+            <a:avLst/>
+          </a:prstGeom>
+          <a:solidFill>
+            <a:srgbClr val="2B3038"/>
+          </a:solidFill>
+          <a:ln w="9525">
+            <a:solidFill>
+              <a:srgbClr val="2B3038"/>
+            </a:solidFill>
+            <a:prstDash val="solid"/>
+          </a:ln>
+        </p:spPr>
+      </p:sp>
+      <p:sp>
+        <p:nvSpPr>
+          <p:cNvPr id="14" name="Text 12"/>
+          <p:cNvSpPr txBox="1"/>
+          <p:nvPr/>
+        </p:nvSpPr>
+        <p:spPr>
+          <a:xfrm>
+            <a:off x="8247888" y="1883664"/>
+            <a:ext cx="1426464" cy="310896"/>
+          </a:xfrm>
+          <a:prstGeom prst="rect">
+            <a:avLst/>
+          </a:prstGeom>
+          <a:noFill/>
+          <a:ln/>
+        </p:spPr>
+        <p:txBody>
+          <a:bodyPr wrap="square" lIns="0" tIns="0" rIns="0" bIns="0" rtlCol="0" anchor="t"/>
+          <a:lstStyle/>
+          <a:p>
+            <a:pPr indent="0" marL="0">
+              <a:lnSpc>
+                <a:spcPts val="1050"/>
+              </a:lnSpc>
+              <a:buNone/>
+            </a:pPr>
+            <a:r>
+              <a:rPr lang="en-US" sz="860" b="1" dirty="0">
+                <a:solidFill>
+                  <a:srgbClr val="FFFFFF"/>
+                </a:solidFill>
+                <a:latin typeface="Cambria" pitchFamily="34" charset="0"/>
+                <a:ea typeface="Cambria" pitchFamily="34" charset="-122"/>
+                <a:cs typeface="Cambria" pitchFamily="34" charset="-120"/>
+              </a:rPr>
+              <a:t>Decide and act</a:t>
+            </a:r>
+            <a:endParaRPr lang="en-US" sz="860" dirty="0"/>
+          </a:p>
+        </p:txBody>
+      </p:sp>
+      <p:sp>
+        <p:nvSpPr>
+          <p:cNvPr id="15" name="Shape 13"/>
+          <p:cNvSpPr/>
+          <p:nvPr/>
+        </p:nvSpPr>
+        <p:spPr>
+          <a:xfrm>
+            <a:off x="9829800" y="1810512"/>
+            <a:ext cx="1609344" cy="420624"/>
+          </a:xfrm>
+          <a:prstGeom prst="rect">
+            <a:avLst/>
+          </a:prstGeom>
+          <a:solidFill>
+            <a:srgbClr val="2B3038"/>
+          </a:solidFill>
+          <a:ln w="9525">
+            <a:solidFill>
+              <a:srgbClr val="2B3038"/>
+            </a:solidFill>
+            <a:prstDash val="solid"/>
+          </a:ln>
+        </p:spPr>
+      </p:sp>
+      <p:sp>
+        <p:nvSpPr>
+          <p:cNvPr id="16" name="Text 14"/>
+          <p:cNvSpPr txBox="1"/>
+          <p:nvPr/>
+        </p:nvSpPr>
+        <p:spPr>
+          <a:xfrm>
+            <a:off x="9921240" y="1883664"/>
+            <a:ext cx="1426464" cy="310896"/>
+          </a:xfrm>
+          <a:prstGeom prst="rect">
+            <a:avLst/>
+          </a:prstGeom>
+          <a:noFill/>
+          <a:ln/>
+        </p:spPr>
+        <p:txBody>
+          <a:bodyPr wrap="square" lIns="0" tIns="0" rIns="0" bIns="0" rtlCol="0" anchor="t"/>
+          <a:lstStyle/>
+          <a:p>
+            <a:pPr indent="0" marL="0">
+              <a:lnSpc>
+                <a:spcPts val="1050"/>
+              </a:lnSpc>
+              <a:buNone/>
+            </a:pPr>
+            <a:r>
+              <a:rPr lang="en-US" sz="860" b="1" dirty="0">
+                <a:solidFill>
+                  <a:srgbClr val="FFFFFF"/>
+                </a:solidFill>
+                <a:latin typeface="Cambria" pitchFamily="34" charset="0"/>
+                <a:ea typeface="Cambria" pitchFamily="34" charset="-122"/>
+                <a:cs typeface="Cambria" pitchFamily="34" charset="-120"/>
+              </a:rPr>
+              <a:t>See whether it worked</a:t>
+            </a:r>
+            <a:endParaRPr lang="en-US" sz="860" dirty="0"/>
+          </a:p>
+        </p:txBody>
+      </p:sp>
+      <p:sp>
+        <p:nvSpPr>
+          <p:cNvPr id="17" name="Text 15"/>
+          <p:cNvSpPr txBox="1"/>
+          <p:nvPr/>
+        </p:nvSpPr>
+        <p:spPr>
+          <a:xfrm>
+            <a:off x="658368" y="2304288"/>
+            <a:ext cx="713232" cy="219456"/>
+          </a:xfrm>
+          <a:prstGeom prst="rect">
+            <a:avLst/>
+          </a:prstGeom>
+          <a:noFill/>
+          <a:ln/>
+        </p:spPr>
+        <p:txBody>
+          <a:bodyPr wrap="square" lIns="0" tIns="0" rIns="0" bIns="0" rtlCol="0" anchor="t"/>
+          <a:lstStyle/>
+          <a:p>
+            <a:pPr indent="0" marL="0">
+              <a:buNone/>
+            </a:pPr>
+            <a:r>
+              <a:rPr lang="en-US" sz="1100" b="1" dirty="0">
+                <a:solidFill>
+                  <a:srgbClr val="C8621E"/>
+                </a:solidFill>
+                <a:latin typeface="Cambria" pitchFamily="34" charset="0"/>
+                <a:ea typeface="Cambria" pitchFamily="34" charset="-122"/>
+                <a:cs typeface="Cambria" pitchFamily="34" charset="-120"/>
+              </a:rPr>
+              <a:t>v1</a:t>
+            </a:r>
+            <a:endParaRPr lang="en-US" sz="1100" dirty="0"/>
+          </a:p>
+        </p:txBody>
+      </p:sp>
+      <p:sp>
+        <p:nvSpPr>
+          <p:cNvPr id="18" name="Text 16"/>
+          <p:cNvSpPr txBox="1"/>
+          <p:nvPr/>
+        </p:nvSpPr>
+        <p:spPr>
+          <a:xfrm>
+            <a:off x="658368" y="2514600"/>
+            <a:ext cx="749808" cy="402336"/>
+          </a:xfrm>
+          <a:prstGeom prst="rect">
+            <a:avLst/>
+          </a:prstGeom>
+          <a:noFill/>
+          <a:ln/>
+        </p:spPr>
+        <p:txBody>
+          <a:bodyPr wrap="square" lIns="0" tIns="0" rIns="0" bIns="0" rtlCol="0" anchor="t"/>
+          <a:lstStyle/>
+          <a:p>
+            <a:pPr indent="0" marL="0">
+              <a:lnSpc>
+                <a:spcPts val="860"/>
+              </a:lnSpc>
+              <a:buNone/>
+            </a:pPr>
+            <a:r>
+              <a:rPr lang="en-US" sz="700" dirty="0">
+                <a:solidFill>
+                  <a:srgbClr val="98A0A8"/>
+                </a:solidFill>
+                <a:latin typeface="Calibri" pitchFamily="34" charset="0"/>
+                <a:ea typeface="Calibri" pitchFamily="34" charset="-122"/>
+                <a:cs typeface="Calibri" pitchFamily="34" charset="-120"/>
+              </a:rPr>
+              <a:t>first shippable,</a:t>
+            </a:r>
+            <a:endParaRPr lang="en-US" sz="700" dirty="0"/>
+          </a:p>
+          <a:p>
+            <a:pPr indent="0" marL="0">
+              <a:lnSpc>
+                <a:spcPts val="860"/>
+              </a:lnSpc>
+              <a:buNone/>
+            </a:pPr>
+            <a:r>
+              <a:rPr lang="en-US" sz="700" dirty="0">
+                <a:solidFill>
+                  <a:srgbClr val="98A0A8"/>
+                </a:solidFill>
+                <a:latin typeface="Calibri" pitchFamily="34" charset="0"/>
+                <a:ea typeface="Calibri" pitchFamily="34" charset="-122"/>
+                <a:cs typeface="Calibri" pitchFamily="34" charset="-120"/>
+              </a:rPr>
+              <a:t>14 stories</a:t>
+            </a:r>
+            <a:endParaRPr lang="en-US" sz="700" dirty="0"/>
+          </a:p>
+        </p:txBody>
+      </p:sp>
+      <p:sp>
+        <p:nvSpPr>
+          <p:cNvPr id="19" name="Shape 17"/>
+          <p:cNvSpPr/>
+          <p:nvPr/>
+        </p:nvSpPr>
+        <p:spPr>
+          <a:xfrm>
+            <a:off x="1463040" y="2304288"/>
+            <a:ext cx="1609344" cy="475488"/>
+          </a:xfrm>
+          <a:prstGeom prst="rect">
+            <a:avLst/>
+          </a:prstGeom>
+          <a:solidFill>
+            <a:srgbClr val="F2F3F4"/>
+          </a:solidFill>
+          <a:ln w="9525">
+            <a:solidFill>
+              <a:srgbClr val="DDE0E3"/>
+            </a:solidFill>
+            <a:prstDash val="solid"/>
+          </a:ln>
+        </p:spPr>
+      </p:sp>
+      <p:sp>
+        <p:nvSpPr>
+          <p:cNvPr id="20" name="Shape 18"/>
+          <p:cNvSpPr/>
+          <p:nvPr/>
+        </p:nvSpPr>
+        <p:spPr>
+          <a:xfrm>
+            <a:off x="1463040" y="2304288"/>
+            <a:ext cx="32004" cy="475488"/>
+          </a:xfrm>
+          <a:prstGeom prst="rect">
+            <a:avLst/>
+          </a:prstGeom>
+          <a:solidFill>
+            <a:srgbClr val="98A0A8"/>
+          </a:solidFill>
+          <a:ln w="12700">
+            <a:solidFill>
+              <a:srgbClr val="333333"/>
+            </a:solidFill>
+            <a:prstDash val="solid"/>
+          </a:ln>
+        </p:spPr>
+      </p:sp>
+      <p:sp>
+        <p:nvSpPr>
+          <p:cNvPr id="21" name="Text 19"/>
+          <p:cNvSpPr txBox="1"/>
+          <p:nvPr/>
+        </p:nvSpPr>
+        <p:spPr>
+          <a:xfrm>
+            <a:off x="1554480" y="2359152"/>
+            <a:ext cx="1481328" cy="384048"/>
+          </a:xfrm>
+          <a:prstGeom prst="rect">
+            <a:avLst/>
+          </a:prstGeom>
+          <a:noFill/>
+          <a:ln/>
+        </p:spPr>
+        <p:txBody>
+          <a:bodyPr wrap="square" lIns="0" tIns="0" rIns="0" bIns="0" rtlCol="0" anchor="t"/>
+          <a:lstStyle/>
+          <a:p>
+            <a:pPr indent="0" marL="0">
+              <a:lnSpc>
+                <a:spcPts val="980"/>
+              </a:lnSpc>
+              <a:buNone/>
+            </a:pPr>
+            <a:r>
+              <a:rPr lang="en-US" sz="660" b="1" dirty="0">
+                <a:solidFill>
+                  <a:srgbClr val="98A0A8"/>
+                </a:solidFill>
+                <a:latin typeface="Calibri" pitchFamily="34" charset="0"/>
+                <a:ea typeface="Calibri" pitchFamily="34" charset="-122"/>
+                <a:cs typeface="Calibri" pitchFamily="34" charset="-120"/>
+                <a:hlinkClick r:id="rId2" invalidUrl="" action="" tgtFrame="" tooltip="Four triggers, every signal" history="1" highlightClick="0" endSnd="0">
+                  <a:extLst>
+                    <a:ext uri="{A12FA001-AC4F-418D-AE19-62706E023703}">
+                      <ahyp:hlinkClr xmlns:ahyp="http://schemas.microsoft.com/office/drawing/2018/hyperlinkcolor" val="tx"/>
+                    </a:ext>
+                  </a:extLst>
+                </a:hlinkClick>
+              </a:rPr>
+              <a:t>ADR-0012 · platform
+</a:t>
+            </a:r>
+            <a:endParaRPr lang="en-US" sz="660" dirty="0"/>
+          </a:p>
+          <a:p>
+            <a:pPr indent="0" marL="0">
+              <a:lnSpc>
+                <a:spcPts val="980"/>
+              </a:lnSpc>
+              <a:buNone/>
+            </a:pPr>
+            <a:r>
+              <a:rPr lang="en-US" sz="800" b="1" dirty="0">
+                <a:solidFill>
+                  <a:srgbClr val="2B3038"/>
+                </a:solidFill>
+                <a:latin typeface="Calibri" pitchFamily="34" charset="0"/>
+                <a:ea typeface="Calibri" pitchFamily="34" charset="-122"/>
+                <a:cs typeface="Calibri" pitchFamily="34" charset="-120"/>
+                <a:hlinkClick r:id="rId3" invalidUrl="" action="" tgtFrame="" tooltip="Four triggers, every signal" history="1" highlightClick="0" endSnd="0">
+                  <a:extLst>
+                    <a:ext uri="{A12FA001-AC4F-418D-AE19-62706E023703}">
+                      <ahyp:hlinkClr xmlns:ahyp="http://schemas.microsoft.com/office/drawing/2018/hyperlinkcolor" val="tx"/>
+                    </a:ext>
+                  </a:extLst>
+                </a:hlinkClick>
+              </a:rPr>
+              <a:t>Four triggers, every signal</a:t>
+            </a:r>
+            <a:endParaRPr lang="en-US" sz="660" dirty="0"/>
+          </a:p>
+        </p:txBody>
+      </p:sp>
+      <p:sp>
+        <p:nvSpPr>
+          <p:cNvPr id="22" name="Shape 20"/>
+          <p:cNvSpPr/>
+          <p:nvPr/>
+        </p:nvSpPr>
+        <p:spPr>
+          <a:xfrm>
+            <a:off x="1463040" y="2807208"/>
+            <a:ext cx="1609344" cy="475488"/>
+          </a:xfrm>
+          <a:prstGeom prst="rect">
+            <a:avLst/>
+          </a:prstGeom>
+          <a:solidFill>
+            <a:srgbClr val="F2F3F4"/>
+          </a:solidFill>
+          <a:ln w="9525">
+            <a:solidFill>
+              <a:srgbClr val="DDE0E3"/>
+            </a:solidFill>
+            <a:prstDash val="solid"/>
+          </a:ln>
+        </p:spPr>
+      </p:sp>
+      <p:sp>
+        <p:nvSpPr>
+          <p:cNvPr id="23" name="Shape 21"/>
+          <p:cNvSpPr/>
+          <p:nvPr/>
+        </p:nvSpPr>
+        <p:spPr>
+          <a:xfrm>
+            <a:off x="1463040" y="2807208"/>
+            <a:ext cx="32004" cy="475488"/>
+          </a:xfrm>
+          <a:prstGeom prst="rect">
+            <a:avLst/>
+          </a:prstGeom>
+          <a:solidFill>
+            <a:srgbClr val="98A0A8"/>
+          </a:solidFill>
+          <a:ln w="12700">
+            <a:solidFill>
+              <a:srgbClr val="333333"/>
+            </a:solidFill>
+            <a:prstDash val="solid"/>
+          </a:ln>
+        </p:spPr>
+      </p:sp>
+      <p:sp>
+        <p:nvSpPr>
+          <p:cNvPr id="24" name="Text 22"/>
+          <p:cNvSpPr txBox="1"/>
+          <p:nvPr/>
+        </p:nvSpPr>
+        <p:spPr>
+          <a:xfrm>
+            <a:off x="1554480" y="2862072"/>
+            <a:ext cx="1481328" cy="384048"/>
+          </a:xfrm>
+          <a:prstGeom prst="rect">
+            <a:avLst/>
+          </a:prstGeom>
+          <a:noFill/>
+          <a:ln/>
+        </p:spPr>
+        <p:txBody>
+          <a:bodyPr wrap="square" lIns="0" tIns="0" rIns="0" bIns="0" rtlCol="0" anchor="t"/>
+          <a:lstStyle/>
+          <a:p>
+            <a:pPr indent="0" marL="0">
+              <a:lnSpc>
+                <a:spcPts val="980"/>
+              </a:lnSpc>
+              <a:buNone/>
+            </a:pPr>
+            <a:r>
+              <a:rPr lang="en-US" sz="660" b="1" dirty="0">
+                <a:solidFill>
+                  <a:srgbClr val="98A0A8"/>
+                </a:solidFill>
+                <a:latin typeface="Calibri" pitchFamily="34" charset="0"/>
+                <a:ea typeface="Calibri" pitchFamily="34" charset="-122"/>
+                <a:cs typeface="Calibri" pitchFamily="34" charset="-120"/>
+                <a:hlinkClick r:id="rId4" invalidUrl="" action="" tgtFrame="" tooltip="Severity-gated video upload" history="1" highlightClick="0" endSnd="0">
+                  <a:extLst>
+                    <a:ext uri="{A12FA001-AC4F-418D-AE19-62706E023703}">
+                      <ahyp:hlinkClr xmlns:ahyp="http://schemas.microsoft.com/office/drawing/2018/hyperlinkcolor" val="tx"/>
+                    </a:ext>
+                  </a:extLst>
+                </a:hlinkClick>
+              </a:rPr>
+              <a:t>ADR-0002 · platform
+</a:t>
+            </a:r>
+            <a:endParaRPr lang="en-US" sz="660" dirty="0"/>
+          </a:p>
+          <a:p>
+            <a:pPr indent="0" marL="0">
+              <a:lnSpc>
+                <a:spcPts val="980"/>
+              </a:lnSpc>
+              <a:buNone/>
+            </a:pPr>
+            <a:r>
+              <a:rPr lang="en-US" sz="800" b="1" dirty="0">
+                <a:solidFill>
+                  <a:srgbClr val="2B3038"/>
+                </a:solidFill>
+                <a:latin typeface="Calibri" pitchFamily="34" charset="0"/>
+                <a:ea typeface="Calibri" pitchFamily="34" charset="-122"/>
+                <a:cs typeface="Calibri" pitchFamily="34" charset="-120"/>
+                <a:hlinkClick r:id="rId5" invalidUrl="" action="" tgtFrame="" tooltip="Severity-gated video upload" history="1" highlightClick="0" endSnd="0">
+                  <a:extLst>
+                    <a:ext uri="{A12FA001-AC4F-418D-AE19-62706E023703}">
+                      <ahyp:hlinkClr xmlns:ahyp="http://schemas.microsoft.com/office/drawing/2018/hyperlinkcolor" val="tx"/>
+                    </a:ext>
+                  </a:extLst>
+                </a:hlinkClick>
+              </a:rPr>
+              <a:t>Severity-gated video upload</a:t>
+            </a:r>
+            <a:endParaRPr lang="en-US" sz="660" dirty="0"/>
+          </a:p>
+        </p:txBody>
+      </p:sp>
+      <p:sp>
+        <p:nvSpPr>
+          <p:cNvPr id="25" name="Shape 23"/>
+          <p:cNvSpPr/>
+          <p:nvPr/>
+        </p:nvSpPr>
+        <p:spPr>
+          <a:xfrm>
+            <a:off x="1463040" y="3310128"/>
+            <a:ext cx="1609344" cy="475488"/>
+          </a:xfrm>
+          <a:prstGeom prst="rect">
+            <a:avLst/>
+          </a:prstGeom>
+          <a:solidFill>
+            <a:srgbClr val="F2F3F4"/>
+          </a:solidFill>
+          <a:ln w="9525">
+            <a:solidFill>
+              <a:srgbClr val="DDE0E3"/>
+            </a:solidFill>
+            <a:prstDash val="solid"/>
+          </a:ln>
+        </p:spPr>
+      </p:sp>
+      <p:sp>
+        <p:nvSpPr>
+          <p:cNvPr id="26" name="Shape 24"/>
+          <p:cNvSpPr/>
+          <p:nvPr/>
+        </p:nvSpPr>
+        <p:spPr>
+          <a:xfrm>
+            <a:off x="1463040" y="3310128"/>
+            <a:ext cx="32004" cy="475488"/>
+          </a:xfrm>
+          <a:prstGeom prst="rect">
+            <a:avLst/>
+          </a:prstGeom>
+          <a:solidFill>
+            <a:srgbClr val="98A0A8"/>
+          </a:solidFill>
+          <a:ln w="12700">
+            <a:solidFill>
+              <a:srgbClr val="333333"/>
+            </a:solidFill>
+            <a:prstDash val="solid"/>
+          </a:ln>
+        </p:spPr>
+      </p:sp>
+      <p:sp>
+        <p:nvSpPr>
+          <p:cNvPr id="27" name="Text 25"/>
+          <p:cNvSpPr txBox="1"/>
+          <p:nvPr/>
+        </p:nvSpPr>
+        <p:spPr>
+          <a:xfrm>
+            <a:off x="1554480" y="3364992"/>
+            <a:ext cx="1481328" cy="384048"/>
+          </a:xfrm>
+          <a:prstGeom prst="rect">
+            <a:avLst/>
+          </a:prstGeom>
+          <a:noFill/>
+          <a:ln/>
+        </p:spPr>
+        <p:txBody>
+          <a:bodyPr wrap="square" lIns="0" tIns="0" rIns="0" bIns="0" rtlCol="0" anchor="t"/>
+          <a:lstStyle/>
+          <a:p>
+            <a:pPr indent="0" marL="0">
+              <a:lnSpc>
+                <a:spcPts val="980"/>
+              </a:lnSpc>
+              <a:buNone/>
+            </a:pPr>
+            <a:r>
+              <a:rPr lang="en-US" sz="660" b="1" dirty="0">
+                <a:solidFill>
+                  <a:srgbClr val="98A0A8"/>
+                </a:solidFill>
+                <a:latin typeface="Calibri" pitchFamily="34" charset="0"/>
+                <a:ea typeface="Calibri" pitchFamily="34" charset="-122"/>
+                <a:cs typeface="Calibri" pitchFamily="34" charset="-120"/>
+                <a:hlinkClick r:id="rId6" invalidUrl="" action="" tgtFrame="" tooltip="Four bands, each with an action" history="1" highlightClick="0" endSnd="0">
+                  <a:extLst>
+                    <a:ext uri="{A12FA001-AC4F-418D-AE19-62706E023703}">
+                      <ahyp:hlinkClr xmlns:ahyp="http://schemas.microsoft.com/office/drawing/2018/hyperlinkcolor" val="tx"/>
+                    </a:ext>
+                  </a:extLst>
+                </a:hlinkClick>
+              </a:rPr>
+              <a:t>ADR-0007 · platform
+</a:t>
+            </a:r>
+            <a:endParaRPr lang="en-US" sz="660" dirty="0"/>
+          </a:p>
+          <a:p>
+            <a:pPr indent="0" marL="0">
+              <a:lnSpc>
+                <a:spcPts val="980"/>
+              </a:lnSpc>
+              <a:buNone/>
+            </a:pPr>
+            <a:r>
+              <a:rPr lang="en-US" sz="800" b="1" dirty="0">
+                <a:solidFill>
+                  <a:srgbClr val="2B3038"/>
+                </a:solidFill>
+                <a:latin typeface="Calibri" pitchFamily="34" charset="0"/>
+                <a:ea typeface="Calibri" pitchFamily="34" charset="-122"/>
+                <a:cs typeface="Calibri" pitchFamily="34" charset="-120"/>
+                <a:hlinkClick r:id="rId7" invalidUrl="" action="" tgtFrame="" tooltip="Four bands, each with an action" history="1" highlightClick="0" endSnd="0">
+                  <a:extLst>
+                    <a:ext uri="{A12FA001-AC4F-418D-AE19-62706E023703}">
+                      <ahyp:hlinkClr xmlns:ahyp="http://schemas.microsoft.com/office/drawing/2018/hyperlinkcolor" val="tx"/>
+                    </a:ext>
+                  </a:extLst>
+                </a:hlinkClick>
+              </a:rPr>
+              <a:t>Four bands, each with an action</a:t>
+            </a:r>
+            <a:endParaRPr lang="en-US" sz="660" dirty="0"/>
+          </a:p>
+        </p:txBody>
+      </p:sp>
+      <p:sp>
+        <p:nvSpPr>
+          <p:cNvPr id="28" name="Shape 26"/>
+          <p:cNvSpPr/>
+          <p:nvPr/>
+        </p:nvSpPr>
+        <p:spPr>
+          <a:xfrm>
+            <a:off x="1463040" y="3813048"/>
+            <a:ext cx="1609344" cy="475488"/>
+          </a:xfrm>
+          <a:prstGeom prst="rect">
+            <a:avLst/>
+          </a:prstGeom>
+          <a:solidFill>
+            <a:srgbClr val="F2F3F4"/>
+          </a:solidFill>
+          <a:ln w="9525">
+            <a:solidFill>
+              <a:srgbClr val="DDE0E3"/>
+            </a:solidFill>
+            <a:prstDash val="solid"/>
+          </a:ln>
+        </p:spPr>
+      </p:sp>
+      <p:sp>
+        <p:nvSpPr>
+          <p:cNvPr id="29" name="Shape 27"/>
+          <p:cNvSpPr/>
+          <p:nvPr/>
+        </p:nvSpPr>
+        <p:spPr>
+          <a:xfrm>
+            <a:off x="1463040" y="3813048"/>
+            <a:ext cx="32004" cy="475488"/>
+          </a:xfrm>
+          <a:prstGeom prst="rect">
+            <a:avLst/>
+          </a:prstGeom>
+          <a:solidFill>
+            <a:srgbClr val="98A0A8"/>
+          </a:solidFill>
+          <a:ln w="12700">
+            <a:solidFill>
+              <a:srgbClr val="333333"/>
+            </a:solidFill>
+            <a:prstDash val="solid"/>
+          </a:ln>
+        </p:spPr>
+      </p:sp>
+      <p:sp>
+        <p:nvSpPr>
+          <p:cNvPr id="30" name="Text 28"/>
+          <p:cNvSpPr txBox="1"/>
+          <p:nvPr/>
+        </p:nvSpPr>
+        <p:spPr>
+          <a:xfrm>
+            <a:off x="1554480" y="3867912"/>
+            <a:ext cx="1481328" cy="384048"/>
+          </a:xfrm>
+          <a:prstGeom prst="rect">
+            <a:avLst/>
+          </a:prstGeom>
+          <a:noFill/>
+          <a:ln/>
+        </p:spPr>
+        <p:txBody>
+          <a:bodyPr wrap="square" lIns="0" tIns="0" rIns="0" bIns="0" rtlCol="0" anchor="t"/>
+          <a:lstStyle/>
+          <a:p>
+            <a:pPr indent="0" marL="0">
+              <a:lnSpc>
+                <a:spcPts val="980"/>
+              </a:lnSpc>
+              <a:buNone/>
+            </a:pPr>
+            <a:r>
+              <a:rPr lang="en-US" sz="660" b="1" dirty="0">
+                <a:solidFill>
+                  <a:srgbClr val="98A0A8"/>
+                </a:solidFill>
+                <a:latin typeface="Calibri" pitchFamily="34" charset="0"/>
+                <a:ea typeface="Calibri" pitchFamily="34" charset="-122"/>
+                <a:cs typeface="Calibri" pitchFamily="34" charset="-120"/>
+                <a:hlinkClick r:id="rId8" invalidUrl="" action="" tgtFrame="" tooltip="Risk, neutral or credit" history="1" highlightClick="0" endSnd="0">
+                  <a:extLst>
+                    <a:ext uri="{A12FA001-AC4F-418D-AE19-62706E023703}">
+                      <ahyp:hlinkClr xmlns:ahyp="http://schemas.microsoft.com/office/drawing/2018/hyperlinkcolor" val="tx"/>
+                    </a:ext>
+                  </a:extLst>
+                </a:hlinkClick>
+              </a:rPr>
+              <a:t>ADR-0010 · platform
+</a:t>
+            </a:r>
+            <a:endParaRPr lang="en-US" sz="660" dirty="0"/>
+          </a:p>
+          <a:p>
+            <a:pPr indent="0" marL="0">
+              <a:lnSpc>
+                <a:spcPts val="980"/>
+              </a:lnSpc>
+              <a:buNone/>
+            </a:pPr>
+            <a:r>
+              <a:rPr lang="en-US" sz="800" b="1" dirty="0">
+                <a:solidFill>
+                  <a:srgbClr val="2B3038"/>
+                </a:solidFill>
+                <a:latin typeface="Calibri" pitchFamily="34" charset="0"/>
+                <a:ea typeface="Calibri" pitchFamily="34" charset="-122"/>
+                <a:cs typeface="Calibri" pitchFamily="34" charset="-120"/>
+                <a:hlinkClick r:id="rId9" invalidUrl="" action="" tgtFrame="" tooltip="Risk, neutral or credit" history="1" highlightClick="0" endSnd="0">
+                  <a:extLst>
+                    <a:ext uri="{A12FA001-AC4F-418D-AE19-62706E023703}">
+                      <ahyp:hlinkClr xmlns:ahyp="http://schemas.microsoft.com/office/drawing/2018/hyperlinkcolor" val="tx"/>
+                    </a:ext>
+                  </a:extLst>
+                </a:hlinkClick>
+              </a:rPr>
+              <a:t>Risk, neutral or credit</a:t>
+            </a:r>
+            <a:endParaRPr lang="en-US" sz="660" dirty="0"/>
+          </a:p>
+        </p:txBody>
+      </p:sp>
+      <p:sp>
+        <p:nvSpPr>
+          <p:cNvPr id="31" name="Shape 29"/>
+          <p:cNvSpPr/>
+          <p:nvPr/>
+        </p:nvSpPr>
+        <p:spPr>
+          <a:xfrm>
+            <a:off x="3136392" y="2304288"/>
+            <a:ext cx="1609344" cy="475488"/>
+          </a:xfrm>
+          <a:prstGeom prst="rect">
+            <a:avLst/>
+          </a:prstGeom>
+          <a:solidFill>
+            <a:srgbClr val="FFFFFF"/>
+          </a:solidFill>
+          <a:ln w="9525">
+            <a:solidFill>
+              <a:srgbClr val="DDE0E3"/>
+            </a:solidFill>
+            <a:prstDash val="solid"/>
+          </a:ln>
+        </p:spPr>
+      </p:sp>
+      <p:sp>
+        <p:nvSpPr>
+          <p:cNvPr id="32" name="Shape 30"/>
+          <p:cNvSpPr/>
+          <p:nvPr/>
+        </p:nvSpPr>
+        <p:spPr>
+          <a:xfrm>
+            <a:off x="3136392" y="2304288"/>
+            <a:ext cx="32004" cy="475488"/>
+          </a:xfrm>
+          <a:prstGeom prst="rect">
+            <a:avLst/>
+          </a:prstGeom>
+          <a:solidFill>
+            <a:srgbClr val="C8621E"/>
+          </a:solidFill>
+          <a:ln w="12700">
+            <a:solidFill>
+              <a:srgbClr val="333333"/>
+            </a:solidFill>
+            <a:prstDash val="solid"/>
+          </a:ln>
+        </p:spPr>
+      </p:sp>
+      <p:sp>
+        <p:nvSpPr>
+          <p:cNvPr id="33" name="Text 31"/>
+          <p:cNvSpPr txBox="1"/>
+          <p:nvPr/>
+        </p:nvSpPr>
+        <p:spPr>
+          <a:xfrm>
+            <a:off x="3227832" y="2359152"/>
+            <a:ext cx="1481328" cy="384048"/>
+          </a:xfrm>
+          <a:prstGeom prst="rect">
+            <a:avLst/>
+          </a:prstGeom>
+          <a:noFill/>
+          <a:ln/>
+        </p:spPr>
+        <p:txBody>
+          <a:bodyPr wrap="square" lIns="0" tIns="0" rIns="0" bIns="0" rtlCol="0" anchor="t"/>
+          <a:lstStyle/>
+          <a:p>
+            <a:pPr indent="0" marL="0">
+              <a:lnSpc>
+                <a:spcPts val="980"/>
+              </a:lnSpc>
+              <a:buNone/>
+            </a:pPr>
+            <a:r>
+              <a:rPr lang="en-US" sz="660" b="1" dirty="0">
+                <a:solidFill>
+                  <a:srgbClr val="98A0A8"/>
+                </a:solidFill>
+                <a:latin typeface="Calibri" pitchFamily="34" charset="0"/>
+                <a:ea typeface="Calibri" pitchFamily="34" charset="-122"/>
+                <a:cs typeface="Calibri" pitchFamily="34" charset="-120"/>
+                <a:hlinkClick r:id="rId10" invalidUrl="" action="" tgtFrame="" tooltip="A weekly set that can be finished" history="1" highlightClick="0" endSnd="0">
+                  <a:extLst>
+                    <a:ext uri="{A12FA001-AC4F-418D-AE19-62706E023703}">
+                      <ahyp:hlinkClr xmlns:ahyp="http://schemas.microsoft.com/office/drawing/2018/hyperlinkcolor" val="tx"/>
+                    </a:ext>
+                  </a:extLst>
+                </a:hlinkClick>
+              </a:rPr>
+              <a:t>US-001
+</a:t>
+            </a:r>
+            <a:endParaRPr lang="en-US" sz="660" dirty="0"/>
+          </a:p>
+          <a:p>
+            <a:pPr indent="0" marL="0">
+              <a:lnSpc>
+                <a:spcPts val="980"/>
+              </a:lnSpc>
+              <a:buNone/>
+            </a:pPr>
+            <a:r>
+              <a:rPr lang="en-US" sz="800" b="1" dirty="0">
+                <a:solidFill>
+                  <a:srgbClr val="2B3038"/>
+                </a:solidFill>
+                <a:latin typeface="Calibri" pitchFamily="34" charset="0"/>
+                <a:ea typeface="Calibri" pitchFamily="34" charset="-122"/>
+                <a:cs typeface="Calibri" pitchFamily="34" charset="-120"/>
+                <a:hlinkClick r:id="rId11" invalidUrl="" action="" tgtFrame="" tooltip="A weekly set that can be finished" history="1" highlightClick="0" endSnd="0">
+                  <a:extLst>
+                    <a:ext uri="{A12FA001-AC4F-418D-AE19-62706E023703}">
+                      <ahyp:hlinkClr xmlns:ahyp="http://schemas.microsoft.com/office/drawing/2018/hyperlinkcolor" val="tx"/>
+                    </a:ext>
+                  </a:extLst>
+                </a:hlinkClick>
+              </a:rPr>
+              <a:t>A weekly set that can be finished</a:t>
+            </a:r>
+            <a:endParaRPr lang="en-US" sz="660" dirty="0"/>
+          </a:p>
+        </p:txBody>
+      </p:sp>
+      <p:sp>
+        <p:nvSpPr>
+          <p:cNvPr id="34" name="Shape 32"/>
+          <p:cNvSpPr/>
+          <p:nvPr/>
+        </p:nvSpPr>
+        <p:spPr>
+          <a:xfrm>
+            <a:off x="3136392" y="2807208"/>
+            <a:ext cx="1609344" cy="475488"/>
+          </a:xfrm>
+          <a:prstGeom prst="rect">
+            <a:avLst/>
+          </a:prstGeom>
+          <a:solidFill>
+            <a:srgbClr val="FFFFFF"/>
+          </a:solidFill>
+          <a:ln w="9525">
+            <a:solidFill>
+              <a:srgbClr val="DDE0E3"/>
+            </a:solidFill>
+            <a:prstDash val="solid"/>
+          </a:ln>
+        </p:spPr>
+      </p:sp>
+      <p:sp>
+        <p:nvSpPr>
+          <p:cNvPr id="35" name="Shape 33"/>
+          <p:cNvSpPr/>
+          <p:nvPr/>
+        </p:nvSpPr>
+        <p:spPr>
+          <a:xfrm>
+            <a:off x="3136392" y="2807208"/>
+            <a:ext cx="32004" cy="475488"/>
+          </a:xfrm>
+          <a:prstGeom prst="rect">
+            <a:avLst/>
+          </a:prstGeom>
+          <a:solidFill>
+            <a:srgbClr val="C8621E"/>
+          </a:solidFill>
+          <a:ln w="12700">
+            <a:solidFill>
+              <a:srgbClr val="333333"/>
+            </a:solidFill>
+            <a:prstDash val="solid"/>
+          </a:ln>
+        </p:spPr>
+      </p:sp>
+      <p:sp>
+        <p:nvSpPr>
+          <p:cNvPr id="36" name="Text 34"/>
+          <p:cNvSpPr txBox="1"/>
+          <p:nvPr/>
+        </p:nvSpPr>
+        <p:spPr>
+          <a:xfrm>
+            <a:off x="3227832" y="2862072"/>
+            <a:ext cx="1481328" cy="384048"/>
+          </a:xfrm>
+          <a:prstGeom prst="rect">
+            <a:avLst/>
+          </a:prstGeom>
+          <a:noFill/>
+          <a:ln/>
+        </p:spPr>
+        <p:txBody>
+          <a:bodyPr wrap="square" lIns="0" tIns="0" rIns="0" bIns="0" rtlCol="0" anchor="t"/>
+          <a:lstStyle/>
+          <a:p>
+            <a:pPr indent="0" marL="0">
+              <a:lnSpc>
+                <a:spcPts val="980"/>
+              </a:lnSpc>
+              <a:buNone/>
+            </a:pPr>
+            <a:r>
+              <a:rPr lang="en-US" sz="660" b="1" dirty="0">
+                <a:solidFill>
+                  <a:srgbClr val="98A0A8"/>
+                </a:solidFill>
+                <a:latin typeface="Calibri" pitchFamily="34" charset="0"/>
+                <a:ea typeface="Calibri" pitchFamily="34" charset="-122"/>
+                <a:cs typeface="Calibri" pitchFamily="34" charset="-120"/>
+                <a:hlinkClick r:id="rId12" invalidUrl="" action="" tgtFrame="" tooltip="Critical events bypass the rhythm" history="1" highlightClick="0" endSnd="0">
+                  <a:extLst>
+                    <a:ext uri="{A12FA001-AC4F-418D-AE19-62706E023703}">
+                      <ahyp:hlinkClr xmlns:ahyp="http://schemas.microsoft.com/office/drawing/2018/hyperlinkcolor" val="tx"/>
+                    </a:ext>
+                  </a:extLst>
+                </a:hlinkClick>
+              </a:rPr>
+              <a:t>US-002
+</a:t>
+            </a:r>
+            <a:endParaRPr lang="en-US" sz="660" dirty="0"/>
+          </a:p>
+          <a:p>
+            <a:pPr indent="0" marL="0">
+              <a:lnSpc>
+                <a:spcPts val="980"/>
+              </a:lnSpc>
+              <a:buNone/>
+            </a:pPr>
+            <a:r>
+              <a:rPr lang="en-US" sz="800" b="1" dirty="0">
+                <a:solidFill>
+                  <a:srgbClr val="2B3038"/>
+                </a:solidFill>
+                <a:latin typeface="Calibri" pitchFamily="34" charset="0"/>
+                <a:ea typeface="Calibri" pitchFamily="34" charset="-122"/>
+                <a:cs typeface="Calibri" pitchFamily="34" charset="-120"/>
+                <a:hlinkClick r:id="rId13" invalidUrl="" action="" tgtFrame="" tooltip="Critical events bypass the rhythm" history="1" highlightClick="0" endSnd="0">
+                  <a:extLst>
+                    <a:ext uri="{A12FA001-AC4F-418D-AE19-62706E023703}">
+                      <ahyp:hlinkClr xmlns:ahyp="http://schemas.microsoft.com/office/drawing/2018/hyperlinkcolor" val="tx"/>
+                    </a:ext>
+                  </a:extLst>
+                </a:hlinkClick>
+              </a:rPr>
+              <a:t>Critical events bypass the rhythm</a:t>
+            </a:r>
+            <a:endParaRPr lang="en-US" sz="660" dirty="0"/>
+          </a:p>
+        </p:txBody>
+      </p:sp>
+      <p:sp>
+        <p:nvSpPr>
+          <p:cNvPr id="37" name="Shape 35"/>
+          <p:cNvSpPr/>
+          <p:nvPr/>
+        </p:nvSpPr>
+        <p:spPr>
+          <a:xfrm>
+            <a:off x="3136392" y="3310128"/>
+            <a:ext cx="1609344" cy="475488"/>
+          </a:xfrm>
+          <a:prstGeom prst="rect">
+            <a:avLst/>
+          </a:prstGeom>
+          <a:solidFill>
+            <a:srgbClr val="FFFFFF"/>
+          </a:solidFill>
+          <a:ln w="9525">
+            <a:solidFill>
+              <a:srgbClr val="DDE0E3"/>
+            </a:solidFill>
+            <a:prstDash val="solid"/>
+          </a:ln>
+        </p:spPr>
+      </p:sp>
+      <p:sp>
+        <p:nvSpPr>
+          <p:cNvPr id="38" name="Shape 36"/>
+          <p:cNvSpPr/>
+          <p:nvPr/>
+        </p:nvSpPr>
+        <p:spPr>
+          <a:xfrm>
+            <a:off x="3136392" y="3310128"/>
+            <a:ext cx="32004" cy="475488"/>
+          </a:xfrm>
+          <a:prstGeom prst="rect">
+            <a:avLst/>
+          </a:prstGeom>
+          <a:solidFill>
+            <a:srgbClr val="C8621E"/>
+          </a:solidFill>
+          <a:ln w="12700">
+            <a:solidFill>
+              <a:srgbClr val="333333"/>
+            </a:solidFill>
+            <a:prstDash val="solid"/>
+          </a:ln>
+        </p:spPr>
+      </p:sp>
+      <p:sp>
+        <p:nvSpPr>
+          <p:cNvPr id="39" name="Text 37"/>
+          <p:cNvSpPr txBox="1"/>
+          <p:nvPr/>
+        </p:nvSpPr>
+        <p:spPr>
+          <a:xfrm>
+            <a:off x="3227832" y="3364992"/>
+            <a:ext cx="1481328" cy="384048"/>
+          </a:xfrm>
+          <a:prstGeom prst="rect">
+            <a:avLst/>
+          </a:prstGeom>
+          <a:noFill/>
+          <a:ln/>
+        </p:spPr>
+        <p:txBody>
+          <a:bodyPr wrap="square" lIns="0" tIns="0" rIns="0" bIns="0" rtlCol="0" anchor="t"/>
+          <a:lstStyle/>
+          <a:p>
+            <a:pPr indent="0" marL="0">
+              <a:lnSpc>
+                <a:spcPts val="980"/>
+              </a:lnSpc>
+              <a:buNone/>
+            </a:pPr>
+            <a:r>
+              <a:rPr lang="en-US" sz="660" b="1" dirty="0">
+                <a:solidFill>
+                  <a:srgbClr val="98A0A8"/>
+                </a:solidFill>
+                <a:latin typeface="Calibri" pitchFamily="34" charset="0"/>
+                <a:ea typeface="Calibri" pitchFamily="34" charset="-122"/>
+                <a:cs typeface="Calibri" pitchFamily="34" charset="-120"/>
+                <a:hlinkClick r:id="rId14" invalidUrl="" action="" tgtFrame="" tooltip="The set closes, visibly" history="1" highlightClick="0" endSnd="0">
+                  <a:extLst>
+                    <a:ext uri="{A12FA001-AC4F-418D-AE19-62706E023703}">
+                      <ahyp:hlinkClr xmlns:ahyp="http://schemas.microsoft.com/office/drawing/2018/hyperlinkcolor" val="tx"/>
+                    </a:ext>
+                  </a:extLst>
+                </a:hlinkClick>
+              </a:rPr>
+              <a:t>US-003
+</a:t>
+            </a:r>
+            <a:endParaRPr lang="en-US" sz="660" dirty="0"/>
+          </a:p>
+          <a:p>
+            <a:pPr indent="0" marL="0">
+              <a:lnSpc>
+                <a:spcPts val="980"/>
+              </a:lnSpc>
+              <a:buNone/>
+            </a:pPr>
+            <a:r>
+              <a:rPr lang="en-US" sz="800" b="1" dirty="0">
+                <a:solidFill>
+                  <a:srgbClr val="2B3038"/>
+                </a:solidFill>
+                <a:latin typeface="Calibri" pitchFamily="34" charset="0"/>
+                <a:ea typeface="Calibri" pitchFamily="34" charset="-122"/>
+                <a:cs typeface="Calibri" pitchFamily="34" charset="-120"/>
+                <a:hlinkClick r:id="rId15" invalidUrl="" action="" tgtFrame="" tooltip="The set closes, visibly" history="1" highlightClick="0" endSnd="0">
+                  <a:extLst>
+                    <a:ext uri="{A12FA001-AC4F-418D-AE19-62706E023703}">
+                      <ahyp:hlinkClr xmlns:ahyp="http://schemas.microsoft.com/office/drawing/2018/hyperlinkcolor" val="tx"/>
+                    </a:ext>
+                  </a:extLst>
+                </a:hlinkClick>
+              </a:rPr>
+              <a:t>The set closes, visibly</a:t>
+            </a:r>
+            <a:endParaRPr lang="en-US" sz="660" dirty="0"/>
+          </a:p>
+        </p:txBody>
+      </p:sp>
+      <p:sp>
+        <p:nvSpPr>
+          <p:cNvPr id="40" name="Shape 38"/>
+          <p:cNvSpPr/>
+          <p:nvPr/>
+        </p:nvSpPr>
+        <p:spPr>
+          <a:xfrm>
+            <a:off x="4809744" y="2304288"/>
+            <a:ext cx="1609344" cy="475488"/>
+          </a:xfrm>
+          <a:prstGeom prst="rect">
+            <a:avLst/>
+          </a:prstGeom>
+          <a:solidFill>
+            <a:srgbClr val="FFFFFF"/>
+          </a:solidFill>
+          <a:ln w="9525">
+            <a:solidFill>
+              <a:srgbClr val="DDE0E3"/>
+            </a:solidFill>
+            <a:prstDash val="solid"/>
+          </a:ln>
+        </p:spPr>
+      </p:sp>
+      <p:sp>
+        <p:nvSpPr>
+          <p:cNvPr id="41" name="Shape 39"/>
+          <p:cNvSpPr/>
+          <p:nvPr/>
+        </p:nvSpPr>
+        <p:spPr>
+          <a:xfrm>
+            <a:off x="4809744" y="2304288"/>
+            <a:ext cx="32004" cy="475488"/>
+          </a:xfrm>
+          <a:prstGeom prst="rect">
+            <a:avLst/>
+          </a:prstGeom>
+          <a:solidFill>
+            <a:srgbClr val="C8621E"/>
+          </a:solidFill>
+          <a:ln w="12700">
+            <a:solidFill>
+              <a:srgbClr val="333333"/>
+            </a:solidFill>
+            <a:prstDash val="solid"/>
+          </a:ln>
+        </p:spPr>
+      </p:sp>
+      <p:sp>
+        <p:nvSpPr>
+          <p:cNvPr id="42" name="Text 40"/>
+          <p:cNvSpPr txBox="1"/>
+          <p:nvPr/>
+        </p:nvSpPr>
+        <p:spPr>
+          <a:xfrm>
+            <a:off x="4901184" y="2359152"/>
+            <a:ext cx="1481328" cy="384048"/>
+          </a:xfrm>
+          <a:prstGeom prst="rect">
+            <a:avLst/>
+          </a:prstGeom>
+          <a:noFill/>
+          <a:ln/>
+        </p:spPr>
+        <p:txBody>
+          <a:bodyPr wrap="square" lIns="0" tIns="0" rIns="0" bIns="0" rtlCol="0" anchor="t"/>
+          <a:lstStyle/>
+          <a:p>
+            <a:pPr indent="0" marL="0">
+              <a:lnSpc>
+                <a:spcPts val="980"/>
+              </a:lnSpc>
+              <a:buNone/>
+            </a:pPr>
+            <a:r>
+              <a:rPr lang="en-US" sz="660" b="1" dirty="0">
+                <a:solidFill>
+                  <a:srgbClr val="98A0A8"/>
+                </a:solidFill>
+                <a:latin typeface="Calibri" pitchFamily="34" charset="0"/>
+                <a:ea typeface="Calibri" pitchFamily="34" charset="-122"/>
+                <a:cs typeface="Calibri" pitchFamily="34" charset="-120"/>
+                <a:hlinkClick r:id="rId16" invalidUrl="" action="" tgtFrame="" tooltip="Dismiss a group with a reason" history="1" highlightClick="0" endSnd="0">
+                  <a:extLst>
+                    <a:ext uri="{A12FA001-AC4F-418D-AE19-62706E023703}">
+                      <ahyp:hlinkClr xmlns:ahyp="http://schemas.microsoft.com/office/drawing/2018/hyperlinkcolor" val="tx"/>
+                    </a:ext>
+                  </a:extLst>
+                </a:hlinkClick>
+              </a:rPr>
+              <a:t>US-004
+</a:t>
+            </a:r>
+            <a:endParaRPr lang="en-US" sz="660" dirty="0"/>
+          </a:p>
+          <a:p>
+            <a:pPr indent="0" marL="0">
+              <a:lnSpc>
+                <a:spcPts val="980"/>
+              </a:lnSpc>
+              <a:buNone/>
+            </a:pPr>
+            <a:r>
+              <a:rPr lang="en-US" sz="800" b="1" dirty="0">
+                <a:solidFill>
+                  <a:srgbClr val="2B3038"/>
+                </a:solidFill>
+                <a:latin typeface="Calibri" pitchFamily="34" charset="0"/>
+                <a:ea typeface="Calibri" pitchFamily="34" charset="-122"/>
+                <a:cs typeface="Calibri" pitchFamily="34" charset="-120"/>
+                <a:hlinkClick r:id="rId17" invalidUrl="" action="" tgtFrame="" tooltip="Dismiss a group with a reason" history="1" highlightClick="0" endSnd="0">
+                  <a:extLst>
+                    <a:ext uri="{A12FA001-AC4F-418D-AE19-62706E023703}">
+                      <ahyp:hlinkClr xmlns:ahyp="http://schemas.microsoft.com/office/drawing/2018/hyperlinkcolor" val="tx"/>
+                    </a:ext>
+                  </a:extLst>
+                </a:hlinkClick>
+              </a:rPr>
+              <a:t>Dismiss a group with a reason</a:t>
+            </a:r>
+            <a:endParaRPr lang="en-US" sz="660" dirty="0"/>
+          </a:p>
+        </p:txBody>
+      </p:sp>
+      <p:sp>
+        <p:nvSpPr>
+          <p:cNvPr id="43" name="Shape 41"/>
+          <p:cNvSpPr/>
+          <p:nvPr/>
+        </p:nvSpPr>
+        <p:spPr>
+          <a:xfrm>
+            <a:off x="4809744" y="2807208"/>
+            <a:ext cx="1609344" cy="475488"/>
+          </a:xfrm>
+          <a:prstGeom prst="rect">
+            <a:avLst/>
+          </a:prstGeom>
+          <a:solidFill>
+            <a:srgbClr val="FFFFFF"/>
+          </a:solidFill>
+          <a:ln w="9525">
+            <a:solidFill>
+              <a:srgbClr val="DDE0E3"/>
+            </a:solidFill>
+            <a:prstDash val="solid"/>
+          </a:ln>
+        </p:spPr>
+      </p:sp>
+      <p:sp>
+        <p:nvSpPr>
+          <p:cNvPr id="44" name="Shape 42"/>
+          <p:cNvSpPr/>
+          <p:nvPr/>
+        </p:nvSpPr>
+        <p:spPr>
+          <a:xfrm>
+            <a:off x="4809744" y="2807208"/>
+            <a:ext cx="32004" cy="475488"/>
+          </a:xfrm>
+          <a:prstGeom prst="rect">
+            <a:avLst/>
+          </a:prstGeom>
+          <a:solidFill>
+            <a:srgbClr val="C8621E"/>
+          </a:solidFill>
+          <a:ln w="12700">
+            <a:solidFill>
+              <a:srgbClr val="333333"/>
+            </a:solidFill>
+            <a:prstDash val="solid"/>
+          </a:ln>
+        </p:spPr>
+      </p:sp>
+      <p:sp>
+        <p:nvSpPr>
+          <p:cNvPr id="45" name="Text 43"/>
+          <p:cNvSpPr txBox="1"/>
+          <p:nvPr/>
+        </p:nvSpPr>
+        <p:spPr>
+          <a:xfrm>
+            <a:off x="4901184" y="2862072"/>
+            <a:ext cx="1481328" cy="384048"/>
+          </a:xfrm>
+          <a:prstGeom prst="rect">
+            <a:avLst/>
+          </a:prstGeom>
+          <a:noFill/>
+          <a:ln/>
+        </p:spPr>
+        <p:txBody>
+          <a:bodyPr wrap="square" lIns="0" tIns="0" rIns="0" bIns="0" rtlCol="0" anchor="t"/>
+          <a:lstStyle/>
+          <a:p>
+            <a:pPr indent="0" marL="0">
+              <a:lnSpc>
+                <a:spcPts val="980"/>
+              </a:lnSpc>
+              <a:buNone/>
+            </a:pPr>
+            <a:r>
+              <a:rPr lang="en-US" sz="660" b="1" dirty="0">
+                <a:solidFill>
+                  <a:srgbClr val="98A0A8"/>
+                </a:solidFill>
+                <a:latin typeface="Calibri" pitchFamily="34" charset="0"/>
+                <a:ea typeface="Calibri" pitchFamily="34" charset="-122"/>
+                <a:cs typeface="Calibri" pitchFamily="34" charset="-120"/>
+                <a:hlinkClick r:id="rId18" invalidUrl="" action="" tgtFrame="" tooltip="Dismiss one, with a reason" history="1" highlightClick="0" endSnd="0">
+                  <a:extLst>
+                    <a:ext uri="{A12FA001-AC4F-418D-AE19-62706E023703}">
+                      <ahyp:hlinkClr xmlns:ahyp="http://schemas.microsoft.com/office/drawing/2018/hyperlinkcolor" val="tx"/>
+                    </a:ext>
+                  </a:extLst>
+                </a:hlinkClick>
+              </a:rPr>
+              <a:t>US-009
+</a:t>
+            </a:r>
+            <a:endParaRPr lang="en-US" sz="660" dirty="0"/>
+          </a:p>
+          <a:p>
+            <a:pPr indent="0" marL="0">
+              <a:lnSpc>
+                <a:spcPts val="980"/>
+              </a:lnSpc>
+              <a:buNone/>
+            </a:pPr>
+            <a:r>
+              <a:rPr lang="en-US" sz="800" b="1" dirty="0">
+                <a:solidFill>
+                  <a:srgbClr val="2B3038"/>
+                </a:solidFill>
+                <a:latin typeface="Calibri" pitchFamily="34" charset="0"/>
+                <a:ea typeface="Calibri" pitchFamily="34" charset="-122"/>
+                <a:cs typeface="Calibri" pitchFamily="34" charset="-120"/>
+                <a:hlinkClick r:id="rId19" invalidUrl="" action="" tgtFrame="" tooltip="Dismiss one, with a reason" history="1" highlightClick="0" endSnd="0">
+                  <a:extLst>
+                    <a:ext uri="{A12FA001-AC4F-418D-AE19-62706E023703}">
+                      <ahyp:hlinkClr xmlns:ahyp="http://schemas.microsoft.com/office/drawing/2018/hyperlinkcolor" val="tx"/>
+                    </a:ext>
+                  </a:extLst>
+                </a:hlinkClick>
+              </a:rPr>
+              <a:t>Dismiss one, with a reason</a:t>
+            </a:r>
+            <a:endParaRPr lang="en-US" sz="660" dirty="0"/>
+          </a:p>
+        </p:txBody>
+      </p:sp>
+      <p:sp>
+        <p:nvSpPr>
+          <p:cNvPr id="46" name="Shape 44"/>
+          <p:cNvSpPr/>
+          <p:nvPr/>
+        </p:nvSpPr>
+        <p:spPr>
+          <a:xfrm>
+            <a:off x="6483096" y="2304288"/>
+            <a:ext cx="1609344" cy="475488"/>
+          </a:xfrm>
+          <a:prstGeom prst="rect">
+            <a:avLst/>
+          </a:prstGeom>
+          <a:solidFill>
+            <a:srgbClr val="FFFFFF"/>
+          </a:solidFill>
+          <a:ln w="9525">
+            <a:solidFill>
+              <a:srgbClr val="DDE0E3"/>
+            </a:solidFill>
+            <a:prstDash val="solid"/>
+          </a:ln>
+        </p:spPr>
+      </p:sp>
+      <p:sp>
+        <p:nvSpPr>
+          <p:cNvPr id="47" name="Shape 45"/>
+          <p:cNvSpPr/>
+          <p:nvPr/>
+        </p:nvSpPr>
+        <p:spPr>
+          <a:xfrm>
+            <a:off x="6483096" y="2304288"/>
+            <a:ext cx="32004" cy="475488"/>
+          </a:xfrm>
+          <a:prstGeom prst="rect">
+            <a:avLst/>
+          </a:prstGeom>
+          <a:solidFill>
+            <a:srgbClr val="C8621E"/>
+          </a:solidFill>
+          <a:ln w="12700">
+            <a:solidFill>
+              <a:srgbClr val="333333"/>
+            </a:solidFill>
+            <a:prstDash val="solid"/>
+          </a:ln>
+        </p:spPr>
+      </p:sp>
+      <p:sp>
+        <p:nvSpPr>
+          <p:cNvPr id="48" name="Text 46"/>
+          <p:cNvSpPr txBox="1"/>
+          <p:nvPr/>
+        </p:nvSpPr>
+        <p:spPr>
+          <a:xfrm>
+            <a:off x="6574536" y="2359152"/>
+            <a:ext cx="1481328" cy="384048"/>
+          </a:xfrm>
+          <a:prstGeom prst="rect">
+            <a:avLst/>
+          </a:prstGeom>
+          <a:noFill/>
+          <a:ln/>
+        </p:spPr>
+        <p:txBody>
+          <a:bodyPr wrap="square" lIns="0" tIns="0" rIns="0" bIns="0" rtlCol="0" anchor="t"/>
+          <a:lstStyle/>
+          <a:p>
+            <a:pPr indent="0" marL="0">
+              <a:lnSpc>
+                <a:spcPts val="980"/>
+              </a:lnSpc>
+              <a:buNone/>
+            </a:pPr>
+            <a:r>
+              <a:rPr lang="en-US" sz="660" b="1" dirty="0">
+                <a:solidFill>
+                  <a:srgbClr val="98A0A8"/>
+                </a:solidFill>
+                <a:latin typeface="Calibri" pitchFamily="34" charset="0"/>
+                <a:ea typeface="Calibri" pitchFamily="34" charset="-122"/>
+                <a:cs typeface="Calibri" pitchFamily="34" charset="-120"/>
+                <a:hlinkClick r:id="rId20" invalidUrl="" action="" tgtFrame="" tooltip="Watch the clip, either side" history="1" highlightClick="0" endSnd="0">
+                  <a:extLst>
+                    <a:ext uri="{A12FA001-AC4F-418D-AE19-62706E023703}">
+                      <ahyp:hlinkClr xmlns:ahyp="http://schemas.microsoft.com/office/drawing/2018/hyperlinkcolor" val="tx"/>
+                    </a:ext>
+                  </a:extLst>
+                </a:hlinkClick>
+              </a:rPr>
+              <a:t>US-005
+</a:t>
+            </a:r>
+            <a:endParaRPr lang="en-US" sz="660" dirty="0"/>
+          </a:p>
+          <a:p>
+            <a:pPr indent="0" marL="0">
+              <a:lnSpc>
+                <a:spcPts val="980"/>
+              </a:lnSpc>
+              <a:buNone/>
+            </a:pPr>
+            <a:r>
+              <a:rPr lang="en-US" sz="800" b="1" dirty="0">
+                <a:solidFill>
+                  <a:srgbClr val="2B3038"/>
+                </a:solidFill>
+                <a:latin typeface="Calibri" pitchFamily="34" charset="0"/>
+                <a:ea typeface="Calibri" pitchFamily="34" charset="-122"/>
+                <a:cs typeface="Calibri" pitchFamily="34" charset="-120"/>
+                <a:hlinkClick r:id="rId21" invalidUrl="" action="" tgtFrame="" tooltip="Watch the clip, either side" history="1" highlightClick="0" endSnd="0">
+                  <a:extLst>
+                    <a:ext uri="{A12FA001-AC4F-418D-AE19-62706E023703}">
+                      <ahyp:hlinkClr xmlns:ahyp="http://schemas.microsoft.com/office/drawing/2018/hyperlinkcolor" val="tx"/>
+                    </a:ext>
+                  </a:extLst>
+                </a:hlinkClick>
+              </a:rPr>
+              <a:t>Watch the clip, either side</a:t>
+            </a:r>
+            <a:endParaRPr lang="en-US" sz="660" dirty="0"/>
+          </a:p>
+        </p:txBody>
+      </p:sp>
+      <p:sp>
+        <p:nvSpPr>
+          <p:cNvPr id="49" name="Shape 47"/>
+          <p:cNvSpPr/>
+          <p:nvPr/>
+        </p:nvSpPr>
+        <p:spPr>
+          <a:xfrm>
+            <a:off x="6483096" y="2807208"/>
+            <a:ext cx="1609344" cy="475488"/>
+          </a:xfrm>
+          <a:prstGeom prst="rect">
+            <a:avLst/>
+          </a:prstGeom>
+          <a:solidFill>
+            <a:srgbClr val="FFFFFF"/>
+          </a:solidFill>
+          <a:ln w="9525">
+            <a:solidFill>
+              <a:srgbClr val="DDE0E3"/>
+            </a:solidFill>
+            <a:prstDash val="solid"/>
+          </a:ln>
+        </p:spPr>
+      </p:sp>
+      <p:sp>
+        <p:nvSpPr>
+          <p:cNvPr id="50" name="Shape 48"/>
+          <p:cNvSpPr/>
+          <p:nvPr/>
+        </p:nvSpPr>
+        <p:spPr>
+          <a:xfrm>
+            <a:off x="6483096" y="2807208"/>
+            <a:ext cx="32004" cy="475488"/>
+          </a:xfrm>
+          <a:prstGeom prst="rect">
+            <a:avLst/>
+          </a:prstGeom>
+          <a:solidFill>
+            <a:srgbClr val="C8621E"/>
+          </a:solidFill>
+          <a:ln w="12700">
+            <a:solidFill>
+              <a:srgbClr val="333333"/>
+            </a:solidFill>
+            <a:prstDash val="solid"/>
+          </a:ln>
+        </p:spPr>
+      </p:sp>
+      <p:sp>
+        <p:nvSpPr>
+          <p:cNvPr id="51" name="Text 49"/>
+          <p:cNvSpPr txBox="1"/>
+          <p:nvPr/>
+        </p:nvSpPr>
+        <p:spPr>
+          <a:xfrm>
+            <a:off x="6574536" y="2862072"/>
+            <a:ext cx="1481328" cy="384048"/>
+          </a:xfrm>
+          <a:prstGeom prst="rect">
+            <a:avLst/>
+          </a:prstGeom>
+          <a:noFill/>
+          <a:ln/>
+        </p:spPr>
+        <p:txBody>
+          <a:bodyPr wrap="square" lIns="0" tIns="0" rIns="0" bIns="0" rtlCol="0" anchor="t"/>
+          <a:lstStyle/>
+          <a:p>
+            <a:pPr indent="0" marL="0">
+              <a:lnSpc>
+                <a:spcPts val="980"/>
+              </a:lnSpc>
+              <a:buNone/>
+            </a:pPr>
+            <a:r>
+              <a:rPr lang="en-US" sz="660" b="1" dirty="0">
+                <a:solidFill>
+                  <a:srgbClr val="98A0A8"/>
+                </a:solidFill>
+                <a:latin typeface="Calibri" pitchFamily="34" charset="0"/>
+                <a:ea typeface="Calibri" pitchFamily="34" charset="-122"/>
+                <a:cs typeface="Calibri" pitchFamily="34" charset="-120"/>
+                <a:hlinkClick r:id="rId22" invalidUrl="" action="" tgtFrame="" tooltip="See why it was graded and classified" history="1" highlightClick="0" endSnd="0">
+                  <a:extLst>
+                    <a:ext uri="{A12FA001-AC4F-418D-AE19-62706E023703}">
+                      <ahyp:hlinkClr xmlns:ahyp="http://schemas.microsoft.com/office/drawing/2018/hyperlinkcolor" val="tx"/>
+                    </a:ext>
+                  </a:extLst>
+                </a:hlinkClick>
+              </a:rPr>
+              <a:t>US-006
+</a:t>
+            </a:r>
+            <a:endParaRPr lang="en-US" sz="660" dirty="0"/>
+          </a:p>
+          <a:p>
+            <a:pPr indent="0" marL="0">
+              <a:lnSpc>
+                <a:spcPts val="980"/>
+              </a:lnSpc>
+              <a:buNone/>
+            </a:pPr>
+            <a:r>
+              <a:rPr lang="en-US" sz="800" b="1" dirty="0">
+                <a:solidFill>
+                  <a:srgbClr val="2B3038"/>
+                </a:solidFill>
+                <a:latin typeface="Calibri" pitchFamily="34" charset="0"/>
+                <a:ea typeface="Calibri" pitchFamily="34" charset="-122"/>
+                <a:cs typeface="Calibri" pitchFamily="34" charset="-120"/>
+                <a:hlinkClick r:id="rId23" invalidUrl="" action="" tgtFrame="" tooltip="See why it was graded and classified" history="1" highlightClick="0" endSnd="0">
+                  <a:extLst>
+                    <a:ext uri="{A12FA001-AC4F-418D-AE19-62706E023703}">
+                      <ahyp:hlinkClr xmlns:ahyp="http://schemas.microsoft.com/office/drawing/2018/hyperlinkcolor" val="tx"/>
+                    </a:ext>
+                  </a:extLst>
+                </a:hlinkClick>
+              </a:rPr>
+              <a:t>See why it was graded and classified</a:t>
+            </a:r>
+            <a:endParaRPr lang="en-US" sz="660" dirty="0"/>
+          </a:p>
+        </p:txBody>
+      </p:sp>
+      <p:sp>
+        <p:nvSpPr>
+          <p:cNvPr id="52" name="Shape 50"/>
+          <p:cNvSpPr/>
+          <p:nvPr/>
+        </p:nvSpPr>
+        <p:spPr>
+          <a:xfrm>
+            <a:off x="6483096" y="3310128"/>
+            <a:ext cx="1609344" cy="475488"/>
+          </a:xfrm>
+          <a:prstGeom prst="rect">
+            <a:avLst/>
+          </a:prstGeom>
+          <a:solidFill>
+            <a:srgbClr val="FFFFFF"/>
+          </a:solidFill>
+          <a:ln w="9525">
+            <a:solidFill>
+              <a:srgbClr val="DDE0E3"/>
+            </a:solidFill>
+            <a:prstDash val="solid"/>
+          </a:ln>
+        </p:spPr>
+      </p:sp>
+      <p:sp>
+        <p:nvSpPr>
+          <p:cNvPr id="53" name="Shape 51"/>
+          <p:cNvSpPr/>
+          <p:nvPr/>
+        </p:nvSpPr>
+        <p:spPr>
+          <a:xfrm>
+            <a:off x="6483096" y="3310128"/>
+            <a:ext cx="32004" cy="475488"/>
+          </a:xfrm>
+          <a:prstGeom prst="rect">
+            <a:avLst/>
+          </a:prstGeom>
+          <a:solidFill>
+            <a:srgbClr val="C8621E"/>
+          </a:solidFill>
+          <a:ln w="12700">
+            <a:solidFill>
+              <a:srgbClr val="333333"/>
+            </a:solidFill>
+            <a:prstDash val="solid"/>
+          </a:ln>
+        </p:spPr>
+      </p:sp>
+      <p:sp>
+        <p:nvSpPr>
+          <p:cNvPr id="54" name="Text 52"/>
+          <p:cNvSpPr txBox="1"/>
+          <p:nvPr/>
+        </p:nvSpPr>
+        <p:spPr>
+          <a:xfrm>
+            <a:off x="6574536" y="3364992"/>
+            <a:ext cx="1481328" cy="384048"/>
+          </a:xfrm>
+          <a:prstGeom prst="rect">
+            <a:avLst/>
+          </a:prstGeom>
+          <a:noFill/>
+          <a:ln/>
+        </p:spPr>
+        <p:txBody>
+          <a:bodyPr wrap="square" lIns="0" tIns="0" rIns="0" bIns="0" rtlCol="0" anchor="t"/>
+          <a:lstStyle/>
+          <a:p>
+            <a:pPr indent="0" marL="0">
+              <a:lnSpc>
+                <a:spcPts val="980"/>
+              </a:lnSpc>
+              <a:buNone/>
+            </a:pPr>
+            <a:r>
+              <a:rPr lang="en-US" sz="660" b="1" dirty="0">
+                <a:solidFill>
+                  <a:srgbClr val="98A0A8"/>
+                </a:solidFill>
+                <a:latin typeface="Calibri" pitchFamily="34" charset="0"/>
+                <a:ea typeface="Calibri" pitchFamily="34" charset="-122"/>
+                <a:cs typeface="Calibri" pitchFamily="34" charset="-120"/>
+                <a:hlinkClick r:id="rId24" invalidUrl="" action="" tgtFrame="" tooltip="Footage states are honest" history="1" highlightClick="0" endSnd="0">
+                  <a:extLst>
+                    <a:ext uri="{A12FA001-AC4F-418D-AE19-62706E023703}">
+                      <ahyp:hlinkClr xmlns:ahyp="http://schemas.microsoft.com/office/drawing/2018/hyperlinkcolor" val="tx"/>
+                    </a:ext>
+                  </a:extLst>
+                </a:hlinkClick>
+              </a:rPr>
+              <a:t>US-007
+</a:t>
+            </a:r>
+            <a:endParaRPr lang="en-US" sz="660" dirty="0"/>
+          </a:p>
+          <a:p>
+            <a:pPr indent="0" marL="0">
+              <a:lnSpc>
+                <a:spcPts val="980"/>
+              </a:lnSpc>
+              <a:buNone/>
+            </a:pPr>
+            <a:r>
+              <a:rPr lang="en-US" sz="800" b="1" dirty="0">
+                <a:solidFill>
+                  <a:srgbClr val="2B3038"/>
+                </a:solidFill>
+                <a:latin typeface="Calibri" pitchFamily="34" charset="0"/>
+                <a:ea typeface="Calibri" pitchFamily="34" charset="-122"/>
+                <a:cs typeface="Calibri" pitchFamily="34" charset="-120"/>
+                <a:hlinkClick r:id="rId25" invalidUrl="" action="" tgtFrame="" tooltip="Footage states are honest" history="1" highlightClick="0" endSnd="0">
+                  <a:extLst>
+                    <a:ext uri="{A12FA001-AC4F-418D-AE19-62706E023703}">
+                      <ahyp:hlinkClr xmlns:ahyp="http://schemas.microsoft.com/office/drawing/2018/hyperlinkcolor" val="tx"/>
+                    </a:ext>
+                  </a:extLst>
+                </a:hlinkClick>
+              </a:rPr>
+              <a:t>Footage states are honest</a:t>
+            </a:r>
+            <a:endParaRPr lang="en-US" sz="660" dirty="0"/>
+          </a:p>
+        </p:txBody>
+      </p:sp>
+      <p:sp>
+        <p:nvSpPr>
+          <p:cNvPr id="55" name="Shape 53"/>
+          <p:cNvSpPr/>
+          <p:nvPr/>
+        </p:nvSpPr>
+        <p:spPr>
+          <a:xfrm>
+            <a:off x="6483096" y="3813048"/>
+            <a:ext cx="1609344" cy="475488"/>
+          </a:xfrm>
+          <a:prstGeom prst="rect">
+            <a:avLst/>
+          </a:prstGeom>
+          <a:solidFill>
+            <a:srgbClr val="FFFFFF"/>
+          </a:solidFill>
+          <a:ln w="9525">
+            <a:solidFill>
+              <a:srgbClr val="DDE0E3"/>
+            </a:solidFill>
+            <a:prstDash val="solid"/>
+          </a:ln>
+        </p:spPr>
+      </p:sp>
+      <p:sp>
+        <p:nvSpPr>
+          <p:cNvPr id="56" name="Shape 54"/>
+          <p:cNvSpPr/>
+          <p:nvPr/>
+        </p:nvSpPr>
+        <p:spPr>
+          <a:xfrm>
+            <a:off x="6483096" y="3813048"/>
+            <a:ext cx="32004" cy="475488"/>
+          </a:xfrm>
+          <a:prstGeom prst="rect">
+            <a:avLst/>
+          </a:prstGeom>
+          <a:solidFill>
+            <a:srgbClr val="C8621E"/>
+          </a:solidFill>
+          <a:ln w="12700">
+            <a:solidFill>
+              <a:srgbClr val="333333"/>
+            </a:solidFill>
+            <a:prstDash val="solid"/>
+          </a:ln>
+        </p:spPr>
+      </p:sp>
+      <p:sp>
+        <p:nvSpPr>
+          <p:cNvPr id="57" name="Text 55"/>
+          <p:cNvSpPr txBox="1"/>
+          <p:nvPr/>
+        </p:nvSpPr>
+        <p:spPr>
+          <a:xfrm>
+            <a:off x="6574536" y="3867912"/>
+            <a:ext cx="1481328" cy="384048"/>
+          </a:xfrm>
+          <a:prstGeom prst="rect">
+            <a:avLst/>
+          </a:prstGeom>
+          <a:noFill/>
+          <a:ln/>
+        </p:spPr>
+        <p:txBody>
+          <a:bodyPr wrap="square" lIns="0" tIns="0" rIns="0" bIns="0" rtlCol="0" anchor="t"/>
+          <a:lstStyle/>
+          <a:p>
+            <a:pPr indent="0" marL="0">
+              <a:lnSpc>
+                <a:spcPts val="980"/>
+              </a:lnSpc>
+              <a:buNone/>
+            </a:pPr>
+            <a:r>
+              <a:rPr lang="en-US" sz="660" b="1" dirty="0">
+                <a:solidFill>
+                  <a:srgbClr val="98A0A8"/>
+                </a:solidFill>
+                <a:latin typeface="Calibri" pitchFamily="34" charset="0"/>
+                <a:ea typeface="Calibri" pitchFamily="34" charset="-122"/>
+                <a:cs typeface="Calibri" pitchFamily="34" charset="-120"/>
+                <a:hlinkClick r:id="rId26" invalidUrl="" action="" tgtFrame="" tooltip="Resolve who was driving" history="1" highlightClick="0" endSnd="0">
+                  <a:extLst>
+                    <a:ext uri="{A12FA001-AC4F-418D-AE19-62706E023703}">
+                      <ahyp:hlinkClr xmlns:ahyp="http://schemas.microsoft.com/office/drawing/2018/hyperlinkcolor" val="tx"/>
+                    </a:ext>
+                  </a:extLst>
+                </a:hlinkClick>
+              </a:rPr>
+              <a:t>US-008
+</a:t>
+            </a:r>
+            <a:endParaRPr lang="en-US" sz="660" dirty="0"/>
+          </a:p>
+          <a:p>
+            <a:pPr indent="0" marL="0">
+              <a:lnSpc>
+                <a:spcPts val="980"/>
+              </a:lnSpc>
+              <a:buNone/>
+            </a:pPr>
+            <a:r>
+              <a:rPr lang="en-US" sz="800" b="1" dirty="0">
+                <a:solidFill>
+                  <a:srgbClr val="2B3038"/>
+                </a:solidFill>
+                <a:latin typeface="Calibri" pitchFamily="34" charset="0"/>
+                <a:ea typeface="Calibri" pitchFamily="34" charset="-122"/>
+                <a:cs typeface="Calibri" pitchFamily="34" charset="-120"/>
+                <a:hlinkClick r:id="rId27" invalidUrl="" action="" tgtFrame="" tooltip="Resolve who was driving" history="1" highlightClick="0" endSnd="0">
+                  <a:extLst>
+                    <a:ext uri="{A12FA001-AC4F-418D-AE19-62706E023703}">
+                      <ahyp:hlinkClr xmlns:ahyp="http://schemas.microsoft.com/office/drawing/2018/hyperlinkcolor" val="tx"/>
+                    </a:ext>
+                  </a:extLst>
+                </a:hlinkClick>
+              </a:rPr>
+              <a:t>Resolve who was driving</a:t>
+            </a:r>
+            <a:endParaRPr lang="en-US" sz="660" dirty="0"/>
+          </a:p>
+        </p:txBody>
+      </p:sp>
+      <p:sp>
+        <p:nvSpPr>
+          <p:cNvPr id="58" name="Shape 56"/>
+          <p:cNvSpPr/>
+          <p:nvPr/>
+        </p:nvSpPr>
+        <p:spPr>
+          <a:xfrm>
+            <a:off x="8156448" y="2304288"/>
+            <a:ext cx="1609344" cy="475488"/>
+          </a:xfrm>
+          <a:prstGeom prst="rect">
+            <a:avLst/>
+          </a:prstGeom>
+          <a:solidFill>
+            <a:srgbClr val="FFFFFF"/>
+          </a:solidFill>
+          <a:ln w="9525">
+            <a:solidFill>
+              <a:srgbClr val="DDE0E3"/>
+            </a:solidFill>
+            <a:prstDash val="solid"/>
+          </a:ln>
+        </p:spPr>
+      </p:sp>
+      <p:sp>
+        <p:nvSpPr>
+          <p:cNvPr id="59" name="Shape 57"/>
+          <p:cNvSpPr/>
+          <p:nvPr/>
+        </p:nvSpPr>
+        <p:spPr>
+          <a:xfrm>
+            <a:off x="8156448" y="2304288"/>
+            <a:ext cx="32004" cy="475488"/>
+          </a:xfrm>
+          <a:prstGeom prst="rect">
+            <a:avLst/>
+          </a:prstGeom>
+          <a:solidFill>
+            <a:srgbClr val="C8621E"/>
+          </a:solidFill>
+          <a:ln w="12700">
+            <a:solidFill>
+              <a:srgbClr val="333333"/>
+            </a:solidFill>
+            <a:prstDash val="solid"/>
+          </a:ln>
+        </p:spPr>
+      </p:sp>
+      <p:sp>
+        <p:nvSpPr>
+          <p:cNvPr id="60" name="Text 58"/>
+          <p:cNvSpPr txBox="1"/>
+          <p:nvPr/>
+        </p:nvSpPr>
+        <p:spPr>
+          <a:xfrm>
+            <a:off x="8247888" y="2359152"/>
+            <a:ext cx="1481328" cy="384048"/>
+          </a:xfrm>
+          <a:prstGeom prst="rect">
+            <a:avLst/>
+          </a:prstGeom>
+          <a:noFill/>
+          <a:ln/>
+        </p:spPr>
+        <p:txBody>
+          <a:bodyPr wrap="square" lIns="0" tIns="0" rIns="0" bIns="0" rtlCol="0" anchor="t"/>
+          <a:lstStyle/>
+          <a:p>
+            <a:pPr indent="0" marL="0">
+              <a:lnSpc>
+                <a:spcPts val="980"/>
+              </a:lnSpc>
+              <a:buNone/>
+            </a:pPr>
+            <a:r>
+              <a:rPr lang="en-US" sz="660" b="1" dirty="0">
+                <a:solidFill>
+                  <a:srgbClr val="98A0A8"/>
+                </a:solidFill>
+                <a:latin typeface="Calibri" pitchFamily="34" charset="0"/>
+                <a:ea typeface="Calibri" pitchFamily="34" charset="-122"/>
+                <a:cs typeface="Calibri" pitchFamily="34" charset="-120"/>
+                <a:hlinkClick r:id="rId28" invalidUrl="" action="" tgtFrame="" tooltip="Log a coaching conversation" history="1" highlightClick="0" endSnd="0">
+                  <a:extLst>
+                    <a:ext uri="{A12FA001-AC4F-418D-AE19-62706E023703}">
+                      <ahyp:hlinkClr xmlns:ahyp="http://schemas.microsoft.com/office/drawing/2018/hyperlinkcolor" val="tx"/>
+                    </a:ext>
+                  </a:extLst>
+                </a:hlinkClick>
+              </a:rPr>
+              <a:t>US-010
+</a:t>
+            </a:r>
+            <a:endParaRPr lang="en-US" sz="660" dirty="0"/>
+          </a:p>
+          <a:p>
+            <a:pPr indent="0" marL="0">
+              <a:lnSpc>
+                <a:spcPts val="980"/>
+              </a:lnSpc>
+              <a:buNone/>
+            </a:pPr>
+            <a:r>
+              <a:rPr lang="en-US" sz="800" b="1" dirty="0">
+                <a:solidFill>
+                  <a:srgbClr val="2B3038"/>
+                </a:solidFill>
+                <a:latin typeface="Calibri" pitchFamily="34" charset="0"/>
+                <a:ea typeface="Calibri" pitchFamily="34" charset="-122"/>
+                <a:cs typeface="Calibri" pitchFamily="34" charset="-120"/>
+                <a:hlinkClick r:id="rId29" invalidUrl="" action="" tgtFrame="" tooltip="Log a coaching conversation" history="1" highlightClick="0" endSnd="0">
+                  <a:extLst>
+                    <a:ext uri="{A12FA001-AC4F-418D-AE19-62706E023703}">
+                      <ahyp:hlinkClr xmlns:ahyp="http://schemas.microsoft.com/office/drawing/2018/hyperlinkcolor" val="tx"/>
+                    </a:ext>
+                  </a:extLst>
+                </a:hlinkClick>
+              </a:rPr>
+              <a:t>Log a coaching conversation</a:t>
+            </a:r>
+            <a:endParaRPr lang="en-US" sz="660" dirty="0"/>
+          </a:p>
+        </p:txBody>
+      </p:sp>
+      <p:sp>
+        <p:nvSpPr>
+          <p:cNvPr id="61" name="Shape 59"/>
+          <p:cNvSpPr/>
+          <p:nvPr/>
+        </p:nvSpPr>
+        <p:spPr>
+          <a:xfrm>
+            <a:off x="8156448" y="2807208"/>
+            <a:ext cx="1609344" cy="475488"/>
+          </a:xfrm>
+          <a:prstGeom prst="rect">
+            <a:avLst/>
+          </a:prstGeom>
+          <a:solidFill>
+            <a:srgbClr val="FFFFFF"/>
+          </a:solidFill>
+          <a:ln w="9525">
+            <a:solidFill>
+              <a:srgbClr val="DDE0E3"/>
+            </a:solidFill>
+            <a:prstDash val="solid"/>
+          </a:ln>
+        </p:spPr>
+      </p:sp>
+      <p:sp>
+        <p:nvSpPr>
+          <p:cNvPr id="62" name="Shape 60"/>
+          <p:cNvSpPr/>
+          <p:nvPr/>
+        </p:nvSpPr>
+        <p:spPr>
+          <a:xfrm>
+            <a:off x="8156448" y="2807208"/>
+            <a:ext cx="32004" cy="475488"/>
+          </a:xfrm>
+          <a:prstGeom prst="rect">
+            <a:avLst/>
+          </a:prstGeom>
+          <a:solidFill>
+            <a:srgbClr val="C8621E"/>
+          </a:solidFill>
+          <a:ln w="12700">
+            <a:solidFill>
+              <a:srgbClr val="333333"/>
+            </a:solidFill>
+            <a:prstDash val="solid"/>
+          </a:ln>
+        </p:spPr>
+      </p:sp>
+      <p:sp>
+        <p:nvSpPr>
+          <p:cNvPr id="63" name="Text 61"/>
+          <p:cNvSpPr txBox="1"/>
+          <p:nvPr/>
+        </p:nvSpPr>
+        <p:spPr>
+          <a:xfrm>
+            <a:off x="8247888" y="2862072"/>
+            <a:ext cx="1481328" cy="384048"/>
+          </a:xfrm>
+          <a:prstGeom prst="rect">
+            <a:avLst/>
+          </a:prstGeom>
+          <a:noFill/>
+          <a:ln/>
+        </p:spPr>
+        <p:txBody>
+          <a:bodyPr wrap="square" lIns="0" tIns="0" rIns="0" bIns="0" rtlCol="0" anchor="t"/>
+          <a:lstStyle/>
+          <a:p>
+            <a:pPr indent="0" marL="0">
+              <a:lnSpc>
+                <a:spcPts val="980"/>
+              </a:lnSpc>
+              <a:buNone/>
+            </a:pPr>
+            <a:r>
+              <a:rPr lang="en-US" sz="660" b="1" dirty="0">
+                <a:solidFill>
+                  <a:srgbClr val="98A0A8"/>
+                </a:solidFill>
+                <a:latin typeface="Calibri" pitchFamily="34" charset="0"/>
+                <a:ea typeface="Calibri" pitchFamily="34" charset="-122"/>
+                <a:cs typeface="Calibri" pitchFamily="34" charset="-120"/>
+                <a:hlinkClick r:id="rId30" invalidUrl="" action="" tgtFrame="" tooltip="Capture what the driver said" history="1" highlightClick="0" endSnd="0">
+                  <a:extLst>
+                    <a:ext uri="{A12FA001-AC4F-418D-AE19-62706E023703}">
+                      <ahyp:hlinkClr xmlns:ahyp="http://schemas.microsoft.com/office/drawing/2018/hyperlinkcolor" val="tx"/>
+                    </a:ext>
+                  </a:extLst>
+                </a:hlinkClick>
+              </a:rPr>
+              <a:t>US-011
+</a:t>
+            </a:r>
+            <a:endParaRPr lang="en-US" sz="660" dirty="0"/>
+          </a:p>
+          <a:p>
+            <a:pPr indent="0" marL="0">
+              <a:lnSpc>
+                <a:spcPts val="980"/>
+              </a:lnSpc>
+              <a:buNone/>
+            </a:pPr>
+            <a:r>
+              <a:rPr lang="en-US" sz="800" b="1" dirty="0">
+                <a:solidFill>
+                  <a:srgbClr val="2B3038"/>
+                </a:solidFill>
+                <a:latin typeface="Calibri" pitchFamily="34" charset="0"/>
+                <a:ea typeface="Calibri" pitchFamily="34" charset="-122"/>
+                <a:cs typeface="Calibri" pitchFamily="34" charset="-120"/>
+                <a:hlinkClick r:id="rId31" invalidUrl="" action="" tgtFrame="" tooltip="Capture what the driver said" history="1" highlightClick="0" endSnd="0">
+                  <a:extLst>
+                    <a:ext uri="{A12FA001-AC4F-418D-AE19-62706E023703}">
+                      <ahyp:hlinkClr xmlns:ahyp="http://schemas.microsoft.com/office/drawing/2018/hyperlinkcolor" val="tx"/>
+                    </a:ext>
+                  </a:extLst>
+                </a:hlinkClick>
+              </a:rPr>
+              <a:t>Capture what the driver said</a:t>
+            </a:r>
+            <a:endParaRPr lang="en-US" sz="660" dirty="0"/>
+          </a:p>
+        </p:txBody>
+      </p:sp>
+      <p:sp>
+        <p:nvSpPr>
+          <p:cNvPr id="64" name="Shape 62"/>
+          <p:cNvSpPr/>
+          <p:nvPr/>
+        </p:nvSpPr>
+        <p:spPr>
+          <a:xfrm>
+            <a:off x="8156448" y="3310128"/>
+            <a:ext cx="1609344" cy="475488"/>
+          </a:xfrm>
+          <a:prstGeom prst="rect">
+            <a:avLst/>
+          </a:prstGeom>
+          <a:solidFill>
+            <a:srgbClr val="FFFFFF"/>
+          </a:solidFill>
+          <a:ln w="9525">
+            <a:solidFill>
+              <a:srgbClr val="DDE0E3"/>
+            </a:solidFill>
+            <a:prstDash val="solid"/>
+          </a:ln>
+        </p:spPr>
+      </p:sp>
+      <p:sp>
+        <p:nvSpPr>
+          <p:cNvPr id="65" name="Shape 63"/>
+          <p:cNvSpPr/>
+          <p:nvPr/>
+        </p:nvSpPr>
+        <p:spPr>
+          <a:xfrm>
+            <a:off x="8156448" y="3310128"/>
+            <a:ext cx="32004" cy="475488"/>
+          </a:xfrm>
+          <a:prstGeom prst="rect">
+            <a:avLst/>
+          </a:prstGeom>
+          <a:solidFill>
+            <a:srgbClr val="C8621E"/>
+          </a:solidFill>
+          <a:ln w="12700">
+            <a:solidFill>
+              <a:srgbClr val="333333"/>
+            </a:solidFill>
+            <a:prstDash val="solid"/>
+          </a:ln>
+        </p:spPr>
+      </p:sp>
+      <p:sp>
+        <p:nvSpPr>
+          <p:cNvPr id="66" name="Text 64"/>
+          <p:cNvSpPr txBox="1"/>
+          <p:nvPr/>
+        </p:nvSpPr>
+        <p:spPr>
+          <a:xfrm>
+            <a:off x="8247888" y="3364992"/>
+            <a:ext cx="1481328" cy="384048"/>
+          </a:xfrm>
+          <a:prstGeom prst="rect">
+            <a:avLst/>
+          </a:prstGeom>
+          <a:noFill/>
+          <a:ln/>
+        </p:spPr>
+        <p:txBody>
+          <a:bodyPr wrap="square" lIns="0" tIns="0" rIns="0" bIns="0" rtlCol="0" anchor="t"/>
+          <a:lstStyle/>
+          <a:p>
+            <a:pPr indent="0" marL="0">
+              <a:lnSpc>
+                <a:spcPts val="980"/>
+              </a:lnSpc>
+              <a:buNone/>
+            </a:pPr>
+            <a:r>
+              <a:rPr lang="en-US" sz="660" b="1" dirty="0">
+                <a:solidFill>
+                  <a:srgbClr val="98A0A8"/>
+                </a:solidFill>
+                <a:latin typeface="Calibri" pitchFamily="34" charset="0"/>
+                <a:ea typeface="Calibri" pitchFamily="34" charset="-122"/>
+                <a:cs typeface="Calibri" pitchFamily="34" charset="-120"/>
+                <a:hlinkClick r:id="rId32" invalidUrl="" action="" tgtFrame="" tooltip="Confirm recognition" history="1" highlightClick="0" endSnd="0">
+                  <a:extLst>
+                    <a:ext uri="{A12FA001-AC4F-418D-AE19-62706E023703}">
+                      <ahyp:hlinkClr xmlns:ahyp="http://schemas.microsoft.com/office/drawing/2018/hyperlinkcolor" val="tx"/>
+                    </a:ext>
+                  </a:extLst>
+                </a:hlinkClick>
+              </a:rPr>
+              <a:t>US-012
+</a:t>
+            </a:r>
+            <a:endParaRPr lang="en-US" sz="660" dirty="0"/>
+          </a:p>
+          <a:p>
+            <a:pPr indent="0" marL="0">
+              <a:lnSpc>
+                <a:spcPts val="980"/>
+              </a:lnSpc>
+              <a:buNone/>
+            </a:pPr>
+            <a:r>
+              <a:rPr lang="en-US" sz="800" b="1" dirty="0">
+                <a:solidFill>
+                  <a:srgbClr val="2B3038"/>
+                </a:solidFill>
+                <a:latin typeface="Calibri" pitchFamily="34" charset="0"/>
+                <a:ea typeface="Calibri" pitchFamily="34" charset="-122"/>
+                <a:cs typeface="Calibri" pitchFamily="34" charset="-120"/>
+                <a:hlinkClick r:id="rId33" invalidUrl="" action="" tgtFrame="" tooltip="Confirm recognition" history="1" highlightClick="0" endSnd="0">
+                  <a:extLst>
+                    <a:ext uri="{A12FA001-AC4F-418D-AE19-62706E023703}">
+                      <ahyp:hlinkClr xmlns:ahyp="http://schemas.microsoft.com/office/drawing/2018/hyperlinkcolor" val="tx"/>
+                    </a:ext>
+                  </a:extLst>
+                </a:hlinkClick>
+              </a:rPr>
+              <a:t>Confirm recognition</a:t>
+            </a:r>
+            <a:endParaRPr lang="en-US" sz="660" dirty="0"/>
+          </a:p>
+        </p:txBody>
+      </p:sp>
+      <p:sp>
+        <p:nvSpPr>
+          <p:cNvPr id="67" name="Shape 65"/>
+          <p:cNvSpPr/>
+          <p:nvPr/>
+        </p:nvSpPr>
+        <p:spPr>
+          <a:xfrm>
+            <a:off x="8156448" y="3813048"/>
+            <a:ext cx="1609344" cy="475488"/>
+          </a:xfrm>
+          <a:prstGeom prst="rect">
+            <a:avLst/>
+          </a:prstGeom>
+          <a:solidFill>
+            <a:srgbClr val="FFFFFF"/>
+          </a:solidFill>
+          <a:ln w="9525">
+            <a:solidFill>
+              <a:srgbClr val="DDE0E3"/>
+            </a:solidFill>
+            <a:prstDash val="solid"/>
+          </a:ln>
+        </p:spPr>
+      </p:sp>
+      <p:sp>
+        <p:nvSpPr>
+          <p:cNvPr id="68" name="Shape 66"/>
+          <p:cNvSpPr/>
+          <p:nvPr/>
+        </p:nvSpPr>
+        <p:spPr>
+          <a:xfrm>
+            <a:off x="8156448" y="3813048"/>
+            <a:ext cx="32004" cy="475488"/>
+          </a:xfrm>
+          <a:prstGeom prst="rect">
+            <a:avLst/>
+          </a:prstGeom>
+          <a:solidFill>
+            <a:srgbClr val="C8621E"/>
+          </a:solidFill>
+          <a:ln w="12700">
+            <a:solidFill>
+              <a:srgbClr val="333333"/>
+            </a:solidFill>
+            <a:prstDash val="solid"/>
+          </a:ln>
+        </p:spPr>
+      </p:sp>
+      <p:sp>
+        <p:nvSpPr>
+          <p:cNvPr id="69" name="Text 67"/>
+          <p:cNvSpPr txBox="1"/>
+          <p:nvPr/>
+        </p:nvSpPr>
+        <p:spPr>
+          <a:xfrm>
+            <a:off x="8247888" y="3867912"/>
+            <a:ext cx="1481328" cy="384048"/>
+          </a:xfrm>
+          <a:prstGeom prst="rect">
+            <a:avLst/>
+          </a:prstGeom>
+          <a:noFill/>
+          <a:ln/>
+        </p:spPr>
+        <p:txBody>
+          <a:bodyPr wrap="square" lIns="0" tIns="0" rIns="0" bIns="0" rtlCol="0" anchor="t"/>
+          <a:lstStyle/>
+          <a:p>
+            <a:pPr indent="0" marL="0">
+              <a:lnSpc>
+                <a:spcPts val="980"/>
+              </a:lnSpc>
+              <a:buNone/>
+            </a:pPr>
+            <a:r>
+              <a:rPr lang="en-US" sz="660" b="1" dirty="0">
+                <a:solidFill>
+                  <a:srgbClr val="98A0A8"/>
+                </a:solidFill>
+                <a:latin typeface="Calibri" pitchFamily="34" charset="0"/>
+                <a:ea typeface="Calibri" pitchFamily="34" charset="-122"/>
+                <a:cs typeface="Calibri" pitchFamily="34" charset="-120"/>
+                <a:hlinkClick r:id="rId34" invalidUrl="" action="" tgtFrame="" tooltip="Send a medium group to the driver" history="1" highlightClick="0" endSnd="0">
+                  <a:extLst>
+                    <a:ext uri="{A12FA001-AC4F-418D-AE19-62706E023703}">
+                      <ahyp:hlinkClr xmlns:ahyp="http://schemas.microsoft.com/office/drawing/2018/hyperlinkcolor" val="tx"/>
+                    </a:ext>
+                  </a:extLst>
+                </a:hlinkClick>
+              </a:rPr>
+              <a:t>US-013
+</a:t>
+            </a:r>
+            <a:endParaRPr lang="en-US" sz="660" dirty="0"/>
+          </a:p>
+          <a:p>
+            <a:pPr indent="0" marL="0">
+              <a:lnSpc>
+                <a:spcPts val="980"/>
+              </a:lnSpc>
+              <a:buNone/>
+            </a:pPr>
+            <a:r>
+              <a:rPr lang="en-US" sz="800" b="1" dirty="0">
+                <a:solidFill>
+                  <a:srgbClr val="2B3038"/>
+                </a:solidFill>
+                <a:latin typeface="Calibri" pitchFamily="34" charset="0"/>
+                <a:ea typeface="Calibri" pitchFamily="34" charset="-122"/>
+                <a:cs typeface="Calibri" pitchFamily="34" charset="-120"/>
+                <a:hlinkClick r:id="rId35" invalidUrl="" action="" tgtFrame="" tooltip="Send a medium group to the driver" history="1" highlightClick="0" endSnd="0">
+                  <a:extLst>
+                    <a:ext uri="{A12FA001-AC4F-418D-AE19-62706E023703}">
+                      <ahyp:hlinkClr xmlns:ahyp="http://schemas.microsoft.com/office/drawing/2018/hyperlinkcolor" val="tx"/>
+                    </a:ext>
+                  </a:extLst>
+                </a:hlinkClick>
+              </a:rPr>
+              <a:t>Send a medium group to the driver</a:t>
+            </a:r>
+            <a:endParaRPr lang="en-US" sz="660" dirty="0"/>
+          </a:p>
+        </p:txBody>
+      </p:sp>
+      <p:sp>
+        <p:nvSpPr>
+          <p:cNvPr id="70" name="Shape 68"/>
+          <p:cNvSpPr/>
+          <p:nvPr/>
+        </p:nvSpPr>
+        <p:spPr>
+          <a:xfrm>
+            <a:off x="9829800" y="2304288"/>
+            <a:ext cx="1609344" cy="475488"/>
+          </a:xfrm>
+          <a:prstGeom prst="rect">
+            <a:avLst/>
+          </a:prstGeom>
+          <a:solidFill>
+            <a:srgbClr val="FFFFFF"/>
+          </a:solidFill>
+          <a:ln w="9525">
+            <a:solidFill>
+              <a:srgbClr val="DDE0E3"/>
+            </a:solidFill>
+            <a:prstDash val="solid"/>
+          </a:ln>
+        </p:spPr>
+      </p:sp>
+      <p:sp>
+        <p:nvSpPr>
+          <p:cNvPr id="71" name="Shape 69"/>
+          <p:cNvSpPr/>
+          <p:nvPr/>
+        </p:nvSpPr>
+        <p:spPr>
+          <a:xfrm>
+            <a:off x="9829800" y="2304288"/>
+            <a:ext cx="32004" cy="475488"/>
+          </a:xfrm>
+          <a:prstGeom prst="rect">
+            <a:avLst/>
+          </a:prstGeom>
+          <a:solidFill>
+            <a:srgbClr val="C8621E"/>
+          </a:solidFill>
+          <a:ln w="12700">
+            <a:solidFill>
+              <a:srgbClr val="333333"/>
+            </a:solidFill>
+            <a:prstDash val="solid"/>
+          </a:ln>
+        </p:spPr>
+      </p:sp>
+      <p:sp>
+        <p:nvSpPr>
+          <p:cNvPr id="72" name="Text 70"/>
+          <p:cNvSpPr txBox="1"/>
+          <p:nvPr/>
+        </p:nvSpPr>
+        <p:spPr>
+          <a:xfrm>
+            <a:off x="9921240" y="2359152"/>
+            <a:ext cx="1481328" cy="384048"/>
+          </a:xfrm>
+          <a:prstGeom prst="rect">
+            <a:avLst/>
+          </a:prstGeom>
+          <a:noFill/>
+          <a:ln/>
+        </p:spPr>
+        <p:txBody>
+          <a:bodyPr wrap="square" lIns="0" tIns="0" rIns="0" bIns="0" rtlCol="0" anchor="t"/>
+          <a:lstStyle/>
+          <a:p>
+            <a:pPr indent="0" marL="0">
+              <a:lnSpc>
+                <a:spcPts val="980"/>
+              </a:lnSpc>
+              <a:buNone/>
+            </a:pPr>
+            <a:r>
+              <a:rPr lang="en-US" sz="660" b="1" dirty="0">
+                <a:solidFill>
+                  <a:srgbClr val="98A0A8"/>
+                </a:solidFill>
+                <a:latin typeface="Calibri" pitchFamily="34" charset="0"/>
+                <a:ea typeface="Calibri" pitchFamily="34" charset="-122"/>
+                <a:cs typeface="Calibri" pitchFamily="34" charset="-120"/>
+                <a:hlinkClick r:id="rId36" invalidUrl="" action="" tgtFrame="" tooltip="A driver record showing both sides" history="1" highlightClick="0" endSnd="0">
+                  <a:extLst>
+                    <a:ext uri="{A12FA001-AC4F-418D-AE19-62706E023703}">
+                      <ahyp:hlinkClr xmlns:ahyp="http://schemas.microsoft.com/office/drawing/2018/hyperlinkcolor" val="tx"/>
+                    </a:ext>
+                  </a:extLst>
+                </a:hlinkClick>
+              </a:rPr>
+              <a:t>US-014
+</a:t>
+            </a:r>
+            <a:endParaRPr lang="en-US" sz="660" dirty="0"/>
+          </a:p>
+          <a:p>
+            <a:pPr indent="0" marL="0">
+              <a:lnSpc>
+                <a:spcPts val="980"/>
+              </a:lnSpc>
+              <a:buNone/>
+            </a:pPr>
+            <a:r>
+              <a:rPr lang="en-US" sz="800" b="1" dirty="0">
+                <a:solidFill>
+                  <a:srgbClr val="2B3038"/>
+                </a:solidFill>
+                <a:latin typeface="Calibri" pitchFamily="34" charset="0"/>
+                <a:ea typeface="Calibri" pitchFamily="34" charset="-122"/>
+                <a:cs typeface="Calibri" pitchFamily="34" charset="-120"/>
+                <a:hlinkClick r:id="rId37" invalidUrl="" action="" tgtFrame="" tooltip="A driver record showing both sides" history="1" highlightClick="0" endSnd="0">
+                  <a:extLst>
+                    <a:ext uri="{A12FA001-AC4F-418D-AE19-62706E023703}">
+                      <ahyp:hlinkClr xmlns:ahyp="http://schemas.microsoft.com/office/drawing/2018/hyperlinkcolor" val="tx"/>
+                    </a:ext>
+                  </a:extLst>
+                </a:hlinkClick>
+              </a:rPr>
+              <a:t>A driver record showing both sides</a:t>
+            </a:r>
+            <a:endParaRPr lang="en-US" sz="660" dirty="0"/>
+          </a:p>
+        </p:txBody>
+      </p:sp>
+      <p:sp>
+        <p:nvSpPr>
+          <p:cNvPr id="73" name="Shape 71"/>
+          <p:cNvSpPr/>
+          <p:nvPr/>
+        </p:nvSpPr>
+        <p:spPr>
+          <a:xfrm>
+            <a:off x="658368" y="4398264"/>
+            <a:ext cx="10844784" cy="603504"/>
+          </a:xfrm>
+          <a:prstGeom prst="rect">
+            <a:avLst/>
+          </a:prstGeom>
+          <a:solidFill>
+            <a:srgbClr val="F6F7F8"/>
+          </a:solidFill>
+          <a:ln w="9525">
+            <a:solidFill>
+              <a:srgbClr val="F6F7F8"/>
+            </a:solidFill>
+            <a:prstDash val="solid"/>
+          </a:ln>
+        </p:spPr>
+      </p:sp>
+      <p:sp>
+        <p:nvSpPr>
+          <p:cNvPr id="74" name="Text 72"/>
+          <p:cNvSpPr txBox="1"/>
+          <p:nvPr/>
+        </p:nvSpPr>
+        <p:spPr>
+          <a:xfrm>
+            <a:off x="658368" y="4462272"/>
+            <a:ext cx="713232" cy="219456"/>
+          </a:xfrm>
+          <a:prstGeom prst="rect">
+            <a:avLst/>
+          </a:prstGeom>
+          <a:noFill/>
+          <a:ln/>
+        </p:spPr>
+        <p:txBody>
+          <a:bodyPr wrap="square" lIns="0" tIns="0" rIns="0" bIns="0" rtlCol="0" anchor="t"/>
+          <a:lstStyle/>
+          <a:p>
+            <a:pPr indent="0" marL="0">
+              <a:buNone/>
+            </a:pPr>
+            <a:r>
+              <a:rPr lang="en-US" sz="1100" b="1" dirty="0">
+                <a:solidFill>
+                  <a:srgbClr val="2B3038"/>
+                </a:solidFill>
+                <a:latin typeface="Cambria" pitchFamily="34" charset="0"/>
+                <a:ea typeface="Cambria" pitchFamily="34" charset="-122"/>
+                <a:cs typeface="Cambria" pitchFamily="34" charset="-120"/>
+              </a:rPr>
+              <a:t>v1.1</a:t>
+            </a:r>
+            <a:endParaRPr lang="en-US" sz="1100" dirty="0"/>
+          </a:p>
+        </p:txBody>
+      </p:sp>
+      <p:sp>
+        <p:nvSpPr>
+          <p:cNvPr id="75" name="Text 73"/>
+          <p:cNvSpPr txBox="1"/>
+          <p:nvPr/>
+        </p:nvSpPr>
+        <p:spPr>
+          <a:xfrm>
+            <a:off x="658368" y="4672584"/>
+            <a:ext cx="749808" cy="402336"/>
+          </a:xfrm>
+          <a:prstGeom prst="rect">
+            <a:avLst/>
+          </a:prstGeom>
+          <a:noFill/>
+          <a:ln/>
+        </p:spPr>
+        <p:txBody>
+          <a:bodyPr wrap="square" lIns="0" tIns="0" rIns="0" bIns="0" rtlCol="0" anchor="t"/>
+          <a:lstStyle/>
+          <a:p>
+            <a:pPr indent="0" marL="0">
+              <a:lnSpc>
+                <a:spcPts val="860"/>
+              </a:lnSpc>
+              <a:buNone/>
+            </a:pPr>
+            <a:r>
+              <a:rPr lang="en-US" sz="700" dirty="0">
+                <a:solidFill>
+                  <a:srgbClr val="98A0A8"/>
+                </a:solidFill>
+                <a:latin typeface="Calibri" pitchFamily="34" charset="0"/>
+                <a:ea typeface="Calibri" pitchFamily="34" charset="-122"/>
+                <a:cs typeface="Calibri" pitchFamily="34" charset="-120"/>
+              </a:rPr>
+              <a:t>opens at four</a:t>
+            </a:r>
+            <a:endParaRPr lang="en-US" sz="700" dirty="0"/>
+          </a:p>
+          <a:p>
+            <a:pPr indent="0" marL="0">
+              <a:lnSpc>
+                <a:spcPts val="860"/>
+              </a:lnSpc>
+              <a:buNone/>
+            </a:pPr>
+            <a:r>
+              <a:rPr lang="en-US" sz="700" dirty="0">
+                <a:solidFill>
+                  <a:srgbClr val="98A0A8"/>
+                </a:solidFill>
+                <a:latin typeface="Calibri" pitchFamily="34" charset="0"/>
+                <a:ea typeface="Calibri" pitchFamily="34" charset="-122"/>
+                <a:cs typeface="Calibri" pitchFamily="34" charset="-120"/>
+              </a:rPr>
+              <a:t>weeks live</a:t>
+            </a:r>
+            <a:endParaRPr lang="en-US" sz="700" dirty="0"/>
+          </a:p>
+        </p:txBody>
+      </p:sp>
+      <p:sp>
+        <p:nvSpPr>
+          <p:cNvPr id="76" name="Text 74"/>
+          <p:cNvSpPr txBox="1"/>
+          <p:nvPr/>
+        </p:nvSpPr>
+        <p:spPr>
+          <a:xfrm>
+            <a:off x="1554480" y="4517136"/>
+            <a:ext cx="1609344" cy="182880"/>
+          </a:xfrm>
+          <a:prstGeom prst="rect">
+            <a:avLst/>
+          </a:prstGeom>
+          <a:noFill/>
+          <a:ln/>
+        </p:spPr>
+        <p:txBody>
+          <a:bodyPr wrap="square" lIns="0" tIns="0" rIns="0" bIns="0" rtlCol="0" anchor="t"/>
+          <a:lstStyle/>
+          <a:p>
+            <a:pPr indent="0" marL="0">
+              <a:buNone/>
+            </a:pPr>
+            <a:r>
+              <a:rPr lang="en-US" sz="900" dirty="0">
+                <a:solidFill>
+                  <a:srgbClr val="CDD2D7"/>
+                </a:solidFill>
+                <a:latin typeface="Calibri" pitchFamily="34" charset="0"/>
+                <a:ea typeface="Calibri" pitchFamily="34" charset="-122"/>
+                <a:cs typeface="Calibri" pitchFamily="34" charset="-120"/>
+              </a:rPr>
+              <a:t>-</a:t>
+            </a:r>
+            <a:endParaRPr lang="en-US" sz="900" dirty="0"/>
+          </a:p>
+        </p:txBody>
+      </p:sp>
+      <p:sp>
+        <p:nvSpPr>
+          <p:cNvPr id="77" name="Text 75"/>
+          <p:cNvSpPr txBox="1"/>
+          <p:nvPr/>
+        </p:nvSpPr>
+        <p:spPr>
+          <a:xfrm>
+            <a:off x="3227832" y="4517136"/>
+            <a:ext cx="1609344" cy="182880"/>
+          </a:xfrm>
+          <a:prstGeom prst="rect">
+            <a:avLst/>
+          </a:prstGeom>
+          <a:noFill/>
+          <a:ln/>
+        </p:spPr>
+        <p:txBody>
+          <a:bodyPr wrap="square" lIns="0" tIns="0" rIns="0" bIns="0" rtlCol="0" anchor="t"/>
+          <a:lstStyle/>
+          <a:p>
+            <a:pPr indent="0" marL="0">
+              <a:buNone/>
+            </a:pPr>
+            <a:r>
+              <a:rPr lang="en-US" sz="900" dirty="0">
+                <a:solidFill>
+                  <a:srgbClr val="CDD2D7"/>
+                </a:solidFill>
+                <a:latin typeface="Calibri" pitchFamily="34" charset="0"/>
+                <a:ea typeface="Calibri" pitchFamily="34" charset="-122"/>
+                <a:cs typeface="Calibri" pitchFamily="34" charset="-120"/>
+              </a:rPr>
+              <a:t>-</a:t>
+            </a:r>
+            <a:endParaRPr lang="en-US" sz="900" dirty="0"/>
+          </a:p>
+        </p:txBody>
+      </p:sp>
+      <p:sp>
+        <p:nvSpPr>
+          <p:cNvPr id="78" name="Text 76"/>
+          <p:cNvSpPr txBox="1"/>
+          <p:nvPr/>
+        </p:nvSpPr>
+        <p:spPr>
+          <a:xfrm>
+            <a:off x="4901184" y="4517136"/>
+            <a:ext cx="1609344" cy="182880"/>
+          </a:xfrm>
+          <a:prstGeom prst="rect">
+            <a:avLst/>
+          </a:prstGeom>
+          <a:noFill/>
+          <a:ln/>
+        </p:spPr>
+        <p:txBody>
+          <a:bodyPr wrap="square" lIns="0" tIns="0" rIns="0" bIns="0" rtlCol="0" anchor="t"/>
+          <a:lstStyle/>
+          <a:p>
+            <a:pPr indent="0" marL="0">
+              <a:buNone/>
+            </a:pPr>
+            <a:r>
+              <a:rPr lang="en-US" sz="900" dirty="0">
+                <a:solidFill>
+                  <a:srgbClr val="CDD2D7"/>
+                </a:solidFill>
+                <a:latin typeface="Calibri" pitchFamily="34" charset="0"/>
+                <a:ea typeface="Calibri" pitchFamily="34" charset="-122"/>
+                <a:cs typeface="Calibri" pitchFamily="34" charset="-120"/>
+              </a:rPr>
+              <a:t>-</a:t>
+            </a:r>
+            <a:endParaRPr lang="en-US" sz="900" dirty="0"/>
+          </a:p>
+        </p:txBody>
+      </p:sp>
+      <p:sp>
+        <p:nvSpPr>
+          <p:cNvPr id="79" name="Text 77"/>
+          <p:cNvSpPr txBox="1"/>
+          <p:nvPr/>
+        </p:nvSpPr>
+        <p:spPr>
+          <a:xfrm>
+            <a:off x="6574536" y="4517136"/>
+            <a:ext cx="1609344" cy="182880"/>
+          </a:xfrm>
+          <a:prstGeom prst="rect">
+            <a:avLst/>
+          </a:prstGeom>
+          <a:noFill/>
+          <a:ln/>
+        </p:spPr>
+        <p:txBody>
+          <a:bodyPr wrap="square" lIns="0" tIns="0" rIns="0" bIns="0" rtlCol="0" anchor="t"/>
+          <a:lstStyle/>
+          <a:p>
+            <a:pPr indent="0" marL="0">
+              <a:buNone/>
+            </a:pPr>
+            <a:r>
+              <a:rPr lang="en-US" sz="900" dirty="0">
+                <a:solidFill>
+                  <a:srgbClr val="CDD2D7"/>
+                </a:solidFill>
+                <a:latin typeface="Calibri" pitchFamily="34" charset="0"/>
+                <a:ea typeface="Calibri" pitchFamily="34" charset="-122"/>
+                <a:cs typeface="Calibri" pitchFamily="34" charset="-120"/>
+              </a:rPr>
+              <a:t>-</a:t>
+            </a:r>
+            <a:endParaRPr lang="en-US" sz="900" dirty="0"/>
+          </a:p>
+        </p:txBody>
+      </p:sp>
+      <p:sp>
+        <p:nvSpPr>
+          <p:cNvPr id="80" name="Text 78"/>
+          <p:cNvSpPr txBox="1"/>
+          <p:nvPr/>
+        </p:nvSpPr>
+        <p:spPr>
+          <a:xfrm>
+            <a:off x="8247888" y="4517136"/>
+            <a:ext cx="1609344" cy="182880"/>
+          </a:xfrm>
+          <a:prstGeom prst="rect">
+            <a:avLst/>
+          </a:prstGeom>
+          <a:noFill/>
+          <a:ln/>
+        </p:spPr>
+        <p:txBody>
+          <a:bodyPr wrap="square" lIns="0" tIns="0" rIns="0" bIns="0" rtlCol="0" anchor="t"/>
+          <a:lstStyle/>
+          <a:p>
+            <a:pPr indent="0" marL="0">
+              <a:buNone/>
+            </a:pPr>
+            <a:r>
+              <a:rPr lang="en-US" sz="900" dirty="0">
+                <a:solidFill>
+                  <a:srgbClr val="CDD2D7"/>
+                </a:solidFill>
+                <a:latin typeface="Calibri" pitchFamily="34" charset="0"/>
+                <a:ea typeface="Calibri" pitchFamily="34" charset="-122"/>
+                <a:cs typeface="Calibri" pitchFamily="34" charset="-120"/>
+              </a:rPr>
+              <a:t>-</a:t>
+            </a:r>
+            <a:endParaRPr lang="en-US" sz="900" dirty="0"/>
+          </a:p>
+        </p:txBody>
+      </p:sp>
+      <p:sp>
+        <p:nvSpPr>
+          <p:cNvPr id="81" name="Shape 79"/>
+          <p:cNvSpPr/>
+          <p:nvPr/>
+        </p:nvSpPr>
+        <p:spPr>
+          <a:xfrm>
+            <a:off x="9829800" y="4462272"/>
+            <a:ext cx="1609344" cy="475488"/>
+          </a:xfrm>
+          <a:prstGeom prst="rect">
+            <a:avLst/>
+          </a:prstGeom>
+          <a:solidFill>
+            <a:srgbClr val="FFFFFF"/>
+          </a:solidFill>
+          <a:ln w="9525">
+            <a:solidFill>
+              <a:srgbClr val="DDE0E3"/>
+            </a:solidFill>
+            <a:prstDash val="solid"/>
+          </a:ln>
+        </p:spPr>
+      </p:sp>
+      <p:sp>
+        <p:nvSpPr>
+          <p:cNvPr id="82" name="Shape 80"/>
+          <p:cNvSpPr/>
+          <p:nvPr/>
+        </p:nvSpPr>
+        <p:spPr>
+          <a:xfrm>
+            <a:off x="9829800" y="4462272"/>
+            <a:ext cx="32004" cy="475488"/>
+          </a:xfrm>
+          <a:prstGeom prst="rect">
+            <a:avLst/>
+          </a:prstGeom>
+          <a:solidFill>
+            <a:srgbClr val="C8621E"/>
+          </a:solidFill>
+          <a:ln w="12700">
+            <a:solidFill>
+              <a:srgbClr val="333333"/>
+            </a:solidFill>
+            <a:prstDash val="solid"/>
+          </a:ln>
+        </p:spPr>
+      </p:sp>
+      <p:sp>
+        <p:nvSpPr>
+          <p:cNvPr id="83" name="Text 81"/>
+          <p:cNvSpPr txBox="1"/>
+          <p:nvPr/>
+        </p:nvSpPr>
+        <p:spPr>
+          <a:xfrm>
+            <a:off x="9921240" y="4517136"/>
+            <a:ext cx="1481328" cy="384048"/>
+          </a:xfrm>
+          <a:prstGeom prst="rect">
+            <a:avLst/>
+          </a:prstGeom>
+          <a:noFill/>
+          <a:ln/>
+        </p:spPr>
+        <p:txBody>
+          <a:bodyPr wrap="square" lIns="0" tIns="0" rIns="0" bIns="0" rtlCol="0" anchor="t"/>
+          <a:lstStyle/>
+          <a:p>
+            <a:pPr indent="0" marL="0">
+              <a:lnSpc>
+                <a:spcPts val="980"/>
+              </a:lnSpc>
+              <a:buNone/>
+            </a:pPr>
+            <a:r>
+              <a:rPr lang="en-US" sz="660" b="1" dirty="0">
+                <a:solidFill>
+                  <a:srgbClr val="98A0A8"/>
+                </a:solidFill>
+                <a:latin typeface="Calibri" pitchFamily="34" charset="0"/>
+                <a:ea typeface="Calibri" pitchFamily="34" charset="-122"/>
+                <a:cs typeface="Calibri" pitchFamily="34" charset="-120"/>
+                <a:hlinkClick r:id="rId38" invalidUrl="" action="" tgtFrame="" tooltip="A fleet view that does not overstate" history="1" highlightClick="0" endSnd="0">
+                  <a:extLst>
+                    <a:ext uri="{A12FA001-AC4F-418D-AE19-62706E023703}">
+                      <ahyp:hlinkClr xmlns:ahyp="http://schemas.microsoft.com/office/drawing/2018/hyperlinkcolor" val="tx"/>
+                    </a:ext>
+                  </a:extLst>
+                </a:hlinkClick>
+              </a:rPr>
+              <a:t>US-015 · J-24
+</a:t>
+            </a:r>
+            <a:endParaRPr lang="en-US" sz="660" dirty="0"/>
+          </a:p>
+          <a:p>
+            <a:pPr indent="0" marL="0">
+              <a:lnSpc>
+                <a:spcPts val="980"/>
+              </a:lnSpc>
+              <a:buNone/>
+            </a:pPr>
+            <a:r>
+              <a:rPr lang="en-US" sz="800" b="1" dirty="0">
+                <a:solidFill>
+                  <a:srgbClr val="2B3038"/>
+                </a:solidFill>
+                <a:latin typeface="Calibri" pitchFamily="34" charset="0"/>
+                <a:ea typeface="Calibri" pitchFamily="34" charset="-122"/>
+                <a:cs typeface="Calibri" pitchFamily="34" charset="-120"/>
+                <a:hlinkClick r:id="rId39" invalidUrl="" action="" tgtFrame="" tooltip="A fleet view that does not overstate" history="1" highlightClick="0" endSnd="0">
+                  <a:extLst>
+                    <a:ext uri="{A12FA001-AC4F-418D-AE19-62706E023703}">
+                      <ahyp:hlinkClr xmlns:ahyp="http://schemas.microsoft.com/office/drawing/2018/hyperlinkcolor" val="tx"/>
+                    </a:ext>
+                  </a:extLst>
+                </a:hlinkClick>
+              </a:rPr>
+              <a:t>A fleet view that does not overstate</a:t>
+            </a:r>
+            <a:endParaRPr lang="en-US" sz="660" dirty="0"/>
+          </a:p>
+        </p:txBody>
+      </p:sp>
+      <p:sp>
+        <p:nvSpPr>
+          <p:cNvPr id="84" name="Text 82"/>
+          <p:cNvSpPr txBox="1"/>
+          <p:nvPr/>
+        </p:nvSpPr>
+        <p:spPr>
+          <a:xfrm>
+            <a:off x="658368" y="5084064"/>
+            <a:ext cx="713232" cy="219456"/>
+          </a:xfrm>
+          <a:prstGeom prst="rect">
+            <a:avLst/>
+          </a:prstGeom>
+          <a:noFill/>
+          <a:ln/>
+        </p:spPr>
+        <p:txBody>
+          <a:bodyPr wrap="square" lIns="0" tIns="0" rIns="0" bIns="0" rtlCol="0" anchor="t"/>
+          <a:lstStyle/>
+          <a:p>
+            <a:pPr indent="0" marL="0">
+              <a:buNone/>
+            </a:pPr>
+            <a:r>
+              <a:rPr lang="en-US" sz="1100" b="1" dirty="0">
+                <a:solidFill>
+                  <a:srgbClr val="2B3038"/>
+                </a:solidFill>
+                <a:latin typeface="Cambria" pitchFamily="34" charset="0"/>
+                <a:ea typeface="Cambria" pitchFamily="34" charset="-122"/>
+                <a:cs typeface="Cambria" pitchFamily="34" charset="-120"/>
+              </a:rPr>
+              <a:t>later</a:t>
+            </a:r>
+            <a:endParaRPr lang="en-US" sz="1100" dirty="0"/>
+          </a:p>
+        </p:txBody>
+      </p:sp>
+      <p:sp>
+        <p:nvSpPr>
+          <p:cNvPr id="85" name="Text 83"/>
+          <p:cNvSpPr txBox="1"/>
+          <p:nvPr/>
+        </p:nvSpPr>
+        <p:spPr>
+          <a:xfrm>
+            <a:off x="658368" y="5294376"/>
+            <a:ext cx="749808" cy="402336"/>
+          </a:xfrm>
+          <a:prstGeom prst="rect">
+            <a:avLst/>
+          </a:prstGeom>
+          <a:noFill/>
+          <a:ln/>
+        </p:spPr>
+        <p:txBody>
+          <a:bodyPr wrap="square" lIns="0" tIns="0" rIns="0" bIns="0" rtlCol="0" anchor="t"/>
+          <a:lstStyle/>
+          <a:p>
+            <a:pPr indent="0" marL="0">
+              <a:lnSpc>
+                <a:spcPts val="860"/>
+              </a:lnSpc>
+              <a:buNone/>
+            </a:pPr>
+            <a:r>
+              <a:rPr lang="en-US" sz="700" dirty="0">
+                <a:solidFill>
+                  <a:srgbClr val="98A0A8"/>
+                </a:solidFill>
+                <a:latin typeface="Calibri" pitchFamily="34" charset="0"/>
+                <a:ea typeface="Calibri" pitchFamily="34" charset="-122"/>
+                <a:cs typeface="Calibri" pitchFamily="34" charset="-120"/>
+              </a:rPr>
+              <a:t>each one a</a:t>
+            </a:r>
+            <a:endParaRPr lang="en-US" sz="700" dirty="0"/>
+          </a:p>
+          <a:p>
+            <a:pPr indent="0" marL="0">
+              <a:lnSpc>
+                <a:spcPts val="860"/>
+              </a:lnSpc>
+              <a:buNone/>
+            </a:pPr>
+            <a:r>
+              <a:rPr lang="en-US" sz="700" dirty="0">
+                <a:solidFill>
+                  <a:srgbClr val="98A0A8"/>
+                </a:solidFill>
+                <a:latin typeface="Calibri" pitchFamily="34" charset="0"/>
+                <a:ea typeface="Calibri" pitchFamily="34" charset="-122"/>
+                <a:cs typeface="Calibri" pitchFamily="34" charset="-120"/>
+              </a:rPr>
+              <a:t>recorded decision</a:t>
+            </a:r>
+            <a:endParaRPr lang="en-US" sz="700" dirty="0"/>
+          </a:p>
+        </p:txBody>
+      </p:sp>
+      <p:sp>
+        <p:nvSpPr>
+          <p:cNvPr id="86" name="Shape 84"/>
+          <p:cNvSpPr/>
+          <p:nvPr/>
+        </p:nvSpPr>
+        <p:spPr>
+          <a:xfrm>
+            <a:off x="1463040" y="5084064"/>
+            <a:ext cx="1609344" cy="475488"/>
+          </a:xfrm>
+          <a:prstGeom prst="rect">
+            <a:avLst/>
+          </a:prstGeom>
+          <a:solidFill>
+            <a:srgbClr val="F2F3F4"/>
+          </a:solidFill>
+          <a:ln w="9525">
+            <a:solidFill>
+              <a:srgbClr val="DDE0E3"/>
+            </a:solidFill>
+            <a:prstDash val="solid"/>
+          </a:ln>
+        </p:spPr>
+      </p:sp>
+      <p:sp>
+        <p:nvSpPr>
+          <p:cNvPr id="87" name="Shape 85"/>
+          <p:cNvSpPr/>
+          <p:nvPr/>
+        </p:nvSpPr>
+        <p:spPr>
+          <a:xfrm>
+            <a:off x="1463040" y="5084064"/>
+            <a:ext cx="32004" cy="475488"/>
+          </a:xfrm>
+          <a:prstGeom prst="rect">
+            <a:avLst/>
+          </a:prstGeom>
+          <a:solidFill>
+            <a:srgbClr val="98A0A8"/>
+          </a:solidFill>
+          <a:ln w="12700">
+            <a:solidFill>
+              <a:srgbClr val="333333"/>
+            </a:solidFill>
+            <a:prstDash val="solid"/>
+          </a:ln>
+        </p:spPr>
+      </p:sp>
+      <p:sp>
+        <p:nvSpPr>
+          <p:cNvPr id="88" name="Text 86"/>
+          <p:cNvSpPr txBox="1"/>
+          <p:nvPr/>
+        </p:nvSpPr>
+        <p:spPr>
+          <a:xfrm>
+            <a:off x="1554480" y="5138928"/>
+            <a:ext cx="1481328" cy="384048"/>
+          </a:xfrm>
+          <a:prstGeom prst="rect">
+            <a:avLst/>
+          </a:prstGeom>
+          <a:noFill/>
+          <a:ln/>
+        </p:spPr>
+        <p:txBody>
+          <a:bodyPr wrap="square" lIns="0" tIns="0" rIns="0" bIns="0" rtlCol="0" anchor="t"/>
+          <a:lstStyle/>
+          <a:p>
+            <a:pPr indent="0" marL="0">
+              <a:lnSpc>
+                <a:spcPts val="980"/>
+              </a:lnSpc>
+              <a:buNone/>
+            </a:pPr>
+            <a:r>
+              <a:rPr lang="en-US" sz="660" b="1" dirty="0">
+                <a:solidFill>
+                  <a:srgbClr val="98A0A8"/>
+                </a:solidFill>
+                <a:latin typeface="Calibri" pitchFamily="34" charset="0"/>
+                <a:ea typeface="Calibri" pitchFamily="34" charset="-122"/>
+                <a:cs typeface="Calibri" pitchFamily="34" charset="-120"/>
+                <a:hlinkClick r:id="rId40" invalidUrl="" action="" tgtFrame="" tooltip="Headway and fatigue" history="1" highlightClick="0" endSnd="0">
+                  <a:extLst>
+                    <a:ext uri="{A12FA001-AC4F-418D-AE19-62706E023703}">
+                      <ahyp:hlinkClr xmlns:ahyp="http://schemas.microsoft.com/office/drawing/2018/hyperlinkcolor" val="tx"/>
+                    </a:ext>
+                  </a:extLst>
+                </a:hlinkClick>
+              </a:rPr>
+              <a:t>ADR-0012
+</a:t>
+            </a:r>
+            <a:endParaRPr lang="en-US" sz="660" dirty="0"/>
+          </a:p>
+          <a:p>
+            <a:pPr indent="0" marL="0">
+              <a:lnSpc>
+                <a:spcPts val="980"/>
+              </a:lnSpc>
+              <a:buNone/>
+            </a:pPr>
+            <a:r>
+              <a:rPr lang="en-US" sz="800" b="1" dirty="0">
+                <a:solidFill>
+                  <a:srgbClr val="2B3038"/>
+                </a:solidFill>
+                <a:latin typeface="Calibri" pitchFamily="34" charset="0"/>
+                <a:ea typeface="Calibri" pitchFamily="34" charset="-122"/>
+                <a:cs typeface="Calibri" pitchFamily="34" charset="-120"/>
+                <a:hlinkClick r:id="rId41" invalidUrl="" action="" tgtFrame="" tooltip="Headway and fatigue" history="1" highlightClick="0" endSnd="0">
+                  <a:extLst>
+                    <a:ext uri="{A12FA001-AC4F-418D-AE19-62706E023703}">
+                      <ahyp:hlinkClr xmlns:ahyp="http://schemas.microsoft.com/office/drawing/2018/hyperlinkcolor" val="tx"/>
+                    </a:ext>
+                  </a:extLst>
+                </a:hlinkClick>
+              </a:rPr>
+              <a:t>Headway and fatigue</a:t>
+            </a:r>
+            <a:endParaRPr lang="en-US" sz="660" dirty="0"/>
+          </a:p>
+        </p:txBody>
+      </p:sp>
+      <p:sp>
+        <p:nvSpPr>
+          <p:cNvPr id="89" name="Shape 87"/>
+          <p:cNvSpPr/>
+          <p:nvPr/>
+        </p:nvSpPr>
+        <p:spPr>
+          <a:xfrm>
+            <a:off x="3136392" y="5084064"/>
+            <a:ext cx="1609344" cy="475488"/>
+          </a:xfrm>
+          <a:prstGeom prst="rect">
+            <a:avLst/>
+          </a:prstGeom>
+          <a:solidFill>
+            <a:srgbClr val="FFFFFF"/>
+          </a:solidFill>
+          <a:ln w="9525">
+            <a:solidFill>
+              <a:srgbClr val="DDE0E3"/>
+            </a:solidFill>
+            <a:prstDash val="solid"/>
+          </a:ln>
+        </p:spPr>
+      </p:sp>
+      <p:sp>
+        <p:nvSpPr>
+          <p:cNvPr id="90" name="Shape 88"/>
+          <p:cNvSpPr/>
+          <p:nvPr/>
+        </p:nvSpPr>
+        <p:spPr>
+          <a:xfrm>
+            <a:off x="3136392" y="5084064"/>
+            <a:ext cx="32004" cy="475488"/>
+          </a:xfrm>
+          <a:prstGeom prst="rect">
+            <a:avLst/>
+          </a:prstGeom>
+          <a:solidFill>
+            <a:srgbClr val="C8621E"/>
+          </a:solidFill>
+          <a:ln w="12700">
+            <a:solidFill>
+              <a:srgbClr val="333333"/>
+            </a:solidFill>
+            <a:prstDash val="solid"/>
+          </a:ln>
+        </p:spPr>
+      </p:sp>
+      <p:sp>
+        <p:nvSpPr>
+          <p:cNvPr id="91" name="Text 89"/>
+          <p:cNvSpPr txBox="1"/>
+          <p:nvPr/>
+        </p:nvSpPr>
+        <p:spPr>
+          <a:xfrm>
+            <a:off x="3227832" y="5138928"/>
+            <a:ext cx="1481328" cy="384048"/>
+          </a:xfrm>
+          <a:prstGeom prst="rect">
+            <a:avLst/>
+          </a:prstGeom>
+          <a:noFill/>
+          <a:ln/>
+        </p:spPr>
+        <p:txBody>
+          <a:bodyPr wrap="square" lIns="0" tIns="0" rIns="0" bIns="0" rtlCol="0" anchor="t"/>
+          <a:lstStyle/>
+          <a:p>
+            <a:pPr indent="0" marL="0">
+              <a:lnSpc>
+                <a:spcPts val="980"/>
+              </a:lnSpc>
+              <a:buNone/>
+            </a:pPr>
+            <a:r>
+              <a:rPr lang="en-US" sz="660" b="1" dirty="0">
+                <a:solidFill>
+                  <a:srgbClr val="98A0A8"/>
+                </a:solidFill>
+                <a:latin typeface="Calibri" pitchFamily="34" charset="0"/>
+                <a:ea typeface="Calibri" pitchFamily="34" charset="-122"/>
+                <a:cs typeface="Calibri" pitchFamily="34" charset="-120"/>
+                <a:hlinkClick r:id="rId42" invalidUrl="" action="" tgtFrame="" tooltip="Re-engagement on sustained non-use" history="1" highlightClick="0" endSnd="0">
+                  <a:extLst>
+                    <a:ext uri="{A12FA001-AC4F-418D-AE19-62706E023703}">
+                      <ahyp:hlinkClr xmlns:ahyp="http://schemas.microsoft.com/office/drawing/2018/hyperlinkcolor" val="tx"/>
+                    </a:ext>
+                  </a:extLst>
+                </a:hlinkClick>
+              </a:rPr>
+              <a:t>ADR-0009 · R-11
+</a:t>
+            </a:r>
+            <a:endParaRPr lang="en-US" sz="660" dirty="0"/>
+          </a:p>
+          <a:p>
+            <a:pPr indent="0" marL="0">
+              <a:lnSpc>
+                <a:spcPts val="980"/>
+              </a:lnSpc>
+              <a:buNone/>
+            </a:pPr>
+            <a:r>
+              <a:rPr lang="en-US" sz="800" b="1" dirty="0">
+                <a:solidFill>
+                  <a:srgbClr val="2B3038"/>
+                </a:solidFill>
+                <a:latin typeface="Calibri" pitchFamily="34" charset="0"/>
+                <a:ea typeface="Calibri" pitchFamily="34" charset="-122"/>
+                <a:cs typeface="Calibri" pitchFamily="34" charset="-120"/>
+                <a:hlinkClick r:id="rId43" invalidUrl="" action="" tgtFrame="" tooltip="Re-engagement on sustained non-use" history="1" highlightClick="0" endSnd="0">
+                  <a:extLst>
+                    <a:ext uri="{A12FA001-AC4F-418D-AE19-62706E023703}">
+                      <ahyp:hlinkClr xmlns:ahyp="http://schemas.microsoft.com/office/drawing/2018/hyperlinkcolor" val="tx"/>
+                    </a:ext>
+                  </a:extLst>
+                </a:hlinkClick>
+              </a:rPr>
+              <a:t>Re-engagement on sustained non-use</a:t>
+            </a:r>
+            <a:endParaRPr lang="en-US" sz="660" dirty="0"/>
+          </a:p>
+        </p:txBody>
+      </p:sp>
+      <p:sp>
+        <p:nvSpPr>
+          <p:cNvPr id="92" name="Shape 90"/>
+          <p:cNvSpPr/>
+          <p:nvPr/>
+        </p:nvSpPr>
+        <p:spPr>
+          <a:xfrm>
+            <a:off x="4809744" y="5084064"/>
+            <a:ext cx="1609344" cy="475488"/>
+          </a:xfrm>
+          <a:prstGeom prst="rect">
+            <a:avLst/>
+          </a:prstGeom>
+          <a:solidFill>
+            <a:srgbClr val="FFFFFF"/>
+          </a:solidFill>
+          <a:ln w="9525">
+            <a:solidFill>
+              <a:srgbClr val="DDE0E3"/>
+            </a:solidFill>
+            <a:prstDash val="solid"/>
+          </a:ln>
+        </p:spPr>
+      </p:sp>
+      <p:sp>
+        <p:nvSpPr>
+          <p:cNvPr id="93" name="Shape 91"/>
+          <p:cNvSpPr/>
+          <p:nvPr/>
+        </p:nvSpPr>
+        <p:spPr>
+          <a:xfrm>
+            <a:off x="4809744" y="5084064"/>
+            <a:ext cx="32004" cy="475488"/>
+          </a:xfrm>
+          <a:prstGeom prst="rect">
+            <a:avLst/>
+          </a:prstGeom>
+          <a:solidFill>
+            <a:srgbClr val="C8621E"/>
+          </a:solidFill>
+          <a:ln w="12700">
+            <a:solidFill>
+              <a:srgbClr val="333333"/>
+            </a:solidFill>
+            <a:prstDash val="solid"/>
+          </a:ln>
+        </p:spPr>
+      </p:sp>
+      <p:sp>
+        <p:nvSpPr>
+          <p:cNvPr id="94" name="Text 92"/>
+          <p:cNvSpPr txBox="1"/>
+          <p:nvPr/>
+        </p:nvSpPr>
+        <p:spPr>
+          <a:xfrm>
+            <a:off x="4901184" y="5138928"/>
+            <a:ext cx="1481328" cy="384048"/>
+          </a:xfrm>
+          <a:prstGeom prst="rect">
+            <a:avLst/>
+          </a:prstGeom>
+          <a:noFill/>
+          <a:ln/>
+        </p:spPr>
+        <p:txBody>
+          <a:bodyPr wrap="square" lIns="0" tIns="0" rIns="0" bIns="0" rtlCol="0" anchor="t"/>
+          <a:lstStyle/>
+          <a:p>
+            <a:pPr indent="0" marL="0">
+              <a:lnSpc>
+                <a:spcPts val="980"/>
+              </a:lnSpc>
+              <a:buNone/>
+            </a:pPr>
+            <a:r>
+              <a:rPr lang="en-US" sz="660" b="1" dirty="0">
+                <a:solidFill>
+                  <a:srgbClr val="98A0A8"/>
+                </a:solidFill>
+                <a:latin typeface="Calibri" pitchFamily="34" charset="0"/>
+                <a:ea typeface="Calibri" pitchFamily="34" charset="-122"/>
+                <a:cs typeface="Calibri" pitchFamily="34" charset="-120"/>
+                <a:hlinkClick r:id="rId44" invalidUrl="" action="" tgtFrame="" tooltip="Downgrade audit tooling" history="1" highlightClick="0" endSnd="0">
+                  <a:extLst>
+                    <a:ext uri="{A12FA001-AC4F-418D-AE19-62706E023703}">
+                      <ahyp:hlinkClr xmlns:ahyp="http://schemas.microsoft.com/office/drawing/2018/hyperlinkcolor" val="tx"/>
+                    </a:ext>
+                  </a:extLst>
+                </a:hlinkClick>
+              </a:rPr>
+              <a:t>ADR-0013
+</a:t>
+            </a:r>
+            <a:endParaRPr lang="en-US" sz="660" dirty="0"/>
+          </a:p>
+          <a:p>
+            <a:pPr indent="0" marL="0">
+              <a:lnSpc>
+                <a:spcPts val="980"/>
+              </a:lnSpc>
+              <a:buNone/>
+            </a:pPr>
+            <a:r>
+              <a:rPr lang="en-US" sz="800" b="1" dirty="0">
+                <a:solidFill>
+                  <a:srgbClr val="2B3038"/>
+                </a:solidFill>
+                <a:latin typeface="Calibri" pitchFamily="34" charset="0"/>
+                <a:ea typeface="Calibri" pitchFamily="34" charset="-122"/>
+                <a:cs typeface="Calibri" pitchFamily="34" charset="-120"/>
+                <a:hlinkClick r:id="rId45" invalidUrl="" action="" tgtFrame="" tooltip="Downgrade audit tooling" history="1" highlightClick="0" endSnd="0">
+                  <a:extLst>
+                    <a:ext uri="{A12FA001-AC4F-418D-AE19-62706E023703}">
+                      <ahyp:hlinkClr xmlns:ahyp="http://schemas.microsoft.com/office/drawing/2018/hyperlinkcolor" val="tx"/>
+                    </a:ext>
+                  </a:extLst>
+                </a:hlinkClick>
+              </a:rPr>
+              <a:t>Downgrade audit tooling</a:t>
+            </a:r>
+            <a:endParaRPr lang="en-US" sz="660" dirty="0"/>
+          </a:p>
+        </p:txBody>
+      </p:sp>
+      <p:sp>
+        <p:nvSpPr>
+          <p:cNvPr id="95" name="Text 93"/>
+          <p:cNvSpPr txBox="1"/>
+          <p:nvPr/>
+        </p:nvSpPr>
+        <p:spPr>
+          <a:xfrm>
+            <a:off x="6574536" y="5138928"/>
+            <a:ext cx="1609344" cy="182880"/>
+          </a:xfrm>
+          <a:prstGeom prst="rect">
+            <a:avLst/>
+          </a:prstGeom>
+          <a:noFill/>
+          <a:ln/>
+        </p:spPr>
+        <p:txBody>
+          <a:bodyPr wrap="square" lIns="0" tIns="0" rIns="0" bIns="0" rtlCol="0" anchor="t"/>
+          <a:lstStyle/>
+          <a:p>
+            <a:pPr indent="0" marL="0">
+              <a:buNone/>
+            </a:pPr>
+            <a:r>
+              <a:rPr lang="en-US" sz="900" dirty="0">
+                <a:solidFill>
+                  <a:srgbClr val="CDD2D7"/>
+                </a:solidFill>
+                <a:latin typeface="Calibri" pitchFamily="34" charset="0"/>
+                <a:ea typeface="Calibri" pitchFamily="34" charset="-122"/>
+                <a:cs typeface="Calibri" pitchFamily="34" charset="-120"/>
+              </a:rPr>
+              <a:t>-</a:t>
+            </a:r>
+            <a:endParaRPr lang="en-US" sz="900" dirty="0"/>
+          </a:p>
+        </p:txBody>
+      </p:sp>
+      <p:sp>
+        <p:nvSpPr>
+          <p:cNvPr id="96" name="Shape 94"/>
+          <p:cNvSpPr/>
+          <p:nvPr/>
+        </p:nvSpPr>
+        <p:spPr>
+          <a:xfrm>
+            <a:off x="8156448" y="5084064"/>
+            <a:ext cx="1609344" cy="475488"/>
+          </a:xfrm>
+          <a:prstGeom prst="rect">
+            <a:avLst/>
+          </a:prstGeom>
+          <a:solidFill>
+            <a:srgbClr val="FFFFFF"/>
+          </a:solidFill>
+          <a:ln w="9525">
+            <a:solidFill>
+              <a:srgbClr val="DDE0E3"/>
+            </a:solidFill>
+            <a:prstDash val="solid"/>
+          </a:ln>
+        </p:spPr>
+      </p:sp>
+      <p:sp>
+        <p:nvSpPr>
+          <p:cNvPr id="97" name="Shape 95"/>
+          <p:cNvSpPr/>
+          <p:nvPr/>
+        </p:nvSpPr>
+        <p:spPr>
+          <a:xfrm>
+            <a:off x="8156448" y="5084064"/>
+            <a:ext cx="32004" cy="475488"/>
+          </a:xfrm>
+          <a:prstGeom prst="rect">
+            <a:avLst/>
+          </a:prstGeom>
+          <a:solidFill>
+            <a:srgbClr val="C8621E"/>
+          </a:solidFill>
+          <a:ln w="12700">
+            <a:solidFill>
+              <a:srgbClr val="333333"/>
+            </a:solidFill>
+            <a:prstDash val="solid"/>
+          </a:ln>
+        </p:spPr>
+      </p:sp>
+      <p:sp>
+        <p:nvSpPr>
+          <p:cNvPr id="98" name="Text 96"/>
+          <p:cNvSpPr txBox="1"/>
+          <p:nvPr/>
+        </p:nvSpPr>
+        <p:spPr>
+          <a:xfrm>
+            <a:off x="8247888" y="5138928"/>
+            <a:ext cx="1481328" cy="384048"/>
+          </a:xfrm>
+          <a:prstGeom prst="rect">
+            <a:avLst/>
+          </a:prstGeom>
+          <a:noFill/>
+          <a:ln/>
+        </p:spPr>
+        <p:txBody>
+          <a:bodyPr wrap="square" lIns="0" tIns="0" rIns="0" bIns="0" rtlCol="0" anchor="t"/>
+          <a:lstStyle/>
+          <a:p>
+            <a:pPr indent="0" marL="0">
+              <a:lnSpc>
+                <a:spcPts val="980"/>
+              </a:lnSpc>
+              <a:buNone/>
+            </a:pPr>
+            <a:r>
+              <a:rPr lang="en-US" sz="660" b="1" dirty="0">
+                <a:solidFill>
+                  <a:srgbClr val="98A0A8"/>
+                </a:solidFill>
+                <a:latin typeface="Calibri" pitchFamily="34" charset="0"/>
+                <a:ea typeface="Calibri" pitchFamily="34" charset="-122"/>
+                <a:cs typeface="Calibri" pitchFamily="34" charset="-120"/>
+                <a:hlinkClick r:id="rId46" invalidUrl="" action="" tgtFrame="" tooltip="Any driver-facing surface" history="1" highlightClick="0" endSnd="0">
+                  <a:extLst>
+                    <a:ext uri="{A12FA001-AC4F-418D-AE19-62706E023703}">
+                      <ahyp:hlinkClr xmlns:ahyp="http://schemas.microsoft.com/office/drawing/2018/hyperlinkcolor" val="tx"/>
+                    </a:ext>
+                  </a:extLst>
+                </a:hlinkClick>
+              </a:rPr>
+              <a:t>ADR-0004
+</a:t>
+            </a:r>
+            <a:endParaRPr lang="en-US" sz="660" dirty="0"/>
+          </a:p>
+          <a:p>
+            <a:pPr indent="0" marL="0">
+              <a:lnSpc>
+                <a:spcPts val="980"/>
+              </a:lnSpc>
+              <a:buNone/>
+            </a:pPr>
+            <a:r>
+              <a:rPr lang="en-US" sz="800" b="1" dirty="0">
+                <a:solidFill>
+                  <a:srgbClr val="2B3038"/>
+                </a:solidFill>
+                <a:latin typeface="Calibri" pitchFamily="34" charset="0"/>
+                <a:ea typeface="Calibri" pitchFamily="34" charset="-122"/>
+                <a:cs typeface="Calibri" pitchFamily="34" charset="-120"/>
+                <a:hlinkClick r:id="rId47" invalidUrl="" action="" tgtFrame="" tooltip="Any driver-facing surface" history="1" highlightClick="0" endSnd="0">
+                  <a:extLst>
+                    <a:ext uri="{A12FA001-AC4F-418D-AE19-62706E023703}">
+                      <ahyp:hlinkClr xmlns:ahyp="http://schemas.microsoft.com/office/drawing/2018/hyperlinkcolor" val="tx"/>
+                    </a:ext>
+                  </a:extLst>
+                </a:hlinkClick>
+              </a:rPr>
+              <a:t>Any driver-facing surface</a:t>
+            </a:r>
+            <a:endParaRPr lang="en-US" sz="660" dirty="0"/>
+          </a:p>
+        </p:txBody>
+      </p:sp>
+      <p:sp>
+        <p:nvSpPr>
+          <p:cNvPr id="99" name="Shape 97"/>
+          <p:cNvSpPr/>
+          <p:nvPr/>
+        </p:nvSpPr>
+        <p:spPr>
+          <a:xfrm>
+            <a:off x="8156448" y="5586984"/>
+            <a:ext cx="1609344" cy="475488"/>
+          </a:xfrm>
+          <a:prstGeom prst="rect">
+            <a:avLst/>
+          </a:prstGeom>
+          <a:solidFill>
+            <a:srgbClr val="FFFFFF"/>
+          </a:solidFill>
+          <a:ln w="9525">
+            <a:solidFill>
+              <a:srgbClr val="DDE0E3"/>
+            </a:solidFill>
+            <a:prstDash val="solid"/>
+          </a:ln>
+        </p:spPr>
+      </p:sp>
+      <p:sp>
+        <p:nvSpPr>
+          <p:cNvPr id="100" name="Shape 98"/>
+          <p:cNvSpPr/>
+          <p:nvPr/>
+        </p:nvSpPr>
+        <p:spPr>
+          <a:xfrm>
+            <a:off x="8156448" y="5586984"/>
+            <a:ext cx="32004" cy="475488"/>
+          </a:xfrm>
+          <a:prstGeom prst="rect">
+            <a:avLst/>
+          </a:prstGeom>
+          <a:solidFill>
+            <a:srgbClr val="C8621E"/>
+          </a:solidFill>
+          <a:ln w="12700">
+            <a:solidFill>
+              <a:srgbClr val="333333"/>
+            </a:solidFill>
+            <a:prstDash val="solid"/>
+          </a:ln>
+        </p:spPr>
+      </p:sp>
+      <p:sp>
+        <p:nvSpPr>
+          <p:cNvPr id="101" name="Text 99"/>
+          <p:cNvSpPr txBox="1"/>
+          <p:nvPr/>
+        </p:nvSpPr>
+        <p:spPr>
+          <a:xfrm>
+            <a:off x="8247888" y="5641848"/>
+            <a:ext cx="1481328" cy="384048"/>
+          </a:xfrm>
+          <a:prstGeom prst="rect">
+            <a:avLst/>
+          </a:prstGeom>
+          <a:noFill/>
+          <a:ln/>
+        </p:spPr>
+        <p:txBody>
+          <a:bodyPr wrap="square" lIns="0" tIns="0" rIns="0" bIns="0" rtlCol="0" anchor="t"/>
+          <a:lstStyle/>
+          <a:p>
+            <a:pPr indent="0" marL="0">
+              <a:lnSpc>
+                <a:spcPts val="980"/>
+              </a:lnSpc>
+              <a:buNone/>
+            </a:pPr>
+            <a:r>
+              <a:rPr lang="en-US" sz="660" b="1" dirty="0">
+                <a:solidFill>
+                  <a:srgbClr val="98A0A8"/>
+                </a:solidFill>
+                <a:latin typeface="Calibri" pitchFamily="34" charset="0"/>
+                <a:ea typeface="Calibri" pitchFamily="34" charset="-122"/>
+                <a:cs typeface="Calibri" pitchFamily="34" charset="-120"/>
+                <a:hlinkClick r:id="rId48" invalidUrl="" action="" tgtFrame="" tooltip="Depot-manager handover" history="1" highlightClick="0" endSnd="0">
+                  <a:extLst>
+                    <a:ext uri="{A12FA001-AC4F-418D-AE19-62706E023703}">
+                      <ahyp:hlinkClr xmlns:ahyp="http://schemas.microsoft.com/office/drawing/2018/hyperlinkcolor" val="tx"/>
+                    </a:ext>
+                  </a:extLst>
+                </a:hlinkClick>
+              </a:rPr>
+              <a:t>ADR-0006 · A-16
+</a:t>
+            </a:r>
+            <a:endParaRPr lang="en-US" sz="660" dirty="0"/>
+          </a:p>
+          <a:p>
+            <a:pPr indent="0" marL="0">
+              <a:lnSpc>
+                <a:spcPts val="980"/>
+              </a:lnSpc>
+              <a:buNone/>
+            </a:pPr>
+            <a:r>
+              <a:rPr lang="en-US" sz="800" b="1" dirty="0">
+                <a:solidFill>
+                  <a:srgbClr val="2B3038"/>
+                </a:solidFill>
+                <a:latin typeface="Calibri" pitchFamily="34" charset="0"/>
+                <a:ea typeface="Calibri" pitchFamily="34" charset="-122"/>
+                <a:cs typeface="Calibri" pitchFamily="34" charset="-120"/>
+                <a:hlinkClick r:id="rId49" invalidUrl="" action="" tgtFrame="" tooltip="Depot-manager handover" history="1" highlightClick="0" endSnd="0">
+                  <a:extLst>
+                    <a:ext uri="{A12FA001-AC4F-418D-AE19-62706E023703}">
+                      <ahyp:hlinkClr xmlns:ahyp="http://schemas.microsoft.com/office/drawing/2018/hyperlinkcolor" val="tx"/>
+                    </a:ext>
+                  </a:extLst>
+                </a:hlinkClick>
+              </a:rPr>
+              <a:t>Depot-manager handover</a:t>
+            </a:r>
+            <a:endParaRPr lang="en-US" sz="660" dirty="0"/>
+          </a:p>
+        </p:txBody>
+      </p:sp>
+      <p:sp>
+        <p:nvSpPr>
+          <p:cNvPr id="102" name="Text 100"/>
+          <p:cNvSpPr txBox="1"/>
+          <p:nvPr/>
+        </p:nvSpPr>
+        <p:spPr>
+          <a:xfrm>
+            <a:off x="9921240" y="5138928"/>
+            <a:ext cx="1609344" cy="182880"/>
+          </a:xfrm>
+          <a:prstGeom prst="rect">
+            <a:avLst/>
+          </a:prstGeom>
+          <a:noFill/>
+          <a:ln/>
+        </p:spPr>
+        <p:txBody>
+          <a:bodyPr wrap="square" lIns="0" tIns="0" rIns="0" bIns="0" rtlCol="0" anchor="t"/>
+          <a:lstStyle/>
+          <a:p>
+            <a:pPr indent="0" marL="0">
+              <a:buNone/>
+            </a:pPr>
+            <a:r>
+              <a:rPr lang="en-US" sz="900" dirty="0">
+                <a:solidFill>
+                  <a:srgbClr val="CDD2D7"/>
+                </a:solidFill>
+                <a:latin typeface="Calibri" pitchFamily="34" charset="0"/>
+                <a:ea typeface="Calibri" pitchFamily="34" charset="-122"/>
+                <a:cs typeface="Calibri" pitchFamily="34" charset="-120"/>
+              </a:rPr>
+              <a:t>-</a:t>
+            </a:r>
+            <a:endParaRPr lang="en-US" sz="900" dirty="0"/>
+          </a:p>
+        </p:txBody>
+      </p:sp>
+      <p:sp>
+        <p:nvSpPr>
+          <p:cNvPr id="103" name="Text 101"/>
+          <p:cNvSpPr txBox="1"/>
+          <p:nvPr/>
+        </p:nvSpPr>
+        <p:spPr>
+          <a:xfrm>
+            <a:off x="658368" y="6144768"/>
             <a:ext cx="10844784" cy="457200"/>
           </a:xfrm>
           <a:prstGeom prst="rect">
@@ -15621,7 +19052,7 @@
                 <a:ea typeface="Calibri" pitchFamily="34" charset="-122"/>
                 <a:cs typeface="Calibri" pitchFamily="34" charset="-120"/>
               </a:rPr>
-              <a:t>Every card here is a link. The first release is a complete walk across the whole row. The bottom row is not a list of things nobody got to: every one is a decision with a record behind it.</a:t>
+              <a:t>The first release is a complete walk across the whole row. The bottom row is not a list of things nobody got to: every one is a decision with a record behind it. The live map carries the sizing and the rationale on each card.</a:t>
             </a:r>
             <a:endParaRPr lang="en-US" sz="1100" dirty="0"/>
           </a:p>

</xml_diff>

<commit_message>
Say what Critical does before saying what it does not
The Critical band explained the push and fetch cases before it said what
the band is for. That answered an architecture question nobody had asked
yet, in the cell whose job is to define the band.

It now says the clip is fetched straight away if the device has not
already sent it, which covers the same ground in one clause and reads
in the order someone meets it.

Co-Authored-By: Claude Opus 5 <noreply@anthropic.com>
Claude-Session: https://claude.ai/code/session_018sKrcprqkNQmfDKnYFUhGV
</commit_message>
<xml_diff>
--- a/Claude outputs/cameramatics-danny-daley.pptx
+++ b/Claude outputs/cameramatics-danny-daley.pptx
@@ -3285,7 +3285,7 @@
                 <a:ea typeface="Cambria" pitchFamily="34" charset="-122"/>
                 <a:cs typeface="Cambria" pitchFamily="34" charset="-120"/>
               </a:rPr>
-              <a:t>One click, not two</a:t>
+              <a:t>One click</a:t>
             </a:r>
             <a:endParaRPr lang="en-US" sz="1300" dirty="0"/>
           </a:p>
@@ -3327,7 +3327,7 @@
                 <a:ea typeface="Calibri" pitchFamily="34" charset="-122"/>
                 <a:cs typeface="Calibri" pitchFamily="34" charset="-120"/>
               </a:rPr>
-              <a:t>An earlier version asked the manager to confirm the label after choosing it. Building the screen showed that the second click was a receipt, not a decision, so it went.</a:t>
+              <a:t>An earlier version asked the manager to confirm the label after choosing it. Building the screen showed the second click recorded nothing the first had not, so it went.</a:t>
             </a:r>
             <a:endParaRPr lang="en-US" sz="1150" dirty="0"/>
           </a:p>
@@ -4514,7 +4514,7 @@
                 <a:ea typeface="Calibri" pitchFamily="34" charset="-122"/>
                 <a:cs typeface="Calibri" pitchFamily="34" charset="-120"/>
               </a:rPr>
-              <a:t>14 of 15 stories. A manager with a queue and no way to act on it has a better dashboard. A manager with a coaching form and no triage has the firehose with extra steps. Neither half is worth shipping on its own.</a:t>
+              <a:t>14 of 15 stories: 9 sized M, 4 S, 1 XS. A manager with a queue and no way to act on it has a better dashboard. A manager with a coaching form and no triage has the firehose with extra steps. Neither half is worth shipping on its own.</a:t>
             </a:r>
             <a:endParaRPr lang="en-US" sz="1150" dirty="0"/>
           </a:p>
@@ -4726,7 +4726,7 @@
                 <a:ea typeface="Calibri" pitchFamily="34" charset="-122"/>
                 <a:cs typeface="Calibri" pitchFamily="34" charset="-120"/>
               </a:rPr>
-              <a:t>The three tracks are genuinely concurrent, so more people buy calendar time up to roughly three teams, past which the joins become the constraint. That figure is my judgement, not a measurement. What capacity does not buy is firmware lead time. That is months and it is not ours to schedule.</a:t>
+              <a:t>The three tracks are genuinely concurrent, so more people buy calendar time up to roughly three teams, past which the joins become the constraint. That figure is my judgement, not a measurement. What capacity does not buy is firmware lead time. I have no basis for a number there and will not guess at one, but it is the item most likely to set the date.</a:t>
             </a:r>
             <a:endParaRPr lang="en-US" sz="1150" dirty="0"/>
           </a:p>
@@ -5261,7 +5261,7 @@
                 <a:ea typeface="Calibri" pitchFamily="34" charset="-122"/>
                 <a:cs typeface="Calibri" pitchFamily="34" charset="-120"/>
               </a:rPr>
-              <a:t>Risky events per 1,000 km, which needs mileage the device does not send today. Are the conversations reaching the drivers causing the events</a:t>
+              <a:t>Risky events per 1,000 km. Assumes distance is on the event record, which I could not confirm from outside and which one question settles. Are the conversations reaching the drivers causing the events</a:t>
             </a:r>
             <a:endParaRPr lang="en-US" sz="1200" dirty="0"/>
           </a:p>
@@ -7338,7 +7338,7 @@
                 <a:ea typeface="Cambria" pitchFamily="34" charset="-122"/>
                 <a:cs typeface="Cambria" pitchFamily="34" charset="-120"/>
               </a:rPr>
-              <a:t>How do you know who was driving, and how often?</a:t>
+              <a:t>How reliable is driver identification, and how often is it wrong?</a:t>
             </a:r>
             <a:endParaRPr lang="en-US" sz="1300" dirty="0"/>
           </a:p>
@@ -7419,7 +7419,7 @@
                 <a:ea typeface="Calibri" pitchFamily="34" charset="-122"/>
                 <a:cs typeface="Calibri" pitchFamily="34" charset="-120"/>
               </a:rPr>
-              <a:t>Assumed solved for this exercise. If it is not, the release splits: review ships, coaching waits.</a:t>
+              <a:t>US-008 ships in v1 either way. The question is how much of it is manual, because coaching a driver the system misnamed is the fastest way to lose the cab.</a:t>
             </a:r>
             <a:endParaRPr lang="en-US" sz="1150" dirty="0"/>
           </a:p>
@@ -7825,7 +7825,7 @@
                 <a:ea typeface="Calibri" pitchFamily="34" charset="-122"/>
                 <a:cs typeface="Calibri" pitchFamily="34" charset="-120"/>
               </a:rPr>
-              <a:t>A question whose answer only moves a date was never blocking. Four of these change the plan. The other two change what we are allowed to claim.</a:t>
+              <a:t>Four of these change the plan. Two change what we are allowed to claim. None of them is a question I would answer by guessing.</a:t>
             </a:r>
             <a:endParaRPr lang="en-US" sz="1100" dirty="0"/>
           </a:p>
@@ -7980,7 +7980,7 @@
                 <a:ea typeface="Calibri" pitchFamily="34" charset="-122"/>
                 <a:cs typeface="Calibri" pitchFamily="34" charset="-120"/>
               </a:rPr>
-              <a:t>This is how I run a product function, not something built for this exercise. Every claim in this deck points at a file in here, and every file says who wrote it, who decided it, and whether it has been challenged yet.</a:t>
+              <a:t>This is how I run a product function. It predates this exercise and it will outlast it. Every claim in this deck points at a file in here, and every file says who wrote it, who decided it, and whether it has been challenged yet.</a:t>
             </a:r>
             <a:endParaRPr lang="en-US" sz="1350" dirty="0"/>
           </a:p>
@@ -8621,7 +8621,7 @@
                 <a:ea typeface="Calibri" pitchFamily="34" charset="-122"/>
                 <a:cs typeface="Calibri" pitchFamily="34" charset="-120"/>
               </a:rPr>
-              <a:t>About six hours of my own focused effort across two days, fitted around other work. The volume is agent output under my direction, and the commit history shows both halves of that honestly.</a:t>
+              <a:t>Every file says who drafted it, who decided it, and whether it has been challenged. The commit history shows the order it happened in.</a:t>
             </a:r>
             <a:endParaRPr lang="en-US" sz="1100" dirty="0"/>
           </a:p>
@@ -9450,7 +9450,7 @@
                 <a:ea typeface="Calibri" pitchFamily="34" charset="-122"/>
                 <a:cs typeface="Calibri" pitchFamily="34" charset="-120"/>
               </a:rPr>
-              <a:t>The judgement log records the decisions where an agent had a view worth arguing with: 29 entries, 9 of them overruled. It does not capture the steering, which happened in conversation before anything was written and is the larger part of the work. What follows is the part you can check.</a:t>
+              <a:t>The judgement log records the decisions where an agent had a view worth arguing with: 30 entries, 9 of them overruled. It does not capture the steering, which happened in conversation before anything was written and is the larger part of the work. What follows is the part you can check.</a:t>
             </a:r>
             <a:endParaRPr lang="en-US" sz="1250" dirty="0"/>
           </a:p>
@@ -10190,7 +10190,7 @@
                 <a:ea typeface="Calibri" pitchFamily="34" charset="-122"/>
                 <a:cs typeface="Calibri" pitchFamily="34" charset="-120"/>
               </a:rPr>
-              <a:t>Rereading after J-26: the whole fixture was British. Coventry street names, mph, UK plates, handed to a Dublin company. Not a wrong fact, a wrong audience, and no validator or adversarial pass can see that. It is a 42-vehicle Dublin fleet now.</a:t>
+              <a:t>The fixture defaulted to one market: mph, Coventry street names, UK plates. Not wrong, they sell hard in the UK. Wrong that nobody asked, when the product runs across Ireland, the UK, Europe and the US and has to carry all of them.</a:t>
             </a:r>
             <a:endParaRPr lang="en-US" sz="1000" dirty="0"/>
           </a:p>
@@ -10274,7 +10274,7 @@
                 <a:ea typeface="Calibri" pitchFamily="34" charset="-122"/>
                 <a:cs typeface="Calibri" pitchFamily="34" charset="-120"/>
               </a:rPr>
-              <a:t>My prototype was making things up: confirming a driver had avoided harm wrote a fixed sentence onto their record, the wrong day, the wrong road, the wrong thing done, under a named manager's confirmation with a clip attached. Found in eleven minutes by an agent that had never seen the work. Five review passes in all, 53 findings on the repository itself, and every one of them is written down there.</a:t>
+              <a:t>My prototype was making things up: confirming a driver had avoided harm wrote a fixed sentence onto their record, the wrong day, the wrong road, the wrong thing done, under a named manager's confirmation with a clip attached. Found in eleven minutes by an agent that had never seen the work. The last pass, on the finished deck, found three numbers nobody had ever checked against the thing they described, including one that broke the rule the screen beside it exists to demonstrate. Every finding is in the repository.</a:t>
             </a:r>
             <a:endParaRPr lang="en-US" sz="1150" dirty="0"/>
           </a:p>
@@ -10758,7 +10758,7 @@
                 <a:ea typeface="Calibri" pitchFamily="34" charset="-122"/>
                 <a:cs typeface="Calibri" pitchFamily="34" charset="-120"/>
               </a:rPr>
-              <a:t>  events a day, one fleet, one manager, and no way to tell which six matter.</a:t>
+              <a:t>  events a day, one fleet, one manager, and no way to tell which of them matter.</a:t>
             </a:r>
             <a:endParaRPr lang="en-US" sz="3800" dirty="0"/>
           </a:p>
@@ -11862,7 +11862,7 @@
                 <a:ea typeface="Cambria" pitchFamily="34" charset="-122"/>
                 <a:cs typeface="Cambria" pitchFamily="34" charset="-120"/>
               </a:rPr>
-              <a:t>The firehose, and the six events</a:t>
+              <a:t>The firehose, and the few that matter</a:t>
             </a:r>
             <a:endParaRPr lang="en-US" sz="3000" dirty="0"/>
           </a:p>
@@ -13117,7 +13117,7 @@
                 <a:ea typeface="Calibri" pitchFamily="34" charset="-122"/>
                 <a:cs typeface="Calibri" pitchFamily="34" charset="-120"/>
               </a:rPr>
-              <a:t>THE UPSIDE, NOT THE HEADLINE</a:t>
+              <a:t>UPSIDE, HELD SEPARATELY</a:t>
             </a:r>
             <a:endParaRPr lang="en-US" sz="900" dirty="0"/>
           </a:p>
@@ -13299,7 +13299,7 @@
                 <a:ea typeface="Calibri" pitchFamily="34" charset="-122"/>
                 <a:cs typeface="Calibri" pitchFamily="34" charset="-120"/>
               </a:rPr>
-              <a:t>Revenue is fitted vehicles times price per vehicle per month times attach rate. Payback is one avoided at-fault collision set against the annual cost of the vehicles it took to find it. Not one of those five inputs is knowable from outside. I would have all five in week one, and I would rather show the arithmetic with the gaps marked than fill them in with numbers I made up. All of it written against a company that raised up to 49 million in June to scale into North America and mainland Europe, so whatever we build has to work in more than one market.</a:t>
+              <a:t>Revenue is fitted vehicles times price per vehicle per month times attach rate. Payback is one avoided at-fault collision set against the annual cost of the vehicles it took to find it. Not one of those five is knowable from outside accurately enough to quote. I would have all five in week one, and I would rather show the arithmetic with the gaps marked than fill them in with numbers I made up. All of it written against a company that raised up to 49m euro in June to scale into North America and mainland Europe, so whatever we build has to work in more than one market.</a:t>
             </a:r>
             <a:endParaRPr lang="en-US" sz="1200" dirty="0"/>
           </a:p>
@@ -13518,7 +13518,7 @@
                 <a:ea typeface="Calibri" pitchFamily="34" charset="-122"/>
                 <a:cs typeface="Calibri" pitchFamily="34" charset="-120"/>
               </a:rPr>
-              <a:t>Interrupt. The clip uploads without being asked for, and an email goes out carrying almost nothing.</a:t>
+              <a:t>Interrupt. The email goes out carrying almost nothing. The clip is pushed where the device flagged the event high and fetched where it did not, so the screen says which of those is happening rather than implying footage is already there.</a:t>
             </a:r>
             <a:endParaRPr lang="en-US" sz="1300" dirty="0"/>
           </a:p>
@@ -14261,7 +14261,7 @@
                 <a:ea typeface="Calibri" pitchFamily="34" charset="-122"/>
                 <a:cs typeface="Calibri" pitchFamily="34" charset="-120"/>
               </a:rPr>
-              <a:t>Detect four behaviours on the device itself, in real time: harsh braking, harsh acceleration, harsh cornering, phone in hand. Attach every signal it has, whichever one set the event off. Keep recording in a loop so a clip can still be fetched days later.</a:t>
+              <a:t>The detectors exist. The ask is that every event they raise carries the full signal set, whichever detector fired. v1 routes four of them: harsh braking, acceleration, cornering, phone in hand. Keep recording in a loop so a clip can still be fetched days later.</a:t>
             </a:r>
             <a:endParaRPr lang="en-US" sz="1150" dirty="0"/>
           </a:p>
@@ -14716,7 +14716,7 @@
                 <a:ea typeface="Calibri" pitchFamily="34" charset="-122"/>
                 <a:cs typeface="Calibri" pitchFamily="34" charset="-120"/>
               </a:rPr>
-              <a:t>It ranks nothing itself and offers no settings. Deciding what deserves attention is our job, not a slider we hand to the customer.</a:t>
+              <a:t>It ranks nothing itself and offers no settings. Deciding what deserves attention is our job. Handing it over as a slider moves the problem to someone with less to go on.</a:t>
             </a:r>
             <a:endParaRPr lang="en-US" sz="1150" dirty="0"/>
           </a:p>
@@ -15526,22 +15526,22 @@
         </p:nvSpPr>
         <p:spPr>
           <a:xfrm>
-            <a:off x="1554480" y="2359152"/>
-            <a:ext cx="1481328" cy="384048"/>
-          </a:xfrm>
-          <a:prstGeom prst="rect">
-            <a:avLst/>
-          </a:prstGeom>
-          <a:noFill/>
-          <a:ln/>
-        </p:spPr>
-        <p:txBody>
-          <a:bodyPr wrap="square" lIns="0" tIns="0" rIns="0" bIns="0" rtlCol="0" anchor="t"/>
-          <a:lstStyle/>
-          <a:p>
-            <a:pPr indent="0" marL="0">
-              <a:lnSpc>
-                <a:spcPts val="980"/>
+            <a:off x="1545336" y="2359152"/>
+            <a:ext cx="1508760" cy="384048"/>
+          </a:xfrm>
+          <a:prstGeom prst="rect">
+            <a:avLst/>
+          </a:prstGeom>
+          <a:noFill/>
+          <a:ln/>
+        </p:spPr>
+        <p:txBody>
+          <a:bodyPr wrap="square" lIns="0" tIns="0" rIns="0" bIns="0" rtlCol="0" anchor="t"/>
+          <a:lstStyle/>
+          <a:p>
+            <a:pPr indent="0" marL="0">
+              <a:lnSpc>
+                <a:spcPts val="960"/>
               </a:lnSpc>
               <a:buNone/>
             </a:pPr>
@@ -15569,12 +15569,12 @@
           <a:p>
             <a:pPr indent="0" marL="0">
               <a:lnSpc>
-                <a:spcPts val="980"/>
-              </a:lnSpc>
-              <a:buNone/>
-            </a:pPr>
-            <a:r>
-              <a:rPr lang="en-US" sz="800" b="1" dirty="0">
+                <a:spcPts val="960"/>
+              </a:lnSpc>
+              <a:buNone/>
+            </a:pPr>
+            <a:r>
+              <a:rPr lang="en-US" sz="780" b="1" dirty="0">
                 <a:solidFill>
                   <a:srgbClr val="2B3038"/>
                 </a:solidFill>
@@ -15653,22 +15653,22 @@
         </p:nvSpPr>
         <p:spPr>
           <a:xfrm>
-            <a:off x="1554480" y="2862072"/>
-            <a:ext cx="1481328" cy="384048"/>
-          </a:xfrm>
-          <a:prstGeom prst="rect">
-            <a:avLst/>
-          </a:prstGeom>
-          <a:noFill/>
-          <a:ln/>
-        </p:spPr>
-        <p:txBody>
-          <a:bodyPr wrap="square" lIns="0" tIns="0" rIns="0" bIns="0" rtlCol="0" anchor="t"/>
-          <a:lstStyle/>
-          <a:p>
-            <a:pPr indent="0" marL="0">
-              <a:lnSpc>
-                <a:spcPts val="980"/>
+            <a:off x="1545336" y="2862072"/>
+            <a:ext cx="1508760" cy="384048"/>
+          </a:xfrm>
+          <a:prstGeom prst="rect">
+            <a:avLst/>
+          </a:prstGeom>
+          <a:noFill/>
+          <a:ln/>
+        </p:spPr>
+        <p:txBody>
+          <a:bodyPr wrap="square" lIns="0" tIns="0" rIns="0" bIns="0" rtlCol="0" anchor="t"/>
+          <a:lstStyle/>
+          <a:p>
+            <a:pPr indent="0" marL="0">
+              <a:lnSpc>
+                <a:spcPts val="960"/>
               </a:lnSpc>
               <a:buNone/>
             </a:pPr>
@@ -15696,12 +15696,12 @@
           <a:p>
             <a:pPr indent="0" marL="0">
               <a:lnSpc>
-                <a:spcPts val="980"/>
-              </a:lnSpc>
-              <a:buNone/>
-            </a:pPr>
-            <a:r>
-              <a:rPr lang="en-US" sz="800" b="1" dirty="0">
+                <a:spcPts val="960"/>
+              </a:lnSpc>
+              <a:buNone/>
+            </a:pPr>
+            <a:r>
+              <a:rPr lang="en-US" sz="780" b="1" dirty="0">
                 <a:solidFill>
                   <a:srgbClr val="2B3038"/>
                 </a:solidFill>
@@ -15780,22 +15780,22 @@
         </p:nvSpPr>
         <p:spPr>
           <a:xfrm>
-            <a:off x="1554480" y="3364992"/>
-            <a:ext cx="1481328" cy="384048"/>
-          </a:xfrm>
-          <a:prstGeom prst="rect">
-            <a:avLst/>
-          </a:prstGeom>
-          <a:noFill/>
-          <a:ln/>
-        </p:spPr>
-        <p:txBody>
-          <a:bodyPr wrap="square" lIns="0" tIns="0" rIns="0" bIns="0" rtlCol="0" anchor="t"/>
-          <a:lstStyle/>
-          <a:p>
-            <a:pPr indent="0" marL="0">
-              <a:lnSpc>
-                <a:spcPts val="980"/>
+            <a:off x="1545336" y="3364992"/>
+            <a:ext cx="1508760" cy="384048"/>
+          </a:xfrm>
+          <a:prstGeom prst="rect">
+            <a:avLst/>
+          </a:prstGeom>
+          <a:noFill/>
+          <a:ln/>
+        </p:spPr>
+        <p:txBody>
+          <a:bodyPr wrap="square" lIns="0" tIns="0" rIns="0" bIns="0" rtlCol="0" anchor="t"/>
+          <a:lstStyle/>
+          <a:p>
+            <a:pPr indent="0" marL="0">
+              <a:lnSpc>
+                <a:spcPts val="960"/>
               </a:lnSpc>
               <a:buNone/>
             </a:pPr>
@@ -15823,12 +15823,12 @@
           <a:p>
             <a:pPr indent="0" marL="0">
               <a:lnSpc>
-                <a:spcPts val="980"/>
-              </a:lnSpc>
-              <a:buNone/>
-            </a:pPr>
-            <a:r>
-              <a:rPr lang="en-US" sz="800" b="1" dirty="0">
+                <a:spcPts val="960"/>
+              </a:lnSpc>
+              <a:buNone/>
+            </a:pPr>
+            <a:r>
+              <a:rPr lang="en-US" sz="780" b="1" dirty="0">
                 <a:solidFill>
                   <a:srgbClr val="2B3038"/>
                 </a:solidFill>
@@ -15907,22 +15907,22 @@
         </p:nvSpPr>
         <p:spPr>
           <a:xfrm>
-            <a:off x="1554480" y="3867912"/>
-            <a:ext cx="1481328" cy="384048"/>
-          </a:xfrm>
-          <a:prstGeom prst="rect">
-            <a:avLst/>
-          </a:prstGeom>
-          <a:noFill/>
-          <a:ln/>
-        </p:spPr>
-        <p:txBody>
-          <a:bodyPr wrap="square" lIns="0" tIns="0" rIns="0" bIns="0" rtlCol="0" anchor="t"/>
-          <a:lstStyle/>
-          <a:p>
-            <a:pPr indent="0" marL="0">
-              <a:lnSpc>
-                <a:spcPts val="980"/>
+            <a:off x="1545336" y="3867912"/>
+            <a:ext cx="1508760" cy="384048"/>
+          </a:xfrm>
+          <a:prstGeom prst="rect">
+            <a:avLst/>
+          </a:prstGeom>
+          <a:noFill/>
+          <a:ln/>
+        </p:spPr>
+        <p:txBody>
+          <a:bodyPr wrap="square" lIns="0" tIns="0" rIns="0" bIns="0" rtlCol="0" anchor="t"/>
+          <a:lstStyle/>
+          <a:p>
+            <a:pPr indent="0" marL="0">
+              <a:lnSpc>
+                <a:spcPts val="960"/>
               </a:lnSpc>
               <a:buNone/>
             </a:pPr>
@@ -15950,12 +15950,12 @@
           <a:p>
             <a:pPr indent="0" marL="0">
               <a:lnSpc>
-                <a:spcPts val="980"/>
-              </a:lnSpc>
-              <a:buNone/>
-            </a:pPr>
-            <a:r>
-              <a:rPr lang="en-US" sz="800" b="1" dirty="0">
+                <a:spcPts val="960"/>
+              </a:lnSpc>
+              <a:buNone/>
+            </a:pPr>
+            <a:r>
+              <a:rPr lang="en-US" sz="780" b="1" dirty="0">
                 <a:solidFill>
                   <a:srgbClr val="2B3038"/>
                 </a:solidFill>
@@ -16034,22 +16034,22 @@
         </p:nvSpPr>
         <p:spPr>
           <a:xfrm>
-            <a:off x="3227832" y="2359152"/>
-            <a:ext cx="1481328" cy="384048"/>
-          </a:xfrm>
-          <a:prstGeom prst="rect">
-            <a:avLst/>
-          </a:prstGeom>
-          <a:noFill/>
-          <a:ln/>
-        </p:spPr>
-        <p:txBody>
-          <a:bodyPr wrap="square" lIns="0" tIns="0" rIns="0" bIns="0" rtlCol="0" anchor="t"/>
-          <a:lstStyle/>
-          <a:p>
-            <a:pPr indent="0" marL="0">
-              <a:lnSpc>
-                <a:spcPts val="980"/>
+            <a:off x="3218688" y="2359152"/>
+            <a:ext cx="1508760" cy="384048"/>
+          </a:xfrm>
+          <a:prstGeom prst="rect">
+            <a:avLst/>
+          </a:prstGeom>
+          <a:noFill/>
+          <a:ln/>
+        </p:spPr>
+        <p:txBody>
+          <a:bodyPr wrap="square" lIns="0" tIns="0" rIns="0" bIns="0" rtlCol="0" anchor="t"/>
+          <a:lstStyle/>
+          <a:p>
+            <a:pPr indent="0" marL="0">
+              <a:lnSpc>
+                <a:spcPts val="960"/>
               </a:lnSpc>
               <a:buNone/>
             </a:pPr>
@@ -16077,12 +16077,12 @@
           <a:p>
             <a:pPr indent="0" marL="0">
               <a:lnSpc>
-                <a:spcPts val="980"/>
-              </a:lnSpc>
-              <a:buNone/>
-            </a:pPr>
-            <a:r>
-              <a:rPr lang="en-US" sz="800" b="1" dirty="0">
+                <a:spcPts val="960"/>
+              </a:lnSpc>
+              <a:buNone/>
+            </a:pPr>
+            <a:r>
+              <a:rPr lang="en-US" sz="780" b="1" dirty="0">
                 <a:solidFill>
                   <a:srgbClr val="2B3038"/>
                 </a:solidFill>
@@ -16161,22 +16161,22 @@
         </p:nvSpPr>
         <p:spPr>
           <a:xfrm>
-            <a:off x="3227832" y="2862072"/>
-            <a:ext cx="1481328" cy="384048"/>
-          </a:xfrm>
-          <a:prstGeom prst="rect">
-            <a:avLst/>
-          </a:prstGeom>
-          <a:noFill/>
-          <a:ln/>
-        </p:spPr>
-        <p:txBody>
-          <a:bodyPr wrap="square" lIns="0" tIns="0" rIns="0" bIns="0" rtlCol="0" anchor="t"/>
-          <a:lstStyle/>
-          <a:p>
-            <a:pPr indent="0" marL="0">
-              <a:lnSpc>
-                <a:spcPts val="980"/>
+            <a:off x="3218688" y="2862072"/>
+            <a:ext cx="1508760" cy="384048"/>
+          </a:xfrm>
+          <a:prstGeom prst="rect">
+            <a:avLst/>
+          </a:prstGeom>
+          <a:noFill/>
+          <a:ln/>
+        </p:spPr>
+        <p:txBody>
+          <a:bodyPr wrap="square" lIns="0" tIns="0" rIns="0" bIns="0" rtlCol="0" anchor="t"/>
+          <a:lstStyle/>
+          <a:p>
+            <a:pPr indent="0" marL="0">
+              <a:lnSpc>
+                <a:spcPts val="960"/>
               </a:lnSpc>
               <a:buNone/>
             </a:pPr>
@@ -16204,12 +16204,12 @@
           <a:p>
             <a:pPr indent="0" marL="0">
               <a:lnSpc>
-                <a:spcPts val="980"/>
-              </a:lnSpc>
-              <a:buNone/>
-            </a:pPr>
-            <a:r>
-              <a:rPr lang="en-US" sz="800" b="1" dirty="0">
+                <a:spcPts val="960"/>
+              </a:lnSpc>
+              <a:buNone/>
+            </a:pPr>
+            <a:r>
+              <a:rPr lang="en-US" sz="780" b="1" dirty="0">
                 <a:solidFill>
                   <a:srgbClr val="2B3038"/>
                 </a:solidFill>
@@ -16288,22 +16288,22 @@
         </p:nvSpPr>
         <p:spPr>
           <a:xfrm>
-            <a:off x="3227832" y="3364992"/>
-            <a:ext cx="1481328" cy="384048"/>
-          </a:xfrm>
-          <a:prstGeom prst="rect">
-            <a:avLst/>
-          </a:prstGeom>
-          <a:noFill/>
-          <a:ln/>
-        </p:spPr>
-        <p:txBody>
-          <a:bodyPr wrap="square" lIns="0" tIns="0" rIns="0" bIns="0" rtlCol="0" anchor="t"/>
-          <a:lstStyle/>
-          <a:p>
-            <a:pPr indent="0" marL="0">
-              <a:lnSpc>
-                <a:spcPts val="980"/>
+            <a:off x="3218688" y="3364992"/>
+            <a:ext cx="1508760" cy="384048"/>
+          </a:xfrm>
+          <a:prstGeom prst="rect">
+            <a:avLst/>
+          </a:prstGeom>
+          <a:noFill/>
+          <a:ln/>
+        </p:spPr>
+        <p:txBody>
+          <a:bodyPr wrap="square" lIns="0" tIns="0" rIns="0" bIns="0" rtlCol="0" anchor="t"/>
+          <a:lstStyle/>
+          <a:p>
+            <a:pPr indent="0" marL="0">
+              <a:lnSpc>
+                <a:spcPts val="960"/>
               </a:lnSpc>
               <a:buNone/>
             </a:pPr>
@@ -16331,12 +16331,12 @@
           <a:p>
             <a:pPr indent="0" marL="0">
               <a:lnSpc>
-                <a:spcPts val="980"/>
-              </a:lnSpc>
-              <a:buNone/>
-            </a:pPr>
-            <a:r>
-              <a:rPr lang="en-US" sz="800" b="1" dirty="0">
+                <a:spcPts val="960"/>
+              </a:lnSpc>
+              <a:buNone/>
+            </a:pPr>
+            <a:r>
+              <a:rPr lang="en-US" sz="780" b="1" dirty="0">
                 <a:solidFill>
                   <a:srgbClr val="2B3038"/>
                 </a:solidFill>
@@ -16415,22 +16415,22 @@
         </p:nvSpPr>
         <p:spPr>
           <a:xfrm>
-            <a:off x="4901184" y="2359152"/>
-            <a:ext cx="1481328" cy="384048"/>
-          </a:xfrm>
-          <a:prstGeom prst="rect">
-            <a:avLst/>
-          </a:prstGeom>
-          <a:noFill/>
-          <a:ln/>
-        </p:spPr>
-        <p:txBody>
-          <a:bodyPr wrap="square" lIns="0" tIns="0" rIns="0" bIns="0" rtlCol="0" anchor="t"/>
-          <a:lstStyle/>
-          <a:p>
-            <a:pPr indent="0" marL="0">
-              <a:lnSpc>
-                <a:spcPts val="980"/>
+            <a:off x="4892040" y="2359152"/>
+            <a:ext cx="1508760" cy="384048"/>
+          </a:xfrm>
+          <a:prstGeom prst="rect">
+            <a:avLst/>
+          </a:prstGeom>
+          <a:noFill/>
+          <a:ln/>
+        </p:spPr>
+        <p:txBody>
+          <a:bodyPr wrap="square" lIns="0" tIns="0" rIns="0" bIns="0" rtlCol="0" anchor="t"/>
+          <a:lstStyle/>
+          <a:p>
+            <a:pPr indent="0" marL="0">
+              <a:lnSpc>
+                <a:spcPts val="960"/>
               </a:lnSpc>
               <a:buNone/>
             </a:pPr>
@@ -16458,12 +16458,12 @@
           <a:p>
             <a:pPr indent="0" marL="0">
               <a:lnSpc>
-                <a:spcPts val="980"/>
-              </a:lnSpc>
-              <a:buNone/>
-            </a:pPr>
-            <a:r>
-              <a:rPr lang="en-US" sz="800" b="1" dirty="0">
+                <a:spcPts val="960"/>
+              </a:lnSpc>
+              <a:buNone/>
+            </a:pPr>
+            <a:r>
+              <a:rPr lang="en-US" sz="780" b="1" dirty="0">
                 <a:solidFill>
                   <a:srgbClr val="2B3038"/>
                 </a:solidFill>
@@ -16542,22 +16542,22 @@
         </p:nvSpPr>
         <p:spPr>
           <a:xfrm>
-            <a:off x="4901184" y="2862072"/>
-            <a:ext cx="1481328" cy="384048"/>
-          </a:xfrm>
-          <a:prstGeom prst="rect">
-            <a:avLst/>
-          </a:prstGeom>
-          <a:noFill/>
-          <a:ln/>
-        </p:spPr>
-        <p:txBody>
-          <a:bodyPr wrap="square" lIns="0" tIns="0" rIns="0" bIns="0" rtlCol="0" anchor="t"/>
-          <a:lstStyle/>
-          <a:p>
-            <a:pPr indent="0" marL="0">
-              <a:lnSpc>
-                <a:spcPts val="980"/>
+            <a:off x="4892040" y="2862072"/>
+            <a:ext cx="1508760" cy="384048"/>
+          </a:xfrm>
+          <a:prstGeom prst="rect">
+            <a:avLst/>
+          </a:prstGeom>
+          <a:noFill/>
+          <a:ln/>
+        </p:spPr>
+        <p:txBody>
+          <a:bodyPr wrap="square" lIns="0" tIns="0" rIns="0" bIns="0" rtlCol="0" anchor="t"/>
+          <a:lstStyle/>
+          <a:p>
+            <a:pPr indent="0" marL="0">
+              <a:lnSpc>
+                <a:spcPts val="960"/>
               </a:lnSpc>
               <a:buNone/>
             </a:pPr>
@@ -16585,12 +16585,12 @@
           <a:p>
             <a:pPr indent="0" marL="0">
               <a:lnSpc>
-                <a:spcPts val="980"/>
-              </a:lnSpc>
-              <a:buNone/>
-            </a:pPr>
-            <a:r>
-              <a:rPr lang="en-US" sz="800" b="1" dirty="0">
+                <a:spcPts val="960"/>
+              </a:lnSpc>
+              <a:buNone/>
+            </a:pPr>
+            <a:r>
+              <a:rPr lang="en-US" sz="780" b="1" dirty="0">
                 <a:solidFill>
                   <a:srgbClr val="2B3038"/>
                 </a:solidFill>
@@ -16669,22 +16669,22 @@
         </p:nvSpPr>
         <p:spPr>
           <a:xfrm>
-            <a:off x="6574536" y="2359152"/>
-            <a:ext cx="1481328" cy="384048"/>
-          </a:xfrm>
-          <a:prstGeom prst="rect">
-            <a:avLst/>
-          </a:prstGeom>
-          <a:noFill/>
-          <a:ln/>
-        </p:spPr>
-        <p:txBody>
-          <a:bodyPr wrap="square" lIns="0" tIns="0" rIns="0" bIns="0" rtlCol="0" anchor="t"/>
-          <a:lstStyle/>
-          <a:p>
-            <a:pPr indent="0" marL="0">
-              <a:lnSpc>
-                <a:spcPts val="980"/>
+            <a:off x="6565392" y="2359152"/>
+            <a:ext cx="1508760" cy="384048"/>
+          </a:xfrm>
+          <a:prstGeom prst="rect">
+            <a:avLst/>
+          </a:prstGeom>
+          <a:noFill/>
+          <a:ln/>
+        </p:spPr>
+        <p:txBody>
+          <a:bodyPr wrap="square" lIns="0" tIns="0" rIns="0" bIns="0" rtlCol="0" anchor="t"/>
+          <a:lstStyle/>
+          <a:p>
+            <a:pPr indent="0" marL="0">
+              <a:lnSpc>
+                <a:spcPts val="960"/>
               </a:lnSpc>
               <a:buNone/>
             </a:pPr>
@@ -16712,12 +16712,12 @@
           <a:p>
             <a:pPr indent="0" marL="0">
               <a:lnSpc>
-                <a:spcPts val="980"/>
-              </a:lnSpc>
-              <a:buNone/>
-            </a:pPr>
-            <a:r>
-              <a:rPr lang="en-US" sz="800" b="1" dirty="0">
+                <a:spcPts val="960"/>
+              </a:lnSpc>
+              <a:buNone/>
+            </a:pPr>
+            <a:r>
+              <a:rPr lang="en-US" sz="780" b="1" dirty="0">
                 <a:solidFill>
                   <a:srgbClr val="2B3038"/>
                 </a:solidFill>
@@ -16796,22 +16796,22 @@
         </p:nvSpPr>
         <p:spPr>
           <a:xfrm>
-            <a:off x="6574536" y="2862072"/>
-            <a:ext cx="1481328" cy="384048"/>
-          </a:xfrm>
-          <a:prstGeom prst="rect">
-            <a:avLst/>
-          </a:prstGeom>
-          <a:noFill/>
-          <a:ln/>
-        </p:spPr>
-        <p:txBody>
-          <a:bodyPr wrap="square" lIns="0" tIns="0" rIns="0" bIns="0" rtlCol="0" anchor="t"/>
-          <a:lstStyle/>
-          <a:p>
-            <a:pPr indent="0" marL="0">
-              <a:lnSpc>
-                <a:spcPts val="980"/>
+            <a:off x="6565392" y="2862072"/>
+            <a:ext cx="1508760" cy="384048"/>
+          </a:xfrm>
+          <a:prstGeom prst="rect">
+            <a:avLst/>
+          </a:prstGeom>
+          <a:noFill/>
+          <a:ln/>
+        </p:spPr>
+        <p:txBody>
+          <a:bodyPr wrap="square" lIns="0" tIns="0" rIns="0" bIns="0" rtlCol="0" anchor="t"/>
+          <a:lstStyle/>
+          <a:p>
+            <a:pPr indent="0" marL="0">
+              <a:lnSpc>
+                <a:spcPts val="960"/>
               </a:lnSpc>
               <a:buNone/>
             </a:pPr>
@@ -16823,7 +16823,7 @@
                 <a:latin typeface="Calibri" pitchFamily="34" charset="0"/>
                 <a:ea typeface="Calibri" pitchFamily="34" charset="-122"/>
                 <a:cs typeface="Calibri" pitchFamily="34" charset="-120"/>
-                <a:hlinkClick r:id="rId22" invalidUrl="" action="" tgtFrame="" tooltip="See why it was graded and classified" history="1" highlightClick="0" endSnd="0">
+                <a:hlinkClick r:id="rId22" invalidUrl="" action="" tgtFrame="" tooltip="Why it was graded, and classified" history="1" highlightClick="0" endSnd="0">
                   <a:extLst>
                     <a:ext uri="{A12FA001-AC4F-418D-AE19-62706E023703}">
                       <ahyp:hlinkClr xmlns:ahyp="http://schemas.microsoft.com/office/drawing/2018/hyperlinkcolor" val="tx"/>
@@ -16839,19 +16839,19 @@
           <a:p>
             <a:pPr indent="0" marL="0">
               <a:lnSpc>
-                <a:spcPts val="980"/>
-              </a:lnSpc>
-              <a:buNone/>
-            </a:pPr>
-            <a:r>
-              <a:rPr lang="en-US" sz="800" b="1" dirty="0">
+                <a:spcPts val="960"/>
+              </a:lnSpc>
+              <a:buNone/>
+            </a:pPr>
+            <a:r>
+              <a:rPr lang="en-US" sz="780" b="1" dirty="0">
                 <a:solidFill>
                   <a:srgbClr val="2B3038"/>
                 </a:solidFill>
                 <a:latin typeface="Calibri" pitchFamily="34" charset="0"/>
                 <a:ea typeface="Calibri" pitchFamily="34" charset="-122"/>
                 <a:cs typeface="Calibri" pitchFamily="34" charset="-120"/>
-                <a:hlinkClick r:id="rId23" invalidUrl="" action="" tgtFrame="" tooltip="See why it was graded and classified" history="1" highlightClick="0" endSnd="0">
+                <a:hlinkClick r:id="rId23" invalidUrl="" action="" tgtFrame="" tooltip="Why it was graded, and classified" history="1" highlightClick="0" endSnd="0">
                   <a:extLst>
                     <a:ext uri="{A12FA001-AC4F-418D-AE19-62706E023703}">
                       <ahyp:hlinkClr xmlns:ahyp="http://schemas.microsoft.com/office/drawing/2018/hyperlinkcolor" val="tx"/>
@@ -16859,7 +16859,7 @@
                   </a:extLst>
                 </a:hlinkClick>
               </a:rPr>
-              <a:t>See why it was graded and classified</a:t>
+              <a:t>Why it was graded, and classified</a:t>
             </a:r>
             <a:endParaRPr lang="en-US" sz="660" dirty="0"/>
           </a:p>
@@ -16923,22 +16923,22 @@
         </p:nvSpPr>
         <p:spPr>
           <a:xfrm>
-            <a:off x="6574536" y="3364992"/>
-            <a:ext cx="1481328" cy="384048"/>
-          </a:xfrm>
-          <a:prstGeom prst="rect">
-            <a:avLst/>
-          </a:prstGeom>
-          <a:noFill/>
-          <a:ln/>
-        </p:spPr>
-        <p:txBody>
-          <a:bodyPr wrap="square" lIns="0" tIns="0" rIns="0" bIns="0" rtlCol="0" anchor="t"/>
-          <a:lstStyle/>
-          <a:p>
-            <a:pPr indent="0" marL="0">
-              <a:lnSpc>
-                <a:spcPts val="980"/>
+            <a:off x="6565392" y="3364992"/>
+            <a:ext cx="1508760" cy="384048"/>
+          </a:xfrm>
+          <a:prstGeom prst="rect">
+            <a:avLst/>
+          </a:prstGeom>
+          <a:noFill/>
+          <a:ln/>
+        </p:spPr>
+        <p:txBody>
+          <a:bodyPr wrap="square" lIns="0" tIns="0" rIns="0" bIns="0" rtlCol="0" anchor="t"/>
+          <a:lstStyle/>
+          <a:p>
+            <a:pPr indent="0" marL="0">
+              <a:lnSpc>
+                <a:spcPts val="960"/>
               </a:lnSpc>
               <a:buNone/>
             </a:pPr>
@@ -16966,12 +16966,12 @@
           <a:p>
             <a:pPr indent="0" marL="0">
               <a:lnSpc>
-                <a:spcPts val="980"/>
-              </a:lnSpc>
-              <a:buNone/>
-            </a:pPr>
-            <a:r>
-              <a:rPr lang="en-US" sz="800" b="1" dirty="0">
+                <a:spcPts val="960"/>
+              </a:lnSpc>
+              <a:buNone/>
+            </a:pPr>
+            <a:r>
+              <a:rPr lang="en-US" sz="780" b="1" dirty="0">
                 <a:solidFill>
                   <a:srgbClr val="2B3038"/>
                 </a:solidFill>
@@ -17050,22 +17050,22 @@
         </p:nvSpPr>
         <p:spPr>
           <a:xfrm>
-            <a:off x="6574536" y="3867912"/>
-            <a:ext cx="1481328" cy="384048"/>
-          </a:xfrm>
-          <a:prstGeom prst="rect">
-            <a:avLst/>
-          </a:prstGeom>
-          <a:noFill/>
-          <a:ln/>
-        </p:spPr>
-        <p:txBody>
-          <a:bodyPr wrap="square" lIns="0" tIns="0" rIns="0" bIns="0" rtlCol="0" anchor="t"/>
-          <a:lstStyle/>
-          <a:p>
-            <a:pPr indent="0" marL="0">
-              <a:lnSpc>
-                <a:spcPts val="980"/>
+            <a:off x="6565392" y="3867912"/>
+            <a:ext cx="1508760" cy="384048"/>
+          </a:xfrm>
+          <a:prstGeom prst="rect">
+            <a:avLst/>
+          </a:prstGeom>
+          <a:noFill/>
+          <a:ln/>
+        </p:spPr>
+        <p:txBody>
+          <a:bodyPr wrap="square" lIns="0" tIns="0" rIns="0" bIns="0" rtlCol="0" anchor="t"/>
+          <a:lstStyle/>
+          <a:p>
+            <a:pPr indent="0" marL="0">
+              <a:lnSpc>
+                <a:spcPts val="960"/>
               </a:lnSpc>
               <a:buNone/>
             </a:pPr>
@@ -17093,12 +17093,12 @@
           <a:p>
             <a:pPr indent="0" marL="0">
               <a:lnSpc>
-                <a:spcPts val="980"/>
-              </a:lnSpc>
-              <a:buNone/>
-            </a:pPr>
-            <a:r>
-              <a:rPr lang="en-US" sz="800" b="1" dirty="0">
+                <a:spcPts val="960"/>
+              </a:lnSpc>
+              <a:buNone/>
+            </a:pPr>
+            <a:r>
+              <a:rPr lang="en-US" sz="780" b="1" dirty="0">
                 <a:solidFill>
                   <a:srgbClr val="2B3038"/>
                 </a:solidFill>
@@ -17177,22 +17177,22 @@
         </p:nvSpPr>
         <p:spPr>
           <a:xfrm>
-            <a:off x="8247888" y="2359152"/>
-            <a:ext cx="1481328" cy="384048"/>
-          </a:xfrm>
-          <a:prstGeom prst="rect">
-            <a:avLst/>
-          </a:prstGeom>
-          <a:noFill/>
-          <a:ln/>
-        </p:spPr>
-        <p:txBody>
-          <a:bodyPr wrap="square" lIns="0" tIns="0" rIns="0" bIns="0" rtlCol="0" anchor="t"/>
-          <a:lstStyle/>
-          <a:p>
-            <a:pPr indent="0" marL="0">
-              <a:lnSpc>
-                <a:spcPts val="980"/>
+            <a:off x="8238744" y="2359152"/>
+            <a:ext cx="1508760" cy="384048"/>
+          </a:xfrm>
+          <a:prstGeom prst="rect">
+            <a:avLst/>
+          </a:prstGeom>
+          <a:noFill/>
+          <a:ln/>
+        </p:spPr>
+        <p:txBody>
+          <a:bodyPr wrap="square" lIns="0" tIns="0" rIns="0" bIns="0" rtlCol="0" anchor="t"/>
+          <a:lstStyle/>
+          <a:p>
+            <a:pPr indent="0" marL="0">
+              <a:lnSpc>
+                <a:spcPts val="960"/>
               </a:lnSpc>
               <a:buNone/>
             </a:pPr>
@@ -17220,12 +17220,12 @@
           <a:p>
             <a:pPr indent="0" marL="0">
               <a:lnSpc>
-                <a:spcPts val="980"/>
-              </a:lnSpc>
-              <a:buNone/>
-            </a:pPr>
-            <a:r>
-              <a:rPr lang="en-US" sz="800" b="1" dirty="0">
+                <a:spcPts val="960"/>
+              </a:lnSpc>
+              <a:buNone/>
+            </a:pPr>
+            <a:r>
+              <a:rPr lang="en-US" sz="780" b="1" dirty="0">
                 <a:solidFill>
                   <a:srgbClr val="2B3038"/>
                 </a:solidFill>
@@ -17304,22 +17304,22 @@
         </p:nvSpPr>
         <p:spPr>
           <a:xfrm>
-            <a:off x="8247888" y="2862072"/>
-            <a:ext cx="1481328" cy="384048"/>
-          </a:xfrm>
-          <a:prstGeom prst="rect">
-            <a:avLst/>
-          </a:prstGeom>
-          <a:noFill/>
-          <a:ln/>
-        </p:spPr>
-        <p:txBody>
-          <a:bodyPr wrap="square" lIns="0" tIns="0" rIns="0" bIns="0" rtlCol="0" anchor="t"/>
-          <a:lstStyle/>
-          <a:p>
-            <a:pPr indent="0" marL="0">
-              <a:lnSpc>
-                <a:spcPts val="980"/>
+            <a:off x="8238744" y="2862072"/>
+            <a:ext cx="1508760" cy="384048"/>
+          </a:xfrm>
+          <a:prstGeom prst="rect">
+            <a:avLst/>
+          </a:prstGeom>
+          <a:noFill/>
+          <a:ln/>
+        </p:spPr>
+        <p:txBody>
+          <a:bodyPr wrap="square" lIns="0" tIns="0" rIns="0" bIns="0" rtlCol="0" anchor="t"/>
+          <a:lstStyle/>
+          <a:p>
+            <a:pPr indent="0" marL="0">
+              <a:lnSpc>
+                <a:spcPts val="960"/>
               </a:lnSpc>
               <a:buNone/>
             </a:pPr>
@@ -17347,12 +17347,12 @@
           <a:p>
             <a:pPr indent="0" marL="0">
               <a:lnSpc>
-                <a:spcPts val="980"/>
-              </a:lnSpc>
-              <a:buNone/>
-            </a:pPr>
-            <a:r>
-              <a:rPr lang="en-US" sz="800" b="1" dirty="0">
+                <a:spcPts val="960"/>
+              </a:lnSpc>
+              <a:buNone/>
+            </a:pPr>
+            <a:r>
+              <a:rPr lang="en-US" sz="780" b="1" dirty="0">
                 <a:solidFill>
                   <a:srgbClr val="2B3038"/>
                 </a:solidFill>
@@ -17431,22 +17431,22 @@
         </p:nvSpPr>
         <p:spPr>
           <a:xfrm>
-            <a:off x="8247888" y="3364992"/>
-            <a:ext cx="1481328" cy="384048"/>
-          </a:xfrm>
-          <a:prstGeom prst="rect">
-            <a:avLst/>
-          </a:prstGeom>
-          <a:noFill/>
-          <a:ln/>
-        </p:spPr>
-        <p:txBody>
-          <a:bodyPr wrap="square" lIns="0" tIns="0" rIns="0" bIns="0" rtlCol="0" anchor="t"/>
-          <a:lstStyle/>
-          <a:p>
-            <a:pPr indent="0" marL="0">
-              <a:lnSpc>
-                <a:spcPts val="980"/>
+            <a:off x="8238744" y="3364992"/>
+            <a:ext cx="1508760" cy="384048"/>
+          </a:xfrm>
+          <a:prstGeom prst="rect">
+            <a:avLst/>
+          </a:prstGeom>
+          <a:noFill/>
+          <a:ln/>
+        </p:spPr>
+        <p:txBody>
+          <a:bodyPr wrap="square" lIns="0" tIns="0" rIns="0" bIns="0" rtlCol="0" anchor="t"/>
+          <a:lstStyle/>
+          <a:p>
+            <a:pPr indent="0" marL="0">
+              <a:lnSpc>
+                <a:spcPts val="960"/>
               </a:lnSpc>
               <a:buNone/>
             </a:pPr>
@@ -17474,12 +17474,12 @@
           <a:p>
             <a:pPr indent="0" marL="0">
               <a:lnSpc>
-                <a:spcPts val="980"/>
-              </a:lnSpc>
-              <a:buNone/>
-            </a:pPr>
-            <a:r>
-              <a:rPr lang="en-US" sz="800" b="1" dirty="0">
+                <a:spcPts val="960"/>
+              </a:lnSpc>
+              <a:buNone/>
+            </a:pPr>
+            <a:r>
+              <a:rPr lang="en-US" sz="780" b="1" dirty="0">
                 <a:solidFill>
                   <a:srgbClr val="2B3038"/>
                 </a:solidFill>
@@ -17558,22 +17558,22 @@
         </p:nvSpPr>
         <p:spPr>
           <a:xfrm>
-            <a:off x="8247888" y="3867912"/>
-            <a:ext cx="1481328" cy="384048"/>
-          </a:xfrm>
-          <a:prstGeom prst="rect">
-            <a:avLst/>
-          </a:prstGeom>
-          <a:noFill/>
-          <a:ln/>
-        </p:spPr>
-        <p:txBody>
-          <a:bodyPr wrap="square" lIns="0" tIns="0" rIns="0" bIns="0" rtlCol="0" anchor="t"/>
-          <a:lstStyle/>
-          <a:p>
-            <a:pPr indent="0" marL="0">
-              <a:lnSpc>
-                <a:spcPts val="980"/>
+            <a:off x="8238744" y="3867912"/>
+            <a:ext cx="1508760" cy="384048"/>
+          </a:xfrm>
+          <a:prstGeom prst="rect">
+            <a:avLst/>
+          </a:prstGeom>
+          <a:noFill/>
+          <a:ln/>
+        </p:spPr>
+        <p:txBody>
+          <a:bodyPr wrap="square" lIns="0" tIns="0" rIns="0" bIns="0" rtlCol="0" anchor="t"/>
+          <a:lstStyle/>
+          <a:p>
+            <a:pPr indent="0" marL="0">
+              <a:lnSpc>
+                <a:spcPts val="960"/>
               </a:lnSpc>
               <a:buNone/>
             </a:pPr>
@@ -17601,12 +17601,12 @@
           <a:p>
             <a:pPr indent="0" marL="0">
               <a:lnSpc>
-                <a:spcPts val="980"/>
-              </a:lnSpc>
-              <a:buNone/>
-            </a:pPr>
-            <a:r>
-              <a:rPr lang="en-US" sz="800" b="1" dirty="0">
+                <a:spcPts val="960"/>
+              </a:lnSpc>
+              <a:buNone/>
+            </a:pPr>
+            <a:r>
+              <a:rPr lang="en-US" sz="780" b="1" dirty="0">
                 <a:solidFill>
                   <a:srgbClr val="2B3038"/>
                 </a:solidFill>
@@ -17685,22 +17685,22 @@
         </p:nvSpPr>
         <p:spPr>
           <a:xfrm>
-            <a:off x="9921240" y="2359152"/>
-            <a:ext cx="1481328" cy="384048"/>
-          </a:xfrm>
-          <a:prstGeom prst="rect">
-            <a:avLst/>
-          </a:prstGeom>
-          <a:noFill/>
-          <a:ln/>
-        </p:spPr>
-        <p:txBody>
-          <a:bodyPr wrap="square" lIns="0" tIns="0" rIns="0" bIns="0" rtlCol="0" anchor="t"/>
-          <a:lstStyle/>
-          <a:p>
-            <a:pPr indent="0" marL="0">
-              <a:lnSpc>
-                <a:spcPts val="980"/>
+            <a:off x="9912096" y="2359152"/>
+            <a:ext cx="1508760" cy="384048"/>
+          </a:xfrm>
+          <a:prstGeom prst="rect">
+            <a:avLst/>
+          </a:prstGeom>
+          <a:noFill/>
+          <a:ln/>
+        </p:spPr>
+        <p:txBody>
+          <a:bodyPr wrap="square" lIns="0" tIns="0" rIns="0" bIns="0" rtlCol="0" anchor="t"/>
+          <a:lstStyle/>
+          <a:p>
+            <a:pPr indent="0" marL="0">
+              <a:lnSpc>
+                <a:spcPts val="960"/>
               </a:lnSpc>
               <a:buNone/>
             </a:pPr>
@@ -17728,12 +17728,12 @@
           <a:p>
             <a:pPr indent="0" marL="0">
               <a:lnSpc>
-                <a:spcPts val="980"/>
-              </a:lnSpc>
-              <a:buNone/>
-            </a:pPr>
-            <a:r>
-              <a:rPr lang="en-US" sz="800" b="1" dirty="0">
+                <a:spcPts val="960"/>
+              </a:lnSpc>
+              <a:buNone/>
+            </a:pPr>
+            <a:r>
+              <a:rPr lang="en-US" sz="780" b="1" dirty="0">
                 <a:solidFill>
                   <a:srgbClr val="2B3038"/>
                 </a:solidFill>
@@ -18133,22 +18133,22 @@
         </p:nvSpPr>
         <p:spPr>
           <a:xfrm>
-            <a:off x="9921240" y="4517136"/>
-            <a:ext cx="1481328" cy="384048"/>
-          </a:xfrm>
-          <a:prstGeom prst="rect">
-            <a:avLst/>
-          </a:prstGeom>
-          <a:noFill/>
-          <a:ln/>
-        </p:spPr>
-        <p:txBody>
-          <a:bodyPr wrap="square" lIns="0" tIns="0" rIns="0" bIns="0" rtlCol="0" anchor="t"/>
-          <a:lstStyle/>
-          <a:p>
-            <a:pPr indent="0" marL="0">
-              <a:lnSpc>
-                <a:spcPts val="980"/>
+            <a:off x="9912096" y="4517136"/>
+            <a:ext cx="1508760" cy="384048"/>
+          </a:xfrm>
+          <a:prstGeom prst="rect">
+            <a:avLst/>
+          </a:prstGeom>
+          <a:noFill/>
+          <a:ln/>
+        </p:spPr>
+        <p:txBody>
+          <a:bodyPr wrap="square" lIns="0" tIns="0" rIns="0" bIns="0" rtlCol="0" anchor="t"/>
+          <a:lstStyle/>
+          <a:p>
+            <a:pPr indent="0" marL="0">
+              <a:lnSpc>
+                <a:spcPts val="960"/>
               </a:lnSpc>
               <a:buNone/>
             </a:pPr>
@@ -18176,12 +18176,12 @@
           <a:p>
             <a:pPr indent="0" marL="0">
               <a:lnSpc>
-                <a:spcPts val="980"/>
-              </a:lnSpc>
-              <a:buNone/>
-            </a:pPr>
-            <a:r>
-              <a:rPr lang="en-US" sz="800" b="1" dirty="0">
+                <a:spcPts val="960"/>
+              </a:lnSpc>
+              <a:buNone/>
+            </a:pPr>
+            <a:r>
+              <a:rPr lang="en-US" sz="780" b="1" dirty="0">
                 <a:solidFill>
                   <a:srgbClr val="2B3038"/>
                 </a:solidFill>
@@ -18361,22 +18361,22 @@
         </p:nvSpPr>
         <p:spPr>
           <a:xfrm>
-            <a:off x="1554480" y="5138928"/>
-            <a:ext cx="1481328" cy="384048"/>
-          </a:xfrm>
-          <a:prstGeom prst="rect">
-            <a:avLst/>
-          </a:prstGeom>
-          <a:noFill/>
-          <a:ln/>
-        </p:spPr>
-        <p:txBody>
-          <a:bodyPr wrap="square" lIns="0" tIns="0" rIns="0" bIns="0" rtlCol="0" anchor="t"/>
-          <a:lstStyle/>
-          <a:p>
-            <a:pPr indent="0" marL="0">
-              <a:lnSpc>
-                <a:spcPts val="980"/>
+            <a:off x="1545336" y="5138928"/>
+            <a:ext cx="1508760" cy="384048"/>
+          </a:xfrm>
+          <a:prstGeom prst="rect">
+            <a:avLst/>
+          </a:prstGeom>
+          <a:noFill/>
+          <a:ln/>
+        </p:spPr>
+        <p:txBody>
+          <a:bodyPr wrap="square" lIns="0" tIns="0" rIns="0" bIns="0" rtlCol="0" anchor="t"/>
+          <a:lstStyle/>
+          <a:p>
+            <a:pPr indent="0" marL="0">
+              <a:lnSpc>
+                <a:spcPts val="960"/>
               </a:lnSpc>
               <a:buNone/>
             </a:pPr>
@@ -18404,12 +18404,12 @@
           <a:p>
             <a:pPr indent="0" marL="0">
               <a:lnSpc>
-                <a:spcPts val="980"/>
-              </a:lnSpc>
-              <a:buNone/>
-            </a:pPr>
-            <a:r>
-              <a:rPr lang="en-US" sz="800" b="1" dirty="0">
+                <a:spcPts val="960"/>
+              </a:lnSpc>
+              <a:buNone/>
+            </a:pPr>
+            <a:r>
+              <a:rPr lang="en-US" sz="780" b="1" dirty="0">
                 <a:solidFill>
                   <a:srgbClr val="2B3038"/>
                 </a:solidFill>
@@ -18488,22 +18488,22 @@
         </p:nvSpPr>
         <p:spPr>
           <a:xfrm>
-            <a:off x="3227832" y="5138928"/>
-            <a:ext cx="1481328" cy="384048"/>
-          </a:xfrm>
-          <a:prstGeom prst="rect">
-            <a:avLst/>
-          </a:prstGeom>
-          <a:noFill/>
-          <a:ln/>
-        </p:spPr>
-        <p:txBody>
-          <a:bodyPr wrap="square" lIns="0" tIns="0" rIns="0" bIns="0" rtlCol="0" anchor="t"/>
-          <a:lstStyle/>
-          <a:p>
-            <a:pPr indent="0" marL="0">
-              <a:lnSpc>
-                <a:spcPts val="980"/>
+            <a:off x="3218688" y="5138928"/>
+            <a:ext cx="1508760" cy="384048"/>
+          </a:xfrm>
+          <a:prstGeom prst="rect">
+            <a:avLst/>
+          </a:prstGeom>
+          <a:noFill/>
+          <a:ln/>
+        </p:spPr>
+        <p:txBody>
+          <a:bodyPr wrap="square" lIns="0" tIns="0" rIns="0" bIns="0" rtlCol="0" anchor="t"/>
+          <a:lstStyle/>
+          <a:p>
+            <a:pPr indent="0" marL="0">
+              <a:lnSpc>
+                <a:spcPts val="960"/>
               </a:lnSpc>
               <a:buNone/>
             </a:pPr>
@@ -18515,7 +18515,7 @@
                 <a:latin typeface="Calibri" pitchFamily="34" charset="0"/>
                 <a:ea typeface="Calibri" pitchFamily="34" charset="-122"/>
                 <a:cs typeface="Calibri" pitchFamily="34" charset="-120"/>
-                <a:hlinkClick r:id="rId42" invalidUrl="" action="" tgtFrame="" tooltip="Re-engagement on sustained non-use" history="1" highlightClick="0" endSnd="0">
+                <a:hlinkClick r:id="rId42" invalidUrl="" action="" tgtFrame="" tooltip="Re-engagement on non-use" history="1" highlightClick="0" endSnd="0">
                   <a:extLst>
                     <a:ext uri="{A12FA001-AC4F-418D-AE19-62706E023703}">
                       <ahyp:hlinkClr xmlns:ahyp="http://schemas.microsoft.com/office/drawing/2018/hyperlinkcolor" val="tx"/>
@@ -18531,19 +18531,19 @@
           <a:p>
             <a:pPr indent="0" marL="0">
               <a:lnSpc>
-                <a:spcPts val="980"/>
-              </a:lnSpc>
-              <a:buNone/>
-            </a:pPr>
-            <a:r>
-              <a:rPr lang="en-US" sz="800" b="1" dirty="0">
+                <a:spcPts val="960"/>
+              </a:lnSpc>
+              <a:buNone/>
+            </a:pPr>
+            <a:r>
+              <a:rPr lang="en-US" sz="780" b="1" dirty="0">
                 <a:solidFill>
                   <a:srgbClr val="2B3038"/>
                 </a:solidFill>
                 <a:latin typeface="Calibri" pitchFamily="34" charset="0"/>
                 <a:ea typeface="Calibri" pitchFamily="34" charset="-122"/>
                 <a:cs typeface="Calibri" pitchFamily="34" charset="-120"/>
-                <a:hlinkClick r:id="rId43" invalidUrl="" action="" tgtFrame="" tooltip="Re-engagement on sustained non-use" history="1" highlightClick="0" endSnd="0">
+                <a:hlinkClick r:id="rId43" invalidUrl="" action="" tgtFrame="" tooltip="Re-engagement on non-use" history="1" highlightClick="0" endSnd="0">
                   <a:extLst>
                     <a:ext uri="{A12FA001-AC4F-418D-AE19-62706E023703}">
                       <ahyp:hlinkClr xmlns:ahyp="http://schemas.microsoft.com/office/drawing/2018/hyperlinkcolor" val="tx"/>
@@ -18551,7 +18551,7 @@
                   </a:extLst>
                 </a:hlinkClick>
               </a:rPr>
-              <a:t>Re-engagement on sustained non-use</a:t>
+              <a:t>Re-engagement on non-use</a:t>
             </a:r>
             <a:endParaRPr lang="en-US" sz="660" dirty="0"/>
           </a:p>
@@ -18615,22 +18615,22 @@
         </p:nvSpPr>
         <p:spPr>
           <a:xfrm>
-            <a:off x="4901184" y="5138928"/>
-            <a:ext cx="1481328" cy="384048"/>
-          </a:xfrm>
-          <a:prstGeom prst="rect">
-            <a:avLst/>
-          </a:prstGeom>
-          <a:noFill/>
-          <a:ln/>
-        </p:spPr>
-        <p:txBody>
-          <a:bodyPr wrap="square" lIns="0" tIns="0" rIns="0" bIns="0" rtlCol="0" anchor="t"/>
-          <a:lstStyle/>
-          <a:p>
-            <a:pPr indent="0" marL="0">
-              <a:lnSpc>
-                <a:spcPts val="980"/>
+            <a:off x="4892040" y="5138928"/>
+            <a:ext cx="1508760" cy="384048"/>
+          </a:xfrm>
+          <a:prstGeom prst="rect">
+            <a:avLst/>
+          </a:prstGeom>
+          <a:noFill/>
+          <a:ln/>
+        </p:spPr>
+        <p:txBody>
+          <a:bodyPr wrap="square" lIns="0" tIns="0" rIns="0" bIns="0" rtlCol="0" anchor="t"/>
+          <a:lstStyle/>
+          <a:p>
+            <a:pPr indent="0" marL="0">
+              <a:lnSpc>
+                <a:spcPts val="960"/>
               </a:lnSpc>
               <a:buNone/>
             </a:pPr>
@@ -18658,12 +18658,12 @@
           <a:p>
             <a:pPr indent="0" marL="0">
               <a:lnSpc>
-                <a:spcPts val="980"/>
-              </a:lnSpc>
-              <a:buNone/>
-            </a:pPr>
-            <a:r>
-              <a:rPr lang="en-US" sz="800" b="1" dirty="0">
+                <a:spcPts val="960"/>
+              </a:lnSpc>
+              <a:buNone/>
+            </a:pPr>
+            <a:r>
+              <a:rPr lang="en-US" sz="780" b="1" dirty="0">
                 <a:solidFill>
                   <a:srgbClr val="2B3038"/>
                 </a:solidFill>
@@ -18781,22 +18781,22 @@
         </p:nvSpPr>
         <p:spPr>
           <a:xfrm>
-            <a:off x="8247888" y="5138928"/>
-            <a:ext cx="1481328" cy="384048"/>
-          </a:xfrm>
-          <a:prstGeom prst="rect">
-            <a:avLst/>
-          </a:prstGeom>
-          <a:noFill/>
-          <a:ln/>
-        </p:spPr>
-        <p:txBody>
-          <a:bodyPr wrap="square" lIns="0" tIns="0" rIns="0" bIns="0" rtlCol="0" anchor="t"/>
-          <a:lstStyle/>
-          <a:p>
-            <a:pPr indent="0" marL="0">
-              <a:lnSpc>
-                <a:spcPts val="980"/>
+            <a:off x="8238744" y="5138928"/>
+            <a:ext cx="1508760" cy="384048"/>
+          </a:xfrm>
+          <a:prstGeom prst="rect">
+            <a:avLst/>
+          </a:prstGeom>
+          <a:noFill/>
+          <a:ln/>
+        </p:spPr>
+        <p:txBody>
+          <a:bodyPr wrap="square" lIns="0" tIns="0" rIns="0" bIns="0" rtlCol="0" anchor="t"/>
+          <a:lstStyle/>
+          <a:p>
+            <a:pPr indent="0" marL="0">
+              <a:lnSpc>
+                <a:spcPts val="960"/>
               </a:lnSpc>
               <a:buNone/>
             </a:pPr>
@@ -18824,12 +18824,12 @@
           <a:p>
             <a:pPr indent="0" marL="0">
               <a:lnSpc>
-                <a:spcPts val="980"/>
-              </a:lnSpc>
-              <a:buNone/>
-            </a:pPr>
-            <a:r>
-              <a:rPr lang="en-US" sz="800" b="1" dirty="0">
+                <a:spcPts val="960"/>
+              </a:lnSpc>
+              <a:buNone/>
+            </a:pPr>
+            <a:r>
+              <a:rPr lang="en-US" sz="780" b="1" dirty="0">
                 <a:solidFill>
                   <a:srgbClr val="2B3038"/>
                 </a:solidFill>
@@ -18908,22 +18908,22 @@
         </p:nvSpPr>
         <p:spPr>
           <a:xfrm>
-            <a:off x="8247888" y="5641848"/>
-            <a:ext cx="1481328" cy="384048"/>
-          </a:xfrm>
-          <a:prstGeom prst="rect">
-            <a:avLst/>
-          </a:prstGeom>
-          <a:noFill/>
-          <a:ln/>
-        </p:spPr>
-        <p:txBody>
-          <a:bodyPr wrap="square" lIns="0" tIns="0" rIns="0" bIns="0" rtlCol="0" anchor="t"/>
-          <a:lstStyle/>
-          <a:p>
-            <a:pPr indent="0" marL="0">
-              <a:lnSpc>
-                <a:spcPts val="980"/>
+            <a:off x="8238744" y="5641848"/>
+            <a:ext cx="1508760" cy="384048"/>
+          </a:xfrm>
+          <a:prstGeom prst="rect">
+            <a:avLst/>
+          </a:prstGeom>
+          <a:noFill/>
+          <a:ln/>
+        </p:spPr>
+        <p:txBody>
+          <a:bodyPr wrap="square" lIns="0" tIns="0" rIns="0" bIns="0" rtlCol="0" anchor="t"/>
+          <a:lstStyle/>
+          <a:p>
+            <a:pPr indent="0" marL="0">
+              <a:lnSpc>
+                <a:spcPts val="960"/>
               </a:lnSpc>
               <a:buNone/>
             </a:pPr>
@@ -18951,12 +18951,12 @@
           <a:p>
             <a:pPr indent="0" marL="0">
               <a:lnSpc>
-                <a:spcPts val="980"/>
-              </a:lnSpc>
-              <a:buNone/>
-            </a:pPr>
-            <a:r>
-              <a:rPr lang="en-US" sz="800" b="1" dirty="0">
+                <a:spcPts val="960"/>
+              </a:lnSpc>
+              <a:buNone/>
+            </a:pPr>
+            <a:r>
+              <a:rPr lang="en-US" sz="780" b="1" dirty="0">
                 <a:solidFill>
                   <a:srgbClr val="2B3038"/>
                 </a:solidFill>

</xml_diff>